<commit_message>
Refine department training presentation
</commit_message>
<xml_diff>
--- a/presentation/06_Training_Presentation.pptx
+++ b/presentation/06_Training_Presentation.pptx
@@ -2,22 +2,22 @@
 <file path=ppt/presentation.xml><?xml version="1.0" encoding="utf-8"?>
 <p:presentation xmlns:p="http://schemas.openxmlformats.org/presentationml/2006/main">
   <p:sldMasterIdLst>
-    <p:sldMasterId xmlns:r="http://schemas.openxmlformats.org/officeDocument/2006/relationships" id="2147483648" r:id="R16ff23ff27084e06"/>
+    <p:sldMasterId xmlns:r="http://schemas.openxmlformats.org/officeDocument/2006/relationships" id="2147483648" r:id="R32d07d1937244c8d"/>
   </p:sldMasterIdLst>
   <p:notesMasterIdLst>
-    <p:notesMasterId xmlns:r="http://schemas.openxmlformats.org/officeDocument/2006/relationships" r:id="Rab817f05da5d4223"/>
+    <p:notesMasterId xmlns:r="http://schemas.openxmlformats.org/officeDocument/2006/relationships" r:id="Rafa9f2f7fa314e32"/>
   </p:notesMasterIdLst>
   <p:sldIdLst>
-    <p:sldId xmlns:r="http://schemas.openxmlformats.org/officeDocument/2006/relationships" id="256" r:id="Rb90cba4a0e184886"/>
-    <p:sldId xmlns:r="http://schemas.openxmlformats.org/officeDocument/2006/relationships" id="257" r:id="R7abc472ca4364483"/>
-    <p:sldId xmlns:r="http://schemas.openxmlformats.org/officeDocument/2006/relationships" id="258" r:id="Rc5772633c1154362"/>
-    <p:sldId xmlns:r="http://schemas.openxmlformats.org/officeDocument/2006/relationships" id="259" r:id="Rde034d5145534754"/>
-    <p:sldId xmlns:r="http://schemas.openxmlformats.org/officeDocument/2006/relationships" id="260" r:id="R1970c5052d1841f0"/>
-    <p:sldId xmlns:r="http://schemas.openxmlformats.org/officeDocument/2006/relationships" id="261" r:id="Rff0ac6e76fc64ebb"/>
-    <p:sldId xmlns:r="http://schemas.openxmlformats.org/officeDocument/2006/relationships" id="262" r:id="Rb11b664cd32742ff"/>
-    <p:sldId xmlns:r="http://schemas.openxmlformats.org/officeDocument/2006/relationships" id="263" r:id="Re8ea789fc8a14d83"/>
-    <p:sldId xmlns:r="http://schemas.openxmlformats.org/officeDocument/2006/relationships" id="264" r:id="R736959e2a89b4c15"/>
-    <p:sldId xmlns:r="http://schemas.openxmlformats.org/officeDocument/2006/relationships" id="265" r:id="R6d9d8ddffadd4d66"/>
+    <p:sldId xmlns:r="http://schemas.openxmlformats.org/officeDocument/2006/relationships" id="256" r:id="Rbe72169caeeb4e5f"/>
+    <p:sldId xmlns:r="http://schemas.openxmlformats.org/officeDocument/2006/relationships" id="257" r:id="R471ab88cfc3b4fe8"/>
+    <p:sldId xmlns:r="http://schemas.openxmlformats.org/officeDocument/2006/relationships" id="258" r:id="R3c3d1ece4f1c4079"/>
+    <p:sldId xmlns:r="http://schemas.openxmlformats.org/officeDocument/2006/relationships" id="259" r:id="R7462725418c2404f"/>
+    <p:sldId xmlns:r="http://schemas.openxmlformats.org/officeDocument/2006/relationships" id="260" r:id="Rb5b9afc9fca54736"/>
+    <p:sldId xmlns:r="http://schemas.openxmlformats.org/officeDocument/2006/relationships" id="261" r:id="Rd71a937202d04098"/>
+    <p:sldId xmlns:r="http://schemas.openxmlformats.org/officeDocument/2006/relationships" id="262" r:id="R22429fea4df541a4"/>
+    <p:sldId xmlns:r="http://schemas.openxmlformats.org/officeDocument/2006/relationships" id="263" r:id="R485c8a5e203e47cd"/>
+    <p:sldId xmlns:r="http://schemas.openxmlformats.org/officeDocument/2006/relationships" id="264" r:id="Rcb6965780dda4833"/>
+    <p:sldId xmlns:r="http://schemas.openxmlformats.org/officeDocument/2006/relationships" id="265" r:id="Rdbd329adaf8f4843"/>
   </p:sldIdLst>
   <p:sldSz cx="12192000" cy="6858000"/>
   <p:notesSz cx="6858000" cy="9144000"/>
@@ -1204,7 +1204,7 @@
   </p:cSld>
   <p:clrMap bg1="lt1" tx1="dk1" bg2="lt2" tx2="dk2" accent1="accent1" accent2="accent2" accent3="accent3" accent4="accent4" accent5="accent5" accent6="accent6" hlink="hlink" folHlink="folHlink"/>
   <p:sldLayoutIdLst>
-    <p:sldLayoutId xmlns:r="http://schemas.openxmlformats.org/officeDocument/2006/relationships" id="2147483649" r:id="Rd720cfb5a6ca4a75"/>
+    <p:sldLayoutId xmlns:r="http://schemas.openxmlformats.org/officeDocument/2006/relationships" id="2147483649" r:id="R14c74f2389d3429e"/>
   </p:sldLayoutIdLst>
   <p:txStyles>
     <p:titleStyle>
@@ -1785,6 +1785,7 @@
           <a:lstStyle xmlns:a="http://schemas.openxmlformats.org/drawingml/2006/main"/>
           <a:p xmlns:a="http://schemas.openxmlformats.org/drawingml/2006/main">
             <a:pPr algn="l">
+              <a:buNone/>
               <a:defRPr sz="1200" b="1">
                 <a:solidFill>
                   <a:srgbClr val="2478E5"/>
@@ -1843,6 +1844,7 @@
           <a:lstStyle xmlns:a="http://schemas.openxmlformats.org/drawingml/2006/main"/>
           <a:p xmlns:a="http://schemas.openxmlformats.org/drawingml/2006/main">
             <a:pPr algn="l">
+              <a:buNone/>
               <a:defRPr sz="4350" b="1">
                 <a:solidFill>
                   <a:srgbClr val="111111"/>
@@ -1866,6 +1868,7 @@
           </a:p>
           <a:p xmlns:a="http://schemas.openxmlformats.org/drawingml/2006/main">
             <a:pPr algn="l">
+              <a:buNone/>
               <a:defRPr sz="4350" b="1">
                 <a:solidFill>
                   <a:srgbClr val="111111"/>
@@ -1955,6 +1958,7 @@
           <a:lstStyle xmlns:a="http://schemas.openxmlformats.org/drawingml/2006/main"/>
           <a:p xmlns:a="http://schemas.openxmlformats.org/drawingml/2006/main">
             <a:pPr algn="l">
+              <a:buNone/>
               <a:defRPr sz="1800" b="0">
                 <a:solidFill>
                   <a:srgbClr val="173B57"/>
@@ -2013,6 +2017,7 @@
           <a:lstStyle xmlns:a="http://schemas.openxmlformats.org/drawingml/2006/main"/>
           <a:p xmlns:a="http://schemas.openxmlformats.org/drawingml/2006/main">
             <a:pPr algn="l">
+              <a:buNone/>
               <a:defRPr sz="1500" b="1">
                 <a:solidFill>
                   <a:srgbClr val="111111"/>
@@ -2052,8 +2057,8 @@
         </p:nvSpPr>
         <p:spPr>
           <a:xfrm xmlns:a="http://schemas.openxmlformats.org/drawingml/2006/main">
-            <a:off x="9906000" y="6210300"/>
-            <a:ext cx="1866900" cy="228600"/>
+            <a:off x="9334500" y="6210300"/>
+            <a:ext cx="2438400" cy="228600"/>
           </a:xfrm>
           <a:prstGeom xmlns:a="http://schemas.openxmlformats.org/drawingml/2006/main" prst="rect">
             <a:avLst/>
@@ -2071,6 +2076,7 @@
           <a:lstStyle xmlns:a="http://schemas.openxmlformats.org/drawingml/2006/main"/>
           <a:p xmlns:a="http://schemas.openxmlformats.org/drawingml/2006/main">
             <a:pPr algn="r">
+              <a:buNone/>
               <a:defRPr sz="975" b="0">
                 <a:solidFill>
                   <a:srgbClr val="5C6570"/>
@@ -2081,15 +2087,15 @@
               </a:defRPr>
             </a:pPr>
             <a:r>
-              <a:rPr sz="975" b="0">
-                <a:solidFill>
-                  <a:srgbClr val="5C6570"/>
-                </a:solidFill>
-                <a:latin typeface="Noto Sans TC"/>
-                <a:ea typeface="Noto Sans TC"/>
-                <a:cs typeface="Noto Sans TC"/>
-              </a:rPr>
-              <a:t>v1.0 Candidate</a:t>
+              <a:rPr sz="1000" b="0">
+                <a:solidFill>
+                  <a:srgbClr val="606B7A"/>
+                </a:solidFill>
+                <a:latin typeface="Noto Sans TC"/>
+                <a:ea typeface="Noto Sans TC"/>
+                <a:cs typeface="Noto Sans TC"/>
+              </a:rPr>
+              <a:t>v1.1 Baseline Candidate</a:t>
             </a:r>
           </a:p>
         </p:txBody>
@@ -2158,6 +2164,7 @@
           <a:lstStyle xmlns:a="http://schemas.openxmlformats.org/drawingml/2006/main"/>
           <a:p xmlns:a="http://schemas.openxmlformats.org/drawingml/2006/main">
             <a:pPr algn="l">
+              <a:buNone/>
               <a:defRPr sz="900" b="1">
                 <a:solidFill>
                   <a:srgbClr val="2478E5"/>
@@ -2216,6 +2223,7 @@
           <a:lstStyle xmlns:a="http://schemas.openxmlformats.org/drawingml/2006/main"/>
           <a:p xmlns:a="http://schemas.openxmlformats.org/drawingml/2006/main">
             <a:pPr algn="l">
+              <a:buNone/>
               <a:defRPr sz="2850" b="1">
                 <a:solidFill>
                   <a:srgbClr val="111111"/>
@@ -2241,7 +2249,7 @@
       </p:sp>
       <p:cxnSp>
         <p:nvCxnSpPr>
-          <p:cNvPr id="37" name=""/>
+          <p:cNvPr id="97" name=""/>
           <p:cNvCxnSpPr/>
           <p:nvPr/>
         </p:nvCxnSpPr>
@@ -2296,6 +2304,7 @@
           <a:lstStyle xmlns:a="http://schemas.openxmlformats.org/drawingml/2006/main"/>
           <a:p xmlns:a="http://schemas.openxmlformats.org/drawingml/2006/main">
             <a:pPr algn="r">
+              <a:buNone/>
               <a:defRPr sz="900" b="0">
                 <a:solidFill>
                   <a:srgbClr val="5C6570"/>
@@ -2354,6 +2363,7 @@
           <a:lstStyle xmlns:a="http://schemas.openxmlformats.org/drawingml/2006/main"/>
           <a:p xmlns:a="http://schemas.openxmlformats.org/drawingml/2006/main">
             <a:pPr algn="l">
+              <a:buNone/>
               <a:defRPr sz="1125" b="1">
                 <a:solidFill>
                   <a:srgbClr val="2478E5"/>
@@ -2412,6 +2422,7 @@
           <a:lstStyle xmlns:a="http://schemas.openxmlformats.org/drawingml/2006/main"/>
           <a:p xmlns:a="http://schemas.openxmlformats.org/drawingml/2006/main">
             <a:pPr algn="l">
+              <a:buNone/>
               <a:defRPr sz="1800" b="1">
                 <a:solidFill>
                   <a:srgbClr val="2478E5"/>
@@ -2470,6 +2481,7 @@
           <a:lstStyle xmlns:a="http://schemas.openxmlformats.org/drawingml/2006/main"/>
           <a:p xmlns:a="http://schemas.openxmlformats.org/drawingml/2006/main">
             <a:pPr algn="l">
+              <a:buNone/>
               <a:defRPr sz="1350" b="1">
                 <a:solidFill>
                   <a:srgbClr val="111111"/>
@@ -2495,7 +2507,7 @@
       </p:sp>
       <p:cxnSp>
         <p:nvCxnSpPr>
-          <p:cNvPr id="42" name=""/>
+          <p:cNvPr id="102" name=""/>
           <p:cNvCxnSpPr/>
           <p:nvPr/>
         </p:nvCxnSpPr>
@@ -2550,6 +2562,7 @@
           <a:lstStyle xmlns:a="http://schemas.openxmlformats.org/drawingml/2006/main"/>
           <a:p xmlns:a="http://schemas.openxmlformats.org/drawingml/2006/main">
             <a:pPr algn="l">
+              <a:buNone/>
               <a:defRPr sz="1800" b="1">
                 <a:solidFill>
                   <a:srgbClr val="2478E5"/>
@@ -2608,6 +2621,7 @@
           <a:lstStyle xmlns:a="http://schemas.openxmlformats.org/drawingml/2006/main"/>
           <a:p xmlns:a="http://schemas.openxmlformats.org/drawingml/2006/main">
             <a:pPr algn="l">
+              <a:buNone/>
               <a:defRPr sz="1350" b="1">
                 <a:solidFill>
                   <a:srgbClr val="111111"/>
@@ -2633,7 +2647,7 @@
       </p:sp>
       <p:cxnSp>
         <p:nvCxnSpPr>
-          <p:cNvPr id="45" name=""/>
+          <p:cNvPr id="105" name=""/>
           <p:cNvCxnSpPr/>
           <p:nvPr/>
         </p:nvCxnSpPr>
@@ -2688,6 +2702,7 @@
           <a:lstStyle xmlns:a="http://schemas.openxmlformats.org/drawingml/2006/main"/>
           <a:p xmlns:a="http://schemas.openxmlformats.org/drawingml/2006/main">
             <a:pPr algn="l">
+              <a:buNone/>
               <a:defRPr sz="1800" b="1">
                 <a:solidFill>
                   <a:srgbClr val="2478E5"/>
@@ -2746,6 +2761,7 @@
           <a:lstStyle xmlns:a="http://schemas.openxmlformats.org/drawingml/2006/main"/>
           <a:p xmlns:a="http://schemas.openxmlformats.org/drawingml/2006/main">
             <a:pPr algn="l">
+              <a:buNone/>
               <a:defRPr sz="1350" b="1">
                 <a:solidFill>
                   <a:srgbClr val="111111"/>
@@ -2771,7 +2787,7 @@
       </p:sp>
       <p:cxnSp>
         <p:nvCxnSpPr>
-          <p:cNvPr id="48" name=""/>
+          <p:cNvPr id="108" name=""/>
           <p:cNvCxnSpPr/>
           <p:nvPr/>
         </p:nvCxnSpPr>
@@ -2826,6 +2842,7 @@
           <a:lstStyle xmlns:a="http://schemas.openxmlformats.org/drawingml/2006/main"/>
           <a:p xmlns:a="http://schemas.openxmlformats.org/drawingml/2006/main">
             <a:pPr algn="l">
+              <a:buNone/>
               <a:defRPr sz="1800" b="1">
                 <a:solidFill>
                   <a:srgbClr val="2478E5"/>
@@ -2884,6 +2901,7 @@
           <a:lstStyle xmlns:a="http://schemas.openxmlformats.org/drawingml/2006/main"/>
           <a:p xmlns:a="http://schemas.openxmlformats.org/drawingml/2006/main">
             <a:pPr algn="l">
+              <a:buNone/>
               <a:defRPr sz="1350" b="1">
                 <a:solidFill>
                   <a:srgbClr val="111111"/>
@@ -2909,7 +2927,7 @@
       </p:sp>
       <p:cxnSp>
         <p:nvCxnSpPr>
-          <p:cNvPr id="51" name=""/>
+          <p:cNvPr id="111" name=""/>
           <p:cNvCxnSpPr/>
           <p:nvPr/>
         </p:nvCxnSpPr>
@@ -2964,6 +2982,7 @@
           <a:lstStyle xmlns:a="http://schemas.openxmlformats.org/drawingml/2006/main"/>
           <a:p xmlns:a="http://schemas.openxmlformats.org/drawingml/2006/main">
             <a:pPr algn="l">
+              <a:buNone/>
               <a:defRPr sz="1800" b="1">
                 <a:solidFill>
                   <a:srgbClr val="2478E5"/>
@@ -3022,6 +3041,7 @@
           <a:lstStyle xmlns:a="http://schemas.openxmlformats.org/drawingml/2006/main"/>
           <a:p xmlns:a="http://schemas.openxmlformats.org/drawingml/2006/main">
             <a:pPr algn="l">
+              <a:buNone/>
               <a:defRPr sz="1350" b="1">
                 <a:solidFill>
                   <a:srgbClr val="111111"/>
@@ -3047,7 +3067,7 @@
       </p:sp>
       <p:cxnSp>
         <p:nvCxnSpPr>
-          <p:cNvPr id="54" name=""/>
+          <p:cNvPr id="114" name=""/>
           <p:cNvCxnSpPr/>
           <p:nvPr/>
         </p:nvCxnSpPr>
@@ -3102,6 +3122,7 @@
           <a:lstStyle xmlns:a="http://schemas.openxmlformats.org/drawingml/2006/main"/>
           <a:p xmlns:a="http://schemas.openxmlformats.org/drawingml/2006/main">
             <a:pPr algn="l">
+              <a:buNone/>
               <a:defRPr sz="1125" b="1">
                 <a:solidFill>
                   <a:srgbClr val="2478E5"/>
@@ -3191,6 +3212,7 @@
           <a:lstStyle xmlns:a="http://schemas.openxmlformats.org/drawingml/2006/main"/>
           <a:p xmlns:a="http://schemas.openxmlformats.org/drawingml/2006/main">
             <a:pPr algn="l">
+              <a:buNone/>
               <a:defRPr sz="1500" b="1">
                 <a:solidFill>
                   <a:srgbClr val="2478E5"/>
@@ -3249,6 +3271,7 @@
           <a:lstStyle xmlns:a="http://schemas.openxmlformats.org/drawingml/2006/main"/>
           <a:p xmlns:a="http://schemas.openxmlformats.org/drawingml/2006/main">
             <a:pPr algn="l">
+              <a:buNone/>
               <a:defRPr sz="1125" b="0">
                 <a:solidFill>
                   <a:srgbClr val="5C6570"/>
@@ -3338,6 +3361,7 @@
           <a:lstStyle xmlns:a="http://schemas.openxmlformats.org/drawingml/2006/main"/>
           <a:p xmlns:a="http://schemas.openxmlformats.org/drawingml/2006/main">
             <a:pPr algn="l">
+              <a:buNone/>
               <a:defRPr sz="1500" b="1">
                 <a:solidFill>
                   <a:srgbClr val="2478E5"/>
@@ -3396,6 +3420,7 @@
           <a:lstStyle xmlns:a="http://schemas.openxmlformats.org/drawingml/2006/main"/>
           <a:p xmlns:a="http://schemas.openxmlformats.org/drawingml/2006/main">
             <a:pPr algn="l">
+              <a:buNone/>
               <a:defRPr sz="1125" b="0">
                 <a:solidFill>
                   <a:srgbClr val="5C6570"/>
@@ -3485,6 +3510,7 @@
           <a:lstStyle xmlns:a="http://schemas.openxmlformats.org/drawingml/2006/main"/>
           <a:p xmlns:a="http://schemas.openxmlformats.org/drawingml/2006/main">
             <a:pPr algn="l">
+              <a:buNone/>
               <a:defRPr sz="1500" b="1">
                 <a:solidFill>
                   <a:srgbClr val="2478E5"/>
@@ -3543,6 +3569,7 @@
           <a:lstStyle xmlns:a="http://schemas.openxmlformats.org/drawingml/2006/main"/>
           <a:p xmlns:a="http://schemas.openxmlformats.org/drawingml/2006/main">
             <a:pPr algn="l">
+              <a:buNone/>
               <a:defRPr sz="1125" b="0">
                 <a:solidFill>
                   <a:srgbClr val="5C6570"/>
@@ -3632,6 +3659,7 @@
           <a:lstStyle xmlns:a="http://schemas.openxmlformats.org/drawingml/2006/main"/>
           <a:p xmlns:a="http://schemas.openxmlformats.org/drawingml/2006/main">
             <a:pPr algn="l">
+              <a:buNone/>
               <a:defRPr sz="1050" b="1">
                 <a:solidFill>
                   <a:srgbClr val="6DCBF4"/>
@@ -3671,8 +3699,8 @@
         </p:nvSpPr>
         <p:spPr>
           <a:xfrm xmlns:a="http://schemas.openxmlformats.org/drawingml/2006/main">
-            <a:off x="6505575" y="5438775"/>
-            <a:ext cx="4572000" cy="361950"/>
+            <a:off x="6505575" y="5257800"/>
+            <a:ext cx="4572000" cy="571500"/>
           </a:xfrm>
           <a:prstGeom xmlns:a="http://schemas.openxmlformats.org/drawingml/2006/main" prst="rect">
             <a:avLst/>
@@ -3685,11 +3713,12 @@
         </p:spPr>
         <p:txBody>
           <a:bodyPr xmlns:a="http://schemas.openxmlformats.org/drawingml/2006/main" wrap="square" lIns="0" tIns="0" rIns="0" bIns="0" anchor="t">
-            <a:normAutofit fontScale="87963"/>
+            <a:normAutofit fontScale="88479"/>
           </a:bodyPr>
           <a:lstStyle xmlns:a="http://schemas.openxmlformats.org/drawingml/2006/main"/>
           <a:p xmlns:a="http://schemas.openxmlformats.org/drawingml/2006/main">
             <a:pPr algn="l">
+              <a:buNone/>
               <a:defRPr sz="1350" b="1">
                 <a:solidFill>
                   <a:srgbClr val="FFFFFF"/>
@@ -3700,7 +3729,7 @@
               </a:defRPr>
             </a:pPr>
             <a:r>
-              <a:rPr sz="1350" b="1">
+              <a:rPr sz="1600" b="1">
                 <a:solidFill>
                   <a:srgbClr val="FFFFFF"/>
                 </a:solidFill>
@@ -3708,7 +3737,31 @@
                 <a:ea typeface="Noto Sans TC"/>
                 <a:cs typeface="Noto Sans TC"/>
               </a:rPr>
-              <a:t>本 Sprint 選一個 Feature、一個 Bug；用 Matrix routing，review evidence 與摩擦點。</a:t>
+              <a:t>Sprint：1 Feature + 1 Bug</a:t>
+            </a:r>
+          </a:p>
+          <a:p xmlns:a="http://schemas.openxmlformats.org/drawingml/2006/main">
+            <a:pPr algn="l">
+              <a:buNone/>
+              <a:defRPr sz="1350" b="1">
+                <a:solidFill>
+                  <a:srgbClr val="FFFFFF"/>
+                </a:solidFill>
+                <a:latin typeface="Noto Sans TC"/>
+                <a:ea typeface="Noto Sans TC"/>
+                <a:cs typeface="Noto Sans TC"/>
+              </a:defRPr>
+            </a:pPr>
+            <a:r>
+              <a:rPr sz="1600" b="1">
+                <a:solidFill>
+                  <a:srgbClr val="FFFFFF"/>
+                </a:solidFill>
+                <a:latin typeface="Noto Sans TC"/>
+                <a:ea typeface="Noto Sans TC"/>
+                <a:cs typeface="Noto Sans TC"/>
+              </a:rPr>
+              <a:t>Tech Lead · Sprint Review · routing evidence / friction</a:t>
             </a:r>
           </a:p>
         </p:txBody>
@@ -3748,6 +3801,7 @@
           <a:lstStyle xmlns:a="http://schemas.openxmlformats.org/drawingml/2006/main"/>
           <a:p xmlns:a="http://schemas.openxmlformats.org/drawingml/2006/main">
             <a:pPr algn="l">
+              <a:buNone/>
               <a:defRPr sz="1350" b="1">
                 <a:solidFill>
                   <a:srgbClr val="173B57"/>
@@ -3835,6 +3889,7 @@
           <a:lstStyle xmlns:a="http://schemas.openxmlformats.org/drawingml/2006/main"/>
           <a:p xmlns:a="http://schemas.openxmlformats.org/drawingml/2006/main">
             <a:pPr algn="l">
+              <a:buNone/>
               <a:defRPr sz="2850" b="1">
                 <a:solidFill>
                   <a:srgbClr val="111111"/>
@@ -3860,7 +3915,7 @@
       </p:sp>
       <p:cxnSp>
         <p:nvCxnSpPr>
-          <p:cNvPr id="19" name=""/>
+          <p:cNvPr id="25" name=""/>
           <p:cNvCxnSpPr/>
           <p:nvPr/>
         </p:nvCxnSpPr>
@@ -3915,6 +3970,7 @@
           <a:lstStyle xmlns:a="http://schemas.openxmlformats.org/drawingml/2006/main"/>
           <a:p xmlns:a="http://schemas.openxmlformats.org/drawingml/2006/main">
             <a:pPr algn="r">
+              <a:buNone/>
               <a:defRPr sz="900" b="0">
                 <a:solidFill>
                   <a:srgbClr val="5C6570"/>
@@ -3973,6 +4029,7 @@
           <a:lstStyle xmlns:a="http://schemas.openxmlformats.org/drawingml/2006/main"/>
           <a:p xmlns:a="http://schemas.openxmlformats.org/drawingml/2006/main">
             <a:pPr algn="l">
+              <a:buNone/>
               <a:defRPr sz="1500" b="0">
                 <a:solidFill>
                   <a:srgbClr val="5C6570"/>
@@ -4062,6 +4119,7 @@
           <a:lstStyle xmlns:a="http://schemas.openxmlformats.org/drawingml/2006/main"/>
           <a:p xmlns:a="http://schemas.openxmlformats.org/drawingml/2006/main">
             <a:pPr algn="l">
+              <a:buNone/>
               <a:defRPr sz="1800" b="1">
                 <a:solidFill>
                   <a:srgbClr val="2478E5"/>
@@ -4120,6 +4178,7 @@
           <a:lstStyle xmlns:a="http://schemas.openxmlformats.org/drawingml/2006/main"/>
           <a:p xmlns:a="http://schemas.openxmlformats.org/drawingml/2006/main">
             <a:pPr algn="l">
+              <a:buNone/>
               <a:defRPr sz="1950" b="1">
                 <a:solidFill>
                   <a:srgbClr val="111111"/>
@@ -4178,6 +4237,7 @@
           <a:lstStyle xmlns:a="http://schemas.openxmlformats.org/drawingml/2006/main"/>
           <a:p xmlns:a="http://schemas.openxmlformats.org/drawingml/2006/main">
             <a:pPr algn="l">
+              <a:buNone/>
               <a:defRPr sz="1350" b="0">
                 <a:solidFill>
                   <a:srgbClr val="5C6570"/>
@@ -4267,6 +4327,7 @@
           <a:lstStyle xmlns:a="http://schemas.openxmlformats.org/drawingml/2006/main"/>
           <a:p xmlns:a="http://schemas.openxmlformats.org/drawingml/2006/main">
             <a:pPr algn="l">
+              <a:buNone/>
               <a:defRPr sz="1800" b="1">
                 <a:solidFill>
                   <a:srgbClr val="2478E5"/>
@@ -4325,6 +4386,7 @@
           <a:lstStyle xmlns:a="http://schemas.openxmlformats.org/drawingml/2006/main"/>
           <a:p xmlns:a="http://schemas.openxmlformats.org/drawingml/2006/main">
             <a:pPr algn="l">
+              <a:buNone/>
               <a:defRPr sz="1950" b="1">
                 <a:solidFill>
                   <a:srgbClr val="111111"/>
@@ -4383,6 +4445,7 @@
           <a:lstStyle xmlns:a="http://schemas.openxmlformats.org/drawingml/2006/main"/>
           <a:p xmlns:a="http://schemas.openxmlformats.org/drawingml/2006/main">
             <a:pPr algn="l">
+              <a:buNone/>
               <a:defRPr sz="1350" b="0">
                 <a:solidFill>
                   <a:srgbClr val="5C6570"/>
@@ -4472,6 +4535,7 @@
           <a:lstStyle xmlns:a="http://schemas.openxmlformats.org/drawingml/2006/main"/>
           <a:p xmlns:a="http://schemas.openxmlformats.org/drawingml/2006/main">
             <a:pPr algn="l">
+              <a:buNone/>
               <a:defRPr sz="1800" b="1">
                 <a:solidFill>
                   <a:srgbClr val="2478E5"/>
@@ -4530,6 +4594,7 @@
           <a:lstStyle xmlns:a="http://schemas.openxmlformats.org/drawingml/2006/main"/>
           <a:p xmlns:a="http://schemas.openxmlformats.org/drawingml/2006/main">
             <a:pPr algn="l">
+              <a:buNone/>
               <a:defRPr sz="1950" b="1">
                 <a:solidFill>
                   <a:srgbClr val="111111"/>
@@ -4588,6 +4653,7 @@
           <a:lstStyle xmlns:a="http://schemas.openxmlformats.org/drawingml/2006/main"/>
           <a:p xmlns:a="http://schemas.openxmlformats.org/drawingml/2006/main">
             <a:pPr algn="l">
+              <a:buNone/>
               <a:defRPr sz="1350" b="0">
                 <a:solidFill>
                   <a:srgbClr val="5C6570"/>
@@ -4646,6 +4712,7 @@
           <a:lstStyle xmlns:a="http://schemas.openxmlformats.org/drawingml/2006/main"/>
           <a:p xmlns:a="http://schemas.openxmlformats.org/drawingml/2006/main">
             <a:pPr algn="l">
+              <a:buNone/>
               <a:defRPr sz="1800" b="1">
                 <a:solidFill>
                   <a:srgbClr val="173B57"/>
@@ -4733,6 +4800,7 @@
           <a:lstStyle xmlns:a="http://schemas.openxmlformats.org/drawingml/2006/main"/>
           <a:p xmlns:a="http://schemas.openxmlformats.org/drawingml/2006/main">
             <a:pPr algn="l">
+              <a:buNone/>
               <a:defRPr sz="2850" b="1">
                 <a:solidFill>
                   <a:srgbClr val="111111"/>
@@ -4758,7 +4826,7 @@
       </p:sp>
       <p:cxnSp>
         <p:nvCxnSpPr>
-          <p:cNvPr id="37" name=""/>
+          <p:cNvPr id="130" name=""/>
           <p:cNvCxnSpPr/>
           <p:nvPr/>
         </p:nvCxnSpPr>
@@ -4813,6 +4881,7 @@
           <a:lstStyle xmlns:a="http://schemas.openxmlformats.org/drawingml/2006/main"/>
           <a:p xmlns:a="http://schemas.openxmlformats.org/drawingml/2006/main">
             <a:pPr algn="r">
+              <a:buNone/>
               <a:defRPr sz="900" b="0">
                 <a:solidFill>
                   <a:srgbClr val="5C6570"/>
@@ -4902,6 +4971,7 @@
           <a:lstStyle xmlns:a="http://schemas.openxmlformats.org/drawingml/2006/main"/>
           <a:p xmlns:a="http://schemas.openxmlformats.org/drawingml/2006/main">
             <a:pPr algn="l">
+              <a:buNone/>
               <a:defRPr sz="1350" b="1">
                 <a:solidFill>
                   <a:srgbClr val="6DCBF4"/>
@@ -4960,6 +5030,7 @@
           <a:lstStyle xmlns:a="http://schemas.openxmlformats.org/drawingml/2006/main"/>
           <a:p xmlns:a="http://schemas.openxmlformats.org/drawingml/2006/main">
             <a:pPr algn="l">
+              <a:buNone/>
               <a:defRPr sz="1650" b="1">
                 <a:solidFill>
                   <a:srgbClr val="FFFFFF"/>
@@ -4985,7 +5056,7 @@
       </p:sp>
       <p:cxnSp>
         <p:nvCxnSpPr>
-          <p:cNvPr id="42" name=""/>
+          <p:cNvPr id="135" name=""/>
           <p:cNvCxnSpPr/>
           <p:nvPr/>
         </p:nvCxnSpPr>
@@ -5007,7 +5078,7 @@
       </p:cxnSp>
       <p:cxnSp>
         <p:nvCxnSpPr>
-          <p:cNvPr id="43" name=""/>
+          <p:cNvPr id="136" name=""/>
           <p:cNvCxnSpPr/>
           <p:nvPr/>
         </p:nvCxnSpPr>
@@ -5029,7 +5100,7 @@
       </p:cxnSp>
       <p:cxnSp>
         <p:nvCxnSpPr>
-          <p:cNvPr id="44" name=""/>
+          <p:cNvPr id="137" name=""/>
           <p:cNvCxnSpPr/>
           <p:nvPr/>
         </p:nvCxnSpPr>
@@ -5051,7 +5122,7 @@
       </p:cxnSp>
       <p:cxnSp>
         <p:nvCxnSpPr>
-          <p:cNvPr id="45" name=""/>
+          <p:cNvPr id="138" name=""/>
           <p:cNvCxnSpPr/>
           <p:nvPr/>
         </p:nvCxnSpPr>
@@ -5137,6 +5208,7 @@
           <a:lstStyle xmlns:a="http://schemas.openxmlformats.org/drawingml/2006/main"/>
           <a:p xmlns:a="http://schemas.openxmlformats.org/drawingml/2006/main">
             <a:pPr algn="l">
+              <a:buNone/>
               <a:defRPr sz="1650" b="1">
                 <a:solidFill>
                   <a:srgbClr val="2478E5"/>
@@ -5195,6 +5267,7 @@
           <a:lstStyle xmlns:a="http://schemas.openxmlformats.org/drawingml/2006/main"/>
           <a:p xmlns:a="http://schemas.openxmlformats.org/drawingml/2006/main">
             <a:pPr algn="l">
+              <a:buNone/>
               <a:defRPr sz="1725" b="1">
                 <a:solidFill>
                   <a:srgbClr val="111111"/>
@@ -5253,6 +5326,7 @@
           <a:lstStyle xmlns:a="http://schemas.openxmlformats.org/drawingml/2006/main"/>
           <a:p xmlns:a="http://schemas.openxmlformats.org/drawingml/2006/main">
             <a:pPr algn="l">
+              <a:buNone/>
               <a:defRPr sz="1125" b="0">
                 <a:solidFill>
                   <a:srgbClr val="5C6570"/>
@@ -5342,6 +5416,7 @@
           <a:lstStyle xmlns:a="http://schemas.openxmlformats.org/drawingml/2006/main"/>
           <a:p xmlns:a="http://schemas.openxmlformats.org/drawingml/2006/main">
             <a:pPr algn="l">
+              <a:buNone/>
               <a:defRPr sz="1650" b="1">
                 <a:solidFill>
                   <a:srgbClr val="2478E5"/>
@@ -5400,6 +5475,7 @@
           <a:lstStyle xmlns:a="http://schemas.openxmlformats.org/drawingml/2006/main"/>
           <a:p xmlns:a="http://schemas.openxmlformats.org/drawingml/2006/main">
             <a:pPr algn="l">
+              <a:buNone/>
               <a:defRPr sz="1725" b="1">
                 <a:solidFill>
                   <a:srgbClr val="111111"/>
@@ -5458,6 +5534,7 @@
           <a:lstStyle xmlns:a="http://schemas.openxmlformats.org/drawingml/2006/main"/>
           <a:p xmlns:a="http://schemas.openxmlformats.org/drawingml/2006/main">
             <a:pPr algn="l">
+              <a:buNone/>
               <a:defRPr sz="1125" b="0">
                 <a:solidFill>
                   <a:srgbClr val="5C6570"/>
@@ -5547,6 +5624,7 @@
           <a:lstStyle xmlns:a="http://schemas.openxmlformats.org/drawingml/2006/main"/>
           <a:p xmlns:a="http://schemas.openxmlformats.org/drawingml/2006/main">
             <a:pPr algn="l">
+              <a:buNone/>
               <a:defRPr sz="1650" b="1">
                 <a:solidFill>
                   <a:srgbClr val="2478E5"/>
@@ -5605,6 +5683,7 @@
           <a:lstStyle xmlns:a="http://schemas.openxmlformats.org/drawingml/2006/main"/>
           <a:p xmlns:a="http://schemas.openxmlformats.org/drawingml/2006/main">
             <a:pPr algn="l">
+              <a:buNone/>
               <a:defRPr sz="1725" b="1">
                 <a:solidFill>
                   <a:srgbClr val="111111"/>
@@ -5663,6 +5742,7 @@
           <a:lstStyle xmlns:a="http://schemas.openxmlformats.org/drawingml/2006/main"/>
           <a:p xmlns:a="http://schemas.openxmlformats.org/drawingml/2006/main">
             <a:pPr algn="l">
+              <a:buNone/>
               <a:defRPr sz="1125" b="0">
                 <a:solidFill>
                   <a:srgbClr val="5C6570"/>
@@ -5752,6 +5832,7 @@
           <a:lstStyle xmlns:a="http://schemas.openxmlformats.org/drawingml/2006/main"/>
           <a:p xmlns:a="http://schemas.openxmlformats.org/drawingml/2006/main">
             <a:pPr algn="l">
+              <a:buNone/>
               <a:defRPr sz="1650" b="1">
                 <a:solidFill>
                   <a:srgbClr val="2478E5"/>
@@ -5810,6 +5891,7 @@
           <a:lstStyle xmlns:a="http://schemas.openxmlformats.org/drawingml/2006/main"/>
           <a:p xmlns:a="http://schemas.openxmlformats.org/drawingml/2006/main">
             <a:pPr algn="l">
+              <a:buNone/>
               <a:defRPr sz="1725" b="1">
                 <a:solidFill>
                   <a:srgbClr val="111111"/>
@@ -5868,6 +5950,7 @@
           <a:lstStyle xmlns:a="http://schemas.openxmlformats.org/drawingml/2006/main"/>
           <a:p xmlns:a="http://schemas.openxmlformats.org/drawingml/2006/main">
             <a:pPr algn="l">
+              <a:buNone/>
               <a:defRPr sz="1125" b="0">
                 <a:solidFill>
                   <a:srgbClr val="5C6570"/>
@@ -5957,6 +6040,7 @@
           <a:lstStyle xmlns:a="http://schemas.openxmlformats.org/drawingml/2006/main"/>
           <a:p xmlns:a="http://schemas.openxmlformats.org/drawingml/2006/main">
             <a:pPr algn="l">
+              <a:buNone/>
               <a:defRPr sz="1650" b="1">
                 <a:solidFill>
                   <a:srgbClr val="2478E5"/>
@@ -6015,6 +6099,7 @@
           <a:lstStyle xmlns:a="http://schemas.openxmlformats.org/drawingml/2006/main"/>
           <a:p xmlns:a="http://schemas.openxmlformats.org/drawingml/2006/main">
             <a:pPr algn="l">
+              <a:buNone/>
               <a:defRPr sz="1725" b="1">
                 <a:solidFill>
                   <a:srgbClr val="111111"/>
@@ -6073,6 +6158,7 @@
           <a:lstStyle xmlns:a="http://schemas.openxmlformats.org/drawingml/2006/main"/>
           <a:p xmlns:a="http://schemas.openxmlformats.org/drawingml/2006/main">
             <a:pPr algn="l">
+              <a:buNone/>
               <a:defRPr sz="1125" b="0">
                 <a:solidFill>
                   <a:srgbClr val="5C6570"/>
@@ -6098,7 +6184,7 @@
       </p:sp>
       <p:cxnSp>
         <p:nvCxnSpPr>
-          <p:cNvPr id="66" name=""/>
+          <p:cNvPr id="159" name=""/>
           <p:cNvCxnSpPr/>
           <p:nvPr/>
         </p:nvCxnSpPr>
@@ -6184,6 +6270,7 @@
           <a:lstStyle xmlns:a="http://schemas.openxmlformats.org/drawingml/2006/main"/>
           <a:p xmlns:a="http://schemas.openxmlformats.org/drawingml/2006/main">
             <a:pPr algn="l">
+              <a:buNone/>
               <a:defRPr sz="1650" b="1">
                 <a:solidFill>
                   <a:srgbClr val="173B57"/>
@@ -6242,6 +6329,7 @@
           <a:lstStyle xmlns:a="http://schemas.openxmlformats.org/drawingml/2006/main"/>
           <a:p xmlns:a="http://schemas.openxmlformats.org/drawingml/2006/main">
             <a:pPr algn="l">
+              <a:buNone/>
               <a:defRPr sz="1200" b="0">
                 <a:solidFill>
                   <a:srgbClr val="173B57"/>
@@ -6300,6 +6388,7 @@
           <a:lstStyle xmlns:a="http://schemas.openxmlformats.org/drawingml/2006/main"/>
           <a:p xmlns:a="http://schemas.openxmlformats.org/drawingml/2006/main">
             <a:pPr algn="l">
+              <a:buNone/>
               <a:defRPr sz="1125" b="0">
                 <a:solidFill>
                   <a:srgbClr val="5C6570"/>
@@ -6387,6 +6476,7 @@
           <a:lstStyle xmlns:a="http://schemas.openxmlformats.org/drawingml/2006/main"/>
           <a:p xmlns:a="http://schemas.openxmlformats.org/drawingml/2006/main">
             <a:pPr algn="l">
+              <a:buNone/>
               <a:defRPr sz="2850" b="1">
                 <a:solidFill>
                   <a:srgbClr val="111111"/>
@@ -6412,7 +6502,7 @@
       </p:sp>
       <p:cxnSp>
         <p:nvCxnSpPr>
-          <p:cNvPr id="40" name=""/>
+          <p:cNvPr id="58" name=""/>
           <p:cNvCxnSpPr/>
           <p:nvPr/>
         </p:nvCxnSpPr>
@@ -6467,6 +6557,7 @@
           <a:lstStyle xmlns:a="http://schemas.openxmlformats.org/drawingml/2006/main"/>
           <a:p xmlns:a="http://schemas.openxmlformats.org/drawingml/2006/main">
             <a:pPr algn="r">
+              <a:buNone/>
               <a:defRPr sz="900" b="0">
                 <a:solidFill>
                   <a:srgbClr val="5C6570"/>
@@ -6492,7 +6583,7 @@
       </p:sp>
       <p:cxnSp>
         <p:nvCxnSpPr>
-          <p:cNvPr id="42" name=""/>
+          <p:cNvPr id="60" name=""/>
           <p:cNvCxnSpPr/>
           <p:nvPr/>
         </p:nvCxnSpPr>
@@ -6514,7 +6605,7 @@
       </p:cxnSp>
       <p:cxnSp>
         <p:nvCxnSpPr>
-          <p:cNvPr id="43" name=""/>
+          <p:cNvPr id="61" name=""/>
           <p:cNvCxnSpPr/>
           <p:nvPr/>
         </p:nvCxnSpPr>
@@ -6536,7 +6627,7 @@
       </p:cxnSp>
       <p:cxnSp>
         <p:nvCxnSpPr>
-          <p:cNvPr id="44" name=""/>
+          <p:cNvPr id="62" name=""/>
           <p:cNvCxnSpPr/>
           <p:nvPr/>
         </p:nvCxnSpPr>
@@ -6622,6 +6713,7 @@
           <a:lstStyle xmlns:a="http://schemas.openxmlformats.org/drawingml/2006/main"/>
           <a:p xmlns:a="http://schemas.openxmlformats.org/drawingml/2006/main">
             <a:pPr algn="l">
+              <a:buNone/>
               <a:defRPr sz="1800" b="1">
                 <a:solidFill>
                   <a:srgbClr val="2478E5"/>
@@ -6680,6 +6772,7 @@
           <a:lstStyle xmlns:a="http://schemas.openxmlformats.org/drawingml/2006/main"/>
           <a:p xmlns:a="http://schemas.openxmlformats.org/drawingml/2006/main">
             <a:pPr algn="l">
+              <a:buNone/>
               <a:defRPr sz="1575" b="1">
                 <a:solidFill>
                   <a:srgbClr val="111111"/>
@@ -6738,6 +6831,7 @@
           <a:lstStyle xmlns:a="http://schemas.openxmlformats.org/drawingml/2006/main"/>
           <a:p xmlns:a="http://schemas.openxmlformats.org/drawingml/2006/main">
             <a:pPr algn="l">
+              <a:buNone/>
               <a:defRPr sz="1050" b="0">
                 <a:solidFill>
                   <a:srgbClr val="5C6570"/>
@@ -6827,6 +6921,7 @@
           <a:lstStyle xmlns:a="http://schemas.openxmlformats.org/drawingml/2006/main"/>
           <a:p xmlns:a="http://schemas.openxmlformats.org/drawingml/2006/main">
             <a:pPr algn="l">
+              <a:buNone/>
               <a:defRPr sz="1800" b="1">
                 <a:solidFill>
                   <a:srgbClr val="2478E5"/>
@@ -6885,6 +6980,7 @@
           <a:lstStyle xmlns:a="http://schemas.openxmlformats.org/drawingml/2006/main"/>
           <a:p xmlns:a="http://schemas.openxmlformats.org/drawingml/2006/main">
             <a:pPr algn="l">
+              <a:buNone/>
               <a:defRPr sz="1575" b="1">
                 <a:solidFill>
                   <a:srgbClr val="111111"/>
@@ -6943,6 +7039,7 @@
           <a:lstStyle xmlns:a="http://schemas.openxmlformats.org/drawingml/2006/main"/>
           <a:p xmlns:a="http://schemas.openxmlformats.org/drawingml/2006/main">
             <a:pPr algn="l">
+              <a:buNone/>
               <a:defRPr sz="1050" b="0">
                 <a:solidFill>
                   <a:srgbClr val="5C6570"/>
@@ -7032,6 +7129,7 @@
           <a:lstStyle xmlns:a="http://schemas.openxmlformats.org/drawingml/2006/main"/>
           <a:p xmlns:a="http://schemas.openxmlformats.org/drawingml/2006/main">
             <a:pPr algn="l">
+              <a:buNone/>
               <a:defRPr sz="1800" b="1">
                 <a:solidFill>
                   <a:srgbClr val="2478E5"/>
@@ -7090,6 +7188,7 @@
           <a:lstStyle xmlns:a="http://schemas.openxmlformats.org/drawingml/2006/main"/>
           <a:p xmlns:a="http://schemas.openxmlformats.org/drawingml/2006/main">
             <a:pPr algn="l">
+              <a:buNone/>
               <a:defRPr sz="1575" b="1">
                 <a:solidFill>
                   <a:srgbClr val="111111"/>
@@ -7148,6 +7247,7 @@
           <a:lstStyle xmlns:a="http://schemas.openxmlformats.org/drawingml/2006/main"/>
           <a:p xmlns:a="http://schemas.openxmlformats.org/drawingml/2006/main">
             <a:pPr algn="l">
+              <a:buNone/>
               <a:defRPr sz="1050" b="0">
                 <a:solidFill>
                   <a:srgbClr val="5C6570"/>
@@ -7237,6 +7337,7 @@
           <a:lstStyle xmlns:a="http://schemas.openxmlformats.org/drawingml/2006/main"/>
           <a:p xmlns:a="http://schemas.openxmlformats.org/drawingml/2006/main">
             <a:pPr algn="l">
+              <a:buNone/>
               <a:defRPr sz="1800" b="1">
                 <a:solidFill>
                   <a:srgbClr val="2478E5"/>
@@ -7295,6 +7396,7 @@
           <a:lstStyle xmlns:a="http://schemas.openxmlformats.org/drawingml/2006/main"/>
           <a:p xmlns:a="http://schemas.openxmlformats.org/drawingml/2006/main">
             <a:pPr algn="l">
+              <a:buNone/>
               <a:defRPr sz="1575" b="1">
                 <a:solidFill>
                   <a:srgbClr val="111111"/>
@@ -7353,6 +7455,7 @@
           <a:lstStyle xmlns:a="http://schemas.openxmlformats.org/drawingml/2006/main"/>
           <a:p xmlns:a="http://schemas.openxmlformats.org/drawingml/2006/main">
             <a:pPr algn="l">
+              <a:buNone/>
               <a:defRPr sz="1050" b="0">
                 <a:solidFill>
                   <a:srgbClr val="5C6570"/>
@@ -7442,6 +7545,7 @@
           <a:lstStyle xmlns:a="http://schemas.openxmlformats.org/drawingml/2006/main"/>
           <a:p xmlns:a="http://schemas.openxmlformats.org/drawingml/2006/main">
             <a:pPr algn="l">
+              <a:buNone/>
               <a:defRPr sz="1200" b="1">
                 <a:solidFill>
                   <a:srgbClr val="FFFFFF"/>
@@ -7500,6 +7604,7 @@
           <a:lstStyle xmlns:a="http://schemas.openxmlformats.org/drawingml/2006/main"/>
           <a:p xmlns:a="http://schemas.openxmlformats.org/drawingml/2006/main">
             <a:pPr algn="l">
+              <a:buNone/>
               <a:defRPr sz="1875" b="1">
                 <a:solidFill>
                   <a:srgbClr val="111111"/>
@@ -7589,6 +7694,7 @@
           <a:lstStyle xmlns:a="http://schemas.openxmlformats.org/drawingml/2006/main"/>
           <a:p xmlns:a="http://schemas.openxmlformats.org/drawingml/2006/main">
             <a:pPr algn="l">
+              <a:buNone/>
               <a:defRPr sz="1350" b="1">
                 <a:solidFill>
                   <a:srgbClr val="2478E5"/>
@@ -7647,6 +7753,7 @@
           <a:lstStyle xmlns:a="http://schemas.openxmlformats.org/drawingml/2006/main"/>
           <a:p xmlns:a="http://schemas.openxmlformats.org/drawingml/2006/main">
             <a:pPr algn="l">
+              <a:buNone/>
               <a:defRPr sz="1275" b="0">
                 <a:solidFill>
                   <a:srgbClr val="111111"/>
@@ -7736,6 +7843,7 @@
           <a:lstStyle xmlns:a="http://schemas.openxmlformats.org/drawingml/2006/main"/>
           <a:p xmlns:a="http://schemas.openxmlformats.org/drawingml/2006/main">
             <a:pPr algn="l">
+              <a:buNone/>
               <a:defRPr sz="1350" b="1">
                 <a:solidFill>
                   <a:srgbClr val="2478E5"/>
@@ -7794,6 +7902,7 @@
           <a:lstStyle xmlns:a="http://schemas.openxmlformats.org/drawingml/2006/main"/>
           <a:p xmlns:a="http://schemas.openxmlformats.org/drawingml/2006/main">
             <a:pPr algn="l">
+              <a:buNone/>
               <a:defRPr sz="1275" b="1">
                 <a:solidFill>
                   <a:srgbClr val="111111"/>
@@ -7883,6 +7992,7 @@
           <a:lstStyle xmlns:a="http://schemas.openxmlformats.org/drawingml/2006/main"/>
           <a:p xmlns:a="http://schemas.openxmlformats.org/drawingml/2006/main">
             <a:pPr algn="l">
+              <a:buNone/>
               <a:defRPr sz="1350" b="1">
                 <a:solidFill>
                   <a:srgbClr val="2478E5"/>
@@ -7941,6 +8051,7 @@
           <a:lstStyle xmlns:a="http://schemas.openxmlformats.org/drawingml/2006/main"/>
           <a:p xmlns:a="http://schemas.openxmlformats.org/drawingml/2006/main">
             <a:pPr algn="l">
+              <a:buNone/>
               <a:defRPr sz="1275" b="0">
                 <a:solidFill>
                   <a:srgbClr val="111111"/>
@@ -8030,6 +8141,7 @@
           <a:lstStyle xmlns:a="http://schemas.openxmlformats.org/drawingml/2006/main"/>
           <a:p xmlns:a="http://schemas.openxmlformats.org/drawingml/2006/main">
             <a:pPr algn="l">
+              <a:buNone/>
               <a:defRPr sz="1350" b="1">
                 <a:solidFill>
                   <a:srgbClr val="2478E5"/>
@@ -8088,6 +8200,7 @@
           <a:lstStyle xmlns:a="http://schemas.openxmlformats.org/drawingml/2006/main"/>
           <a:p xmlns:a="http://schemas.openxmlformats.org/drawingml/2006/main">
             <a:pPr algn="l">
+              <a:buNone/>
               <a:defRPr sz="1275" b="0">
                 <a:solidFill>
                   <a:srgbClr val="111111"/>
@@ -8146,6 +8259,7 @@
           <a:lstStyle xmlns:a="http://schemas.openxmlformats.org/drawingml/2006/main"/>
           <a:p xmlns:a="http://schemas.openxmlformats.org/drawingml/2006/main">
             <a:pPr algn="l">
+              <a:buNone/>
               <a:defRPr sz="1875" b="1">
                 <a:solidFill>
                   <a:srgbClr val="173B57"/>
@@ -8233,6 +8347,7 @@
           <a:lstStyle xmlns:a="http://schemas.openxmlformats.org/drawingml/2006/main"/>
           <a:p xmlns:a="http://schemas.openxmlformats.org/drawingml/2006/main">
             <a:pPr algn="l">
+              <a:buNone/>
               <a:defRPr sz="2850" b="1">
                 <a:solidFill>
                   <a:srgbClr val="111111"/>
@@ -8258,7 +8373,7 @@
       </p:sp>
       <p:cxnSp>
         <p:nvCxnSpPr>
-          <p:cNvPr id="67" name=""/>
+          <p:cNvPr id="73" name=""/>
           <p:cNvCxnSpPr/>
           <p:nvPr/>
         </p:nvCxnSpPr>
@@ -8313,6 +8428,7 @@
           <a:lstStyle xmlns:a="http://schemas.openxmlformats.org/drawingml/2006/main"/>
           <a:p xmlns:a="http://schemas.openxmlformats.org/drawingml/2006/main">
             <a:pPr algn="r">
+              <a:buNone/>
               <a:defRPr sz="900" b="0">
                 <a:solidFill>
                   <a:srgbClr val="5C6570"/>
@@ -8371,6 +8487,7 @@
           <a:lstStyle xmlns:a="http://schemas.openxmlformats.org/drawingml/2006/main"/>
           <a:p xmlns:a="http://schemas.openxmlformats.org/drawingml/2006/main">
             <a:pPr algn="l">
+              <a:buNone/>
               <a:defRPr sz="1350" b="0">
                 <a:solidFill>
                   <a:srgbClr val="5C6570"/>
@@ -8460,6 +8577,7 @@
           <a:lstStyle xmlns:a="http://schemas.openxmlformats.org/drawingml/2006/main"/>
           <a:p xmlns:a="http://schemas.openxmlformats.org/drawingml/2006/main">
             <a:pPr algn="l">
+              <a:buNone/>
               <a:defRPr sz="1125" b="1">
                 <a:solidFill>
                   <a:srgbClr val="FFFFFF"/>
@@ -8549,6 +8667,7 @@
           <a:lstStyle xmlns:a="http://schemas.openxmlformats.org/drawingml/2006/main"/>
           <a:p xmlns:a="http://schemas.openxmlformats.org/drawingml/2006/main">
             <a:pPr algn="ctr">
+              <a:buNone/>
               <a:defRPr sz="1200" b="1">
                 <a:solidFill>
                   <a:srgbClr val="111111"/>
@@ -8638,6 +8757,7 @@
           <a:lstStyle xmlns:a="http://schemas.openxmlformats.org/drawingml/2006/main"/>
           <a:p xmlns:a="http://schemas.openxmlformats.org/drawingml/2006/main">
             <a:pPr algn="ctr">
+              <a:buNone/>
               <a:defRPr sz="1200" b="1">
                 <a:solidFill>
                   <a:srgbClr val="111111"/>
@@ -8727,6 +8847,7 @@
           <a:lstStyle xmlns:a="http://schemas.openxmlformats.org/drawingml/2006/main"/>
           <a:p xmlns:a="http://schemas.openxmlformats.org/drawingml/2006/main">
             <a:pPr algn="ctr">
+              <a:buNone/>
               <a:defRPr sz="1200" b="1">
                 <a:solidFill>
                   <a:srgbClr val="111111"/>
@@ -8816,6 +8937,7 @@
           <a:lstStyle xmlns:a="http://schemas.openxmlformats.org/drawingml/2006/main"/>
           <a:p xmlns:a="http://schemas.openxmlformats.org/drawingml/2006/main">
             <a:pPr algn="ctr">
+              <a:buNone/>
               <a:defRPr sz="1200" b="1">
                 <a:solidFill>
                   <a:srgbClr val="111111"/>
@@ -8907,6 +9029,7 @@
           <a:lstStyle xmlns:a="http://schemas.openxmlformats.org/drawingml/2006/main"/>
           <a:p xmlns:a="http://schemas.openxmlformats.org/drawingml/2006/main">
             <a:pPr algn="l">
+              <a:buNone/>
               <a:defRPr sz="1275" b="1">
                 <a:solidFill>
                   <a:srgbClr val="111111"/>
@@ -8998,6 +9121,7 @@
           <a:lstStyle xmlns:a="http://schemas.openxmlformats.org/drawingml/2006/main"/>
           <a:p xmlns:a="http://schemas.openxmlformats.org/drawingml/2006/main">
             <a:pPr algn="ctr">
+              <a:buNone/>
               <a:defRPr sz="1125" b="0">
                 <a:solidFill>
                   <a:srgbClr val="111111"/>
@@ -9008,9 +9132,9 @@
               </a:defRPr>
             </a:pPr>
             <a:r>
-              <a:rPr sz="1125" b="0">
-                <a:solidFill>
-                  <a:srgbClr val="111111"/>
+              <a:rPr sz="1600" b="0">
+                <a:solidFill>
+                  <a:srgbClr val="151515"/>
                 </a:solidFill>
                 <a:latin typeface="Noto Sans TC"/>
                 <a:ea typeface="Noto Sans TC"/>
@@ -9021,6 +9145,7 @@
           </a:p>
           <a:p xmlns:a="http://schemas.openxmlformats.org/drawingml/2006/main">
             <a:pPr algn="ctr">
+              <a:buNone/>
               <a:defRPr sz="1125" b="0">
                 <a:solidFill>
                   <a:srgbClr val="111111"/>
@@ -9031,15 +9156,15 @@
               </a:defRPr>
             </a:pPr>
             <a:r>
-              <a:rPr sz="1125" b="0">
-                <a:solidFill>
-                  <a:srgbClr val="111111"/>
-                </a:solidFill>
-                <a:latin typeface="Noto Sans TC"/>
-                <a:ea typeface="Noto Sans TC"/>
-                <a:cs typeface="Noto Sans TC"/>
-              </a:rPr>
-              <a:t>→ Product / As-Is Brief</a:t>
+              <a:rPr sz="1600" b="0">
+                <a:solidFill>
+                  <a:srgbClr val="151515"/>
+                </a:solidFill>
+                <a:latin typeface="Noto Sans TC"/>
+                <a:ea typeface="Noto Sans TC"/>
+                <a:cs typeface="Noto Sans TC"/>
+              </a:rPr>
+              <a:t>→ As-Is Brief</a:t>
             </a:r>
           </a:p>
         </p:txBody>
@@ -9112,6 +9237,7 @@
           <a:lstStyle xmlns:a="http://schemas.openxmlformats.org/drawingml/2006/main"/>
           <a:p xmlns:a="http://schemas.openxmlformats.org/drawingml/2006/main">
             <a:pPr algn="ctr">
+              <a:buNone/>
               <a:defRPr sz="1125" b="0">
                 <a:solidFill>
                   <a:srgbClr val="111111"/>
@@ -9122,9 +9248,9 @@
               </a:defRPr>
             </a:pPr>
             <a:r>
-              <a:rPr sz="1125" b="0">
-                <a:solidFill>
-                  <a:srgbClr val="111111"/>
+              <a:rPr sz="1600" b="0">
+                <a:solidFill>
+                  <a:srgbClr val="151515"/>
                 </a:solidFill>
                 <a:latin typeface="Noto Sans TC"/>
                 <a:ea typeface="Noto Sans TC"/>
@@ -9135,6 +9261,7 @@
           </a:p>
           <a:p xmlns:a="http://schemas.openxmlformats.org/drawingml/2006/main">
             <a:pPr algn="ctr">
+              <a:buNone/>
               <a:defRPr sz="1125" b="0">
                 <a:solidFill>
                   <a:srgbClr val="111111"/>
@@ -9145,15 +9272,15 @@
               </a:defRPr>
             </a:pPr>
             <a:r>
-              <a:rPr sz="1125" b="0">
-                <a:solidFill>
-                  <a:srgbClr val="111111"/>
-                </a:solidFill>
-                <a:latin typeface="Noto Sans TC"/>
-                <a:ea typeface="Noto Sans TC"/>
-                <a:cs typeface="Noto Sans TC"/>
-              </a:rPr>
-              <a:t>→ Epic Brief / Impact Map</a:t>
+              <a:rPr sz="1600" b="0">
+                <a:solidFill>
+                  <a:srgbClr val="151515"/>
+                </a:solidFill>
+                <a:latin typeface="Noto Sans TC"/>
+                <a:ea typeface="Noto Sans TC"/>
+                <a:cs typeface="Noto Sans TC"/>
+              </a:rPr>
+              <a:t>→ Epic Brief</a:t>
             </a:r>
           </a:p>
         </p:txBody>
@@ -9226,6 +9353,7 @@
           <a:lstStyle xmlns:a="http://schemas.openxmlformats.org/drawingml/2006/main"/>
           <a:p xmlns:a="http://schemas.openxmlformats.org/drawingml/2006/main">
             <a:pPr algn="ctr">
+              <a:buNone/>
               <a:defRPr sz="1125" b="0">
                 <a:solidFill>
                   <a:srgbClr val="111111"/>
@@ -9236,19 +9364,20 @@
               </a:defRPr>
             </a:pPr>
             <a:r>
-              <a:rPr sz="1125" b="0">
-                <a:solidFill>
-                  <a:srgbClr val="111111"/>
-                </a:solidFill>
-                <a:latin typeface="Noto Sans TC"/>
-                <a:ea typeface="Noto Sans TC"/>
-                <a:cs typeface="Noto Sans TC"/>
-              </a:rPr>
-              <a:t>codebase-research</a:t>
+              <a:rPr sz="1600" b="0">
+                <a:solidFill>
+                  <a:srgbClr val="151515"/>
+                </a:solidFill>
+                <a:latin typeface="Noto Sans TC"/>
+                <a:ea typeface="Noto Sans TC"/>
+                <a:cs typeface="Noto Sans TC"/>
+              </a:rPr>
+              <a:t>codebase research</a:t>
             </a:r>
           </a:p>
           <a:p xmlns:a="http://schemas.openxmlformats.org/drawingml/2006/main">
             <a:pPr algn="ctr">
+              <a:buNone/>
               <a:defRPr sz="1125" b="0">
                 <a:solidFill>
                   <a:srgbClr val="111111"/>
@@ -9259,15 +9388,15 @@
               </a:defRPr>
             </a:pPr>
             <a:r>
-              <a:rPr sz="1125" b="0">
-                <a:solidFill>
-                  <a:srgbClr val="111111"/>
-                </a:solidFill>
-                <a:latin typeface="Noto Sans TC"/>
-                <a:ea typeface="Noto Sans TC"/>
-                <a:cs typeface="Noto Sans TC"/>
-              </a:rPr>
-              <a:t>→ Feature Research Brief</a:t>
+              <a:rPr sz="1600" b="0">
+                <a:solidFill>
+                  <a:srgbClr val="151515"/>
+                </a:solidFill>
+                <a:latin typeface="Noto Sans TC"/>
+                <a:ea typeface="Noto Sans TC"/>
+                <a:cs typeface="Noto Sans TC"/>
+              </a:rPr>
+              <a:t>→ Research Brief</a:t>
             </a:r>
           </a:p>
         </p:txBody>
@@ -9340,6 +9469,7 @@
           <a:lstStyle xmlns:a="http://schemas.openxmlformats.org/drawingml/2006/main"/>
           <a:p xmlns:a="http://schemas.openxmlformats.org/drawingml/2006/main">
             <a:pPr algn="ctr">
+              <a:buNone/>
               <a:defRPr sz="1125" b="0">
                 <a:solidFill>
                   <a:srgbClr val="111111"/>
@@ -9350,19 +9480,20 @@
               </a:defRPr>
             </a:pPr>
             <a:r>
-              <a:rPr sz="1125" b="0">
-                <a:solidFill>
-                  <a:srgbClr val="111111"/>
-                </a:solidFill>
-                <a:latin typeface="Noto Sans TC"/>
-                <a:ea typeface="Noto Sans TC"/>
-                <a:cs typeface="Noto Sans TC"/>
-              </a:rPr>
-              <a:t>targeted research / debug</a:t>
+              <a:rPr sz="1600" b="0">
+                <a:solidFill>
+                  <a:srgbClr val="151515"/>
+                </a:solidFill>
+                <a:latin typeface="Noto Sans TC"/>
+                <a:ea typeface="Noto Sans TC"/>
+                <a:cs typeface="Noto Sans TC"/>
+              </a:rPr>
+              <a:t>targeted research</a:t>
             </a:r>
           </a:p>
           <a:p xmlns:a="http://schemas.openxmlformats.org/drawingml/2006/main">
             <a:pPr algn="ctr">
+              <a:buNone/>
               <a:defRPr sz="1125" b="0">
                 <a:solidFill>
                   <a:srgbClr val="111111"/>
@@ -9373,15 +9504,15 @@
               </a:defRPr>
             </a:pPr>
             <a:r>
-              <a:rPr sz="1125" b="0">
-                <a:solidFill>
-                  <a:srgbClr val="111111"/>
-                </a:solidFill>
-                <a:latin typeface="Noto Sans TC"/>
-                <a:ea typeface="Noto Sans TC"/>
-                <a:cs typeface="Noto Sans TC"/>
-              </a:rPr>
-              <a:t>→ context or root cause</a:t>
+              <a:rPr sz="1600" b="0">
+                <a:solidFill>
+                  <a:srgbClr val="151515"/>
+                </a:solidFill>
+                <a:latin typeface="Noto Sans TC"/>
+                <a:ea typeface="Noto Sans TC"/>
+                <a:cs typeface="Noto Sans TC"/>
+              </a:rPr>
+              <a:t>→ context / root cause</a:t>
             </a:r>
           </a:p>
         </p:txBody>
@@ -9454,6 +9585,7 @@
           <a:lstStyle xmlns:a="http://schemas.openxmlformats.org/drawingml/2006/main"/>
           <a:p xmlns:a="http://schemas.openxmlformats.org/drawingml/2006/main">
             <a:pPr algn="l">
+              <a:buNone/>
               <a:defRPr sz="1275" b="1">
                 <a:solidFill>
                   <a:srgbClr val="111111"/>
@@ -9545,6 +9677,7 @@
           <a:lstStyle xmlns:a="http://schemas.openxmlformats.org/drawingml/2006/main"/>
           <a:p xmlns:a="http://schemas.openxmlformats.org/drawingml/2006/main">
             <a:pPr algn="ctr">
+              <a:buNone/>
               <a:defRPr sz="1125" b="0">
                 <a:solidFill>
                   <a:srgbClr val="111111"/>
@@ -9555,19 +9688,20 @@
               </a:defRPr>
             </a:pPr>
             <a:r>
-              <a:rPr sz="1125" b="0">
-                <a:solidFill>
-                  <a:srgbClr val="111111"/>
-                </a:solidFill>
-                <a:latin typeface="Noto Sans TC"/>
-                <a:ea typeface="Noto Sans TC"/>
-                <a:cs typeface="Noto Sans TC"/>
-              </a:rPr>
-              <a:t>system-design + grill</a:t>
+              <a:rPr sz="1600" b="0">
+                <a:solidFill>
+                  <a:srgbClr val="151515"/>
+                </a:solidFill>
+                <a:latin typeface="Noto Sans TC"/>
+                <a:ea typeface="Noto Sans TC"/>
+                <a:cs typeface="Noto Sans TC"/>
+              </a:rPr>
+              <a:t>system-design</a:t>
             </a:r>
           </a:p>
           <a:p xmlns:a="http://schemas.openxmlformats.org/drawingml/2006/main">
             <a:pPr algn="ctr">
+              <a:buNone/>
               <a:defRPr sz="1125" b="0">
                 <a:solidFill>
                   <a:srgbClr val="111111"/>
@@ -9578,15 +9712,15 @@
               </a:defRPr>
             </a:pPr>
             <a:r>
-              <a:rPr sz="1125" b="0">
-                <a:solidFill>
-                  <a:srgbClr val="111111"/>
-                </a:solidFill>
-                <a:latin typeface="Noto Sans TC"/>
-                <a:ea typeface="Noto Sans TC"/>
-                <a:cs typeface="Noto Sans TC"/>
-              </a:rPr>
-              <a:t>→ Product System Design</a:t>
+              <a:rPr sz="1600" b="0">
+                <a:solidFill>
+                  <a:srgbClr val="151515"/>
+                </a:solidFill>
+                <a:latin typeface="Noto Sans TC"/>
+                <a:ea typeface="Noto Sans TC"/>
+                <a:cs typeface="Noto Sans TC"/>
+              </a:rPr>
+              <a:t>→ Product Design</a:t>
             </a:r>
           </a:p>
         </p:txBody>
@@ -9659,6 +9793,7 @@
           <a:lstStyle xmlns:a="http://schemas.openxmlformats.org/drawingml/2006/main"/>
           <a:p xmlns:a="http://schemas.openxmlformats.org/drawingml/2006/main">
             <a:pPr algn="ctr">
+              <a:buNone/>
               <a:defRPr sz="1125" b="0">
                 <a:solidFill>
                   <a:srgbClr val="111111"/>
@@ -9669,19 +9804,20 @@
               </a:defRPr>
             </a:pPr>
             <a:r>
-              <a:rPr sz="1125" b="0">
-                <a:solidFill>
-                  <a:srgbClr val="111111"/>
-                </a:solidFill>
-                <a:latin typeface="Noto Sans TC"/>
-                <a:ea typeface="Noto Sans TC"/>
-                <a:cs typeface="Noto Sans TC"/>
-              </a:rPr>
-              <a:t>system-design + grill</a:t>
+              <a:rPr sz="1600" b="0">
+                <a:solidFill>
+                  <a:srgbClr val="151515"/>
+                </a:solidFill>
+                <a:latin typeface="Noto Sans TC"/>
+                <a:ea typeface="Noto Sans TC"/>
+                <a:cs typeface="Noto Sans TC"/>
+              </a:rPr>
+              <a:t>system-design</a:t>
             </a:r>
           </a:p>
           <a:p xmlns:a="http://schemas.openxmlformats.org/drawingml/2006/main">
             <a:pPr algn="ctr">
+              <a:buNone/>
               <a:defRPr sz="1125" b="0">
                 <a:solidFill>
                   <a:srgbClr val="111111"/>
@@ -9692,9 +9828,9 @@
               </a:defRPr>
             </a:pPr>
             <a:r>
-              <a:rPr sz="1125" b="0">
-                <a:solidFill>
-                  <a:srgbClr val="111111"/>
+              <a:rPr sz="1600" b="0">
+                <a:solidFill>
+                  <a:srgbClr val="151515"/>
                 </a:solidFill>
                 <a:latin typeface="Noto Sans TC"/>
                 <a:ea typeface="Noto Sans TC"/>
@@ -9773,6 +9909,7 @@
           <a:lstStyle xmlns:a="http://schemas.openxmlformats.org/drawingml/2006/main"/>
           <a:p xmlns:a="http://schemas.openxmlformats.org/drawingml/2006/main">
             <a:pPr algn="ctr">
+              <a:buNone/>
               <a:defRPr sz="1125" b="0">
                 <a:solidFill>
                   <a:srgbClr val="111111"/>
@@ -9783,19 +9920,20 @@
               </a:defRPr>
             </a:pPr>
             <a:r>
-              <a:rPr sz="1125" b="0">
-                <a:solidFill>
-                  <a:srgbClr val="111111"/>
-                </a:solidFill>
-                <a:latin typeface="Noto Sans TC"/>
-                <a:ea typeface="Noto Sans TC"/>
-                <a:cs typeface="Noto Sans TC"/>
-              </a:rPr>
-              <a:t>brainstorming + triggered SD</a:t>
+              <a:rPr sz="1600" b="0">
+                <a:solidFill>
+                  <a:srgbClr val="151515"/>
+                </a:solidFill>
+                <a:latin typeface="Noto Sans TC"/>
+                <a:ea typeface="Noto Sans TC"/>
+                <a:cs typeface="Noto Sans TC"/>
+              </a:rPr>
+              <a:t>brainstorming + SD*</a:t>
             </a:r>
           </a:p>
           <a:p xmlns:a="http://schemas.openxmlformats.org/drawingml/2006/main">
             <a:pPr algn="ctr">
+              <a:buNone/>
               <a:defRPr sz="1125" b="0">
                 <a:solidFill>
                   <a:srgbClr val="111111"/>
@@ -9806,15 +9944,15 @@
               </a:defRPr>
             </a:pPr>
             <a:r>
-              <a:rPr sz="1125" b="0">
-                <a:solidFill>
-                  <a:srgbClr val="111111"/>
-                </a:solidFill>
-                <a:latin typeface="Noto Sans TC"/>
-                <a:ea typeface="Noto Sans TC"/>
-                <a:cs typeface="Noto Sans TC"/>
-              </a:rPr>
-              <a:t>→ Approved Feature Design</a:t>
+              <a:rPr sz="1600" b="0">
+                <a:solidFill>
+                  <a:srgbClr val="151515"/>
+                </a:solidFill>
+                <a:latin typeface="Noto Sans TC"/>
+                <a:ea typeface="Noto Sans TC"/>
+                <a:cs typeface="Noto Sans TC"/>
+              </a:rPr>
+              <a:t>→ Feature Design</a:t>
             </a:r>
           </a:p>
         </p:txBody>
@@ -9887,6 +10025,7 @@
           <a:lstStyle xmlns:a="http://schemas.openxmlformats.org/drawingml/2006/main"/>
           <a:p xmlns:a="http://schemas.openxmlformats.org/drawingml/2006/main">
             <a:pPr algn="ctr">
+              <a:buNone/>
               <a:defRPr sz="1125" b="0">
                 <a:solidFill>
                   <a:srgbClr val="111111"/>
@@ -9897,9 +10036,9 @@
               </a:defRPr>
             </a:pPr>
             <a:r>
-              <a:rPr sz="1125" b="0">
-                <a:solidFill>
-                  <a:srgbClr val="111111"/>
+              <a:rPr sz="1600" b="0">
+                <a:solidFill>
+                  <a:srgbClr val="151515"/>
                 </a:solidFill>
                 <a:latin typeface="Noto Sans TC"/>
                 <a:ea typeface="Noto Sans TC"/>
@@ -9910,6 +10049,7 @@
           </a:p>
           <a:p xmlns:a="http://schemas.openxmlformats.org/drawingml/2006/main">
             <a:pPr algn="ctr">
+              <a:buNone/>
               <a:defRPr sz="1125" b="0">
                 <a:solidFill>
                   <a:srgbClr val="111111"/>
@@ -9920,15 +10060,15 @@
               </a:defRPr>
             </a:pPr>
             <a:r>
-              <a:rPr sz="1125" b="0">
-                <a:solidFill>
-                  <a:srgbClr val="111111"/>
-                </a:solidFill>
-                <a:latin typeface="Noto Sans TC"/>
-                <a:ea typeface="Noto Sans TC"/>
-                <a:cs typeface="Noto Sans TC"/>
-              </a:rPr>
-              <a:t>→ approach + test direction</a:t>
+              <a:rPr sz="1600" b="0">
+                <a:solidFill>
+                  <a:srgbClr val="151515"/>
+                </a:solidFill>
+                <a:latin typeface="Noto Sans TC"/>
+                <a:ea typeface="Noto Sans TC"/>
+                <a:cs typeface="Noto Sans TC"/>
+              </a:rPr>
+              <a:t>→ approach + tests</a:t>
             </a:r>
           </a:p>
         </p:txBody>
@@ -10001,6 +10141,7 @@
           <a:lstStyle xmlns:a="http://schemas.openxmlformats.org/drawingml/2006/main"/>
           <a:p xmlns:a="http://schemas.openxmlformats.org/drawingml/2006/main">
             <a:pPr algn="l">
+              <a:buNone/>
               <a:defRPr sz="1275" b="1">
                 <a:solidFill>
                   <a:srgbClr val="FFFFFF"/>
@@ -10092,6 +10233,7 @@
           <a:lstStyle xmlns:a="http://schemas.openxmlformats.org/drawingml/2006/main"/>
           <a:p xmlns:a="http://schemas.openxmlformats.org/drawingml/2006/main">
             <a:pPr algn="ctr">
+              <a:buNone/>
               <a:defRPr sz="1125" b="0">
                 <a:solidFill>
                   <a:srgbClr val="111111"/>
@@ -10102,19 +10244,20 @@
               </a:defRPr>
             </a:pPr>
             <a:r>
-              <a:rPr sz="1125" b="0">
-                <a:solidFill>
-                  <a:srgbClr val="111111"/>
-                </a:solidFill>
-                <a:latin typeface="Noto Sans TC"/>
-                <a:ea typeface="Noto Sans TC"/>
-                <a:cs typeface="Noto Sans TC"/>
-              </a:rPr>
-              <a:t>portfolio decomposition</a:t>
+              <a:rPr sz="1600" b="0">
+                <a:solidFill>
+                  <a:srgbClr val="151515"/>
+                </a:solidFill>
+                <a:latin typeface="Noto Sans TC"/>
+                <a:ea typeface="Noto Sans TC"/>
+                <a:cs typeface="Noto Sans TC"/>
+              </a:rPr>
+              <a:t>portfolio split</a:t>
             </a:r>
           </a:p>
           <a:p xmlns:a="http://schemas.openxmlformats.org/drawingml/2006/main">
             <a:pPr algn="ctr">
+              <a:buNone/>
               <a:defRPr sz="1125" b="0">
                 <a:solidFill>
                   <a:srgbClr val="111111"/>
@@ -10125,15 +10268,15 @@
               </a:defRPr>
             </a:pPr>
             <a:r>
-              <a:rPr sz="1125" b="0">
-                <a:solidFill>
-                  <a:srgbClr val="111111"/>
-                </a:solidFill>
-                <a:latin typeface="Noto Sans TC"/>
-                <a:ea typeface="Noto Sans TC"/>
-                <a:cs typeface="Noto Sans TC"/>
-              </a:rPr>
-              <a:t>→ Roadmap / Wave Map</a:t>
+              <a:rPr sz="1600" b="0">
+                <a:solidFill>
+                  <a:srgbClr val="151515"/>
+                </a:solidFill>
+                <a:latin typeface="Noto Sans TC"/>
+                <a:ea typeface="Noto Sans TC"/>
+                <a:cs typeface="Noto Sans TC"/>
+              </a:rPr>
+              <a:t>→ Roadmap / Waves</a:t>
             </a:r>
           </a:p>
         </p:txBody>
@@ -10206,6 +10349,7 @@
           <a:lstStyle xmlns:a="http://schemas.openxmlformats.org/drawingml/2006/main"/>
           <a:p xmlns:a="http://schemas.openxmlformats.org/drawingml/2006/main">
             <a:pPr algn="ctr">
+              <a:buNone/>
               <a:defRPr sz="1125" b="0">
                 <a:solidFill>
                   <a:srgbClr val="111111"/>
@@ -10216,19 +10360,20 @@
               </a:defRPr>
             </a:pPr>
             <a:r>
-              <a:rPr sz="1125" b="0">
-                <a:solidFill>
-                  <a:srgbClr val="111111"/>
-                </a:solidFill>
-                <a:latin typeface="Noto Sans TC"/>
-                <a:ea typeface="Noto Sans TC"/>
-                <a:cs typeface="Noto Sans TC"/>
-              </a:rPr>
-              <a:t>Feature decomposition</a:t>
+              <a:rPr sz="1600" b="0">
+                <a:solidFill>
+                  <a:srgbClr val="151515"/>
+                </a:solidFill>
+                <a:latin typeface="Noto Sans TC"/>
+                <a:ea typeface="Noto Sans TC"/>
+                <a:cs typeface="Noto Sans TC"/>
+              </a:rPr>
+              <a:t>feature split</a:t>
             </a:r>
           </a:p>
           <a:p xmlns:a="http://schemas.openxmlformats.org/drawingml/2006/main">
             <a:pPr algn="ctr">
+              <a:buNone/>
               <a:defRPr sz="1125" b="0">
                 <a:solidFill>
                   <a:srgbClr val="111111"/>
@@ -10239,15 +10384,15 @@
               </a:defRPr>
             </a:pPr>
             <a:r>
-              <a:rPr sz="1125" b="0">
-                <a:solidFill>
-                  <a:srgbClr val="111111"/>
-                </a:solidFill>
-                <a:latin typeface="Noto Sans TC"/>
-                <a:ea typeface="Noto Sans TC"/>
-                <a:cs typeface="Noto Sans TC"/>
-              </a:rPr>
-              <a:t>→ Feature backlog + deps</a:t>
+              <a:rPr sz="1600" b="0">
+                <a:solidFill>
+                  <a:srgbClr val="151515"/>
+                </a:solidFill>
+                <a:latin typeface="Noto Sans TC"/>
+                <a:ea typeface="Noto Sans TC"/>
+                <a:cs typeface="Noto Sans TC"/>
+              </a:rPr>
+              <a:t>→ backlog + deps</a:t>
             </a:r>
           </a:p>
         </p:txBody>
@@ -10320,6 +10465,7 @@
           <a:lstStyle xmlns:a="http://schemas.openxmlformats.org/drawingml/2006/main"/>
           <a:p xmlns:a="http://schemas.openxmlformats.org/drawingml/2006/main">
             <a:pPr algn="ctr">
+              <a:buNone/>
               <a:defRPr sz="1125" b="1">
                 <a:solidFill>
                   <a:srgbClr val="111111"/>
@@ -10330,9 +10476,9 @@
               </a:defRPr>
             </a:pPr>
             <a:r>
-              <a:rPr sz="1125" b="1">
-                <a:solidFill>
-                  <a:srgbClr val="111111"/>
+              <a:rPr sz="1600" b="1">
+                <a:solidFill>
+                  <a:srgbClr val="151515"/>
                 </a:solidFill>
                 <a:latin typeface="Noto Sans TC"/>
                 <a:ea typeface="Noto Sans TC"/>
@@ -10343,6 +10489,7 @@
           </a:p>
           <a:p xmlns:a="http://schemas.openxmlformats.org/drawingml/2006/main">
             <a:pPr algn="ctr">
+              <a:buNone/>
               <a:defRPr sz="1125" b="1">
                 <a:solidFill>
                   <a:srgbClr val="111111"/>
@@ -10353,15 +10500,15 @@
               </a:defRPr>
             </a:pPr>
             <a:r>
-              <a:rPr sz="1125" b="1">
-                <a:solidFill>
-                  <a:srgbClr val="111111"/>
-                </a:solidFill>
-                <a:latin typeface="Noto Sans TC"/>
-                <a:ea typeface="Noto Sans TC"/>
-                <a:cs typeface="Noto Sans TC"/>
-              </a:rPr>
-              <a:t>→ P0 slices + Blocked by</a:t>
+              <a:rPr sz="1600" b="1">
+                <a:solidFill>
+                  <a:srgbClr val="151515"/>
+                </a:solidFill>
+                <a:latin typeface="Noto Sans TC"/>
+                <a:ea typeface="Noto Sans TC"/>
+                <a:cs typeface="Noto Sans TC"/>
+              </a:rPr>
+              <a:t>→ P0 + Blocked by</a:t>
             </a:r>
           </a:p>
         </p:txBody>
@@ -10434,6 +10581,7 @@
           <a:lstStyle xmlns:a="http://schemas.openxmlformats.org/drawingml/2006/main"/>
           <a:p xmlns:a="http://schemas.openxmlformats.org/drawingml/2006/main">
             <a:pPr algn="ctr">
+              <a:buNone/>
               <a:defRPr sz="1125" b="0">
                 <a:solidFill>
                   <a:srgbClr val="111111"/>
@@ -10444,19 +10592,20 @@
               </a:defRPr>
             </a:pPr>
             <a:r>
-              <a:rPr sz="1125" b="0">
-                <a:solidFill>
-                  <a:srgbClr val="111111"/>
-                </a:solidFill>
-                <a:latin typeface="Noto Sans TC"/>
-                <a:ea typeface="Noto Sans TC"/>
-                <a:cs typeface="Noto Sans TC"/>
-              </a:rPr>
-              <a:t>inline / writing-plans JIT</a:t>
+              <a:rPr sz="1600" b="0">
+                <a:solidFill>
+                  <a:srgbClr val="151515"/>
+                </a:solidFill>
+                <a:latin typeface="Noto Sans TC"/>
+                <a:ea typeface="Noto Sans TC"/>
+                <a:cs typeface="Noto Sans TC"/>
+              </a:rPr>
+              <a:t>writing-plans JIT</a:t>
             </a:r>
           </a:p>
           <a:p xmlns:a="http://schemas.openxmlformats.org/drawingml/2006/main">
             <a:pPr algn="ctr">
+              <a:buNone/>
               <a:defRPr sz="1125" b="0">
                 <a:solidFill>
                   <a:srgbClr val="111111"/>
@@ -10467,15 +10616,15 @@
               </a:defRPr>
             </a:pPr>
             <a:r>
-              <a:rPr sz="1125" b="0">
-                <a:solidFill>
-                  <a:srgbClr val="111111"/>
-                </a:solidFill>
-                <a:latin typeface="Noto Sans TC"/>
-                <a:ea typeface="Noto Sans TC"/>
-                <a:cs typeface="Noto Sans TC"/>
-              </a:rPr>
-              <a:t>→ tasks + files + tests</a:t>
+              <a:rPr sz="1600" b="0">
+                <a:solidFill>
+                  <a:srgbClr val="151515"/>
+                </a:solidFill>
+                <a:latin typeface="Noto Sans TC"/>
+                <a:ea typeface="Noto Sans TC"/>
+                <a:cs typeface="Noto Sans TC"/>
+              </a:rPr>
+              <a:t>→ files + tests</a:t>
             </a:r>
           </a:p>
         </p:txBody>
@@ -10548,6 +10697,7 @@
           <a:lstStyle xmlns:a="http://schemas.openxmlformats.org/drawingml/2006/main"/>
           <a:p xmlns:a="http://schemas.openxmlformats.org/drawingml/2006/main">
             <a:pPr algn="l">
+              <a:buNone/>
               <a:defRPr sz="1275" b="1">
                 <a:solidFill>
                   <a:srgbClr val="111111"/>
@@ -10639,6 +10789,7 @@
           <a:lstStyle xmlns:a="http://schemas.openxmlformats.org/drawingml/2006/main"/>
           <a:p xmlns:a="http://schemas.openxmlformats.org/drawingml/2006/main">
             <a:pPr algn="ctr">
+              <a:buNone/>
               <a:defRPr sz="1125" b="0">
                 <a:solidFill>
                   <a:srgbClr val="111111"/>
@@ -10649,9 +10800,9 @@
               </a:defRPr>
             </a:pPr>
             <a:r>
-              <a:rPr sz="1125" b="0">
-                <a:solidFill>
-                  <a:srgbClr val="111111"/>
+              <a:rPr sz="1600" b="0">
+                <a:solidFill>
+                  <a:srgbClr val="151515"/>
                 </a:solidFill>
                 <a:latin typeface="Noto Sans TC"/>
                 <a:ea typeface="Noto Sans TC"/>
@@ -10662,6 +10813,7 @@
           </a:p>
           <a:p xmlns:a="http://schemas.openxmlformats.org/drawingml/2006/main">
             <a:pPr algn="ctr">
+              <a:buNone/>
               <a:defRPr sz="1125" b="0">
                 <a:solidFill>
                   <a:srgbClr val="111111"/>
@@ -10672,15 +10824,15 @@
               </a:defRPr>
             </a:pPr>
             <a:r>
-              <a:rPr sz="1125" b="0">
-                <a:solidFill>
-                  <a:srgbClr val="111111"/>
-                </a:solidFill>
-                <a:latin typeface="Noto Sans TC"/>
-                <a:ea typeface="Noto Sans TC"/>
-                <a:cs typeface="Noto Sans TC"/>
-              </a:rPr>
-              <a:t>→ working increments</a:t>
+              <a:rPr sz="1600" b="0">
+                <a:solidFill>
+                  <a:srgbClr val="151515"/>
+                </a:solidFill>
+                <a:latin typeface="Noto Sans TC"/>
+                <a:ea typeface="Noto Sans TC"/>
+                <a:cs typeface="Noto Sans TC"/>
+              </a:rPr>
+              <a:t>→ increments</a:t>
             </a:r>
           </a:p>
         </p:txBody>
@@ -10753,6 +10905,7 @@
           <a:lstStyle xmlns:a="http://schemas.openxmlformats.org/drawingml/2006/main"/>
           <a:p xmlns:a="http://schemas.openxmlformats.org/drawingml/2006/main">
             <a:pPr algn="ctr">
+              <a:buNone/>
               <a:defRPr sz="1125" b="0">
                 <a:solidFill>
                   <a:srgbClr val="111111"/>
@@ -10763,9 +10916,9 @@
               </a:defRPr>
             </a:pPr>
             <a:r>
-              <a:rPr sz="1125" b="0">
-                <a:solidFill>
-                  <a:srgbClr val="111111"/>
+              <a:rPr sz="1600" b="0">
+                <a:solidFill>
+                  <a:srgbClr val="151515"/>
                 </a:solidFill>
                 <a:latin typeface="Noto Sans TC"/>
                 <a:ea typeface="Noto Sans TC"/>
@@ -10776,6 +10929,7 @@
           </a:p>
           <a:p xmlns:a="http://schemas.openxmlformats.org/drawingml/2006/main">
             <a:pPr algn="ctr">
+              <a:buNone/>
               <a:defRPr sz="1125" b="0">
                 <a:solidFill>
                   <a:srgbClr val="111111"/>
@@ -10786,15 +10940,15 @@
               </a:defRPr>
             </a:pPr>
             <a:r>
-              <a:rPr sz="1125" b="0">
-                <a:solidFill>
-                  <a:srgbClr val="111111"/>
-                </a:solidFill>
-                <a:latin typeface="Noto Sans TC"/>
-                <a:ea typeface="Noto Sans TC"/>
-                <a:cs typeface="Noto Sans TC"/>
-              </a:rPr>
-              <a:t>→ feature increments</a:t>
+              <a:rPr sz="1600" b="0">
+                <a:solidFill>
+                  <a:srgbClr val="151515"/>
+                </a:solidFill>
+                <a:latin typeface="Noto Sans TC"/>
+                <a:ea typeface="Noto Sans TC"/>
+                <a:cs typeface="Noto Sans TC"/>
+              </a:rPr>
+              <a:t>→ increments</a:t>
             </a:r>
           </a:p>
         </p:txBody>
@@ -10867,6 +11021,7 @@
           <a:lstStyle xmlns:a="http://schemas.openxmlformats.org/drawingml/2006/main"/>
           <a:p xmlns:a="http://schemas.openxmlformats.org/drawingml/2006/main">
             <a:pPr algn="ctr">
+              <a:buNone/>
               <a:defRPr sz="1125" b="0">
                 <a:solidFill>
                   <a:srgbClr val="111111"/>
@@ -10877,19 +11032,20 @@
               </a:defRPr>
             </a:pPr>
             <a:r>
-              <a:rPr sz="1125" b="0">
-                <a:solidFill>
-                  <a:srgbClr val="111111"/>
-                </a:solidFill>
-                <a:latin typeface="Noto Sans TC"/>
-                <a:ea typeface="Noto Sans TC"/>
-                <a:cs typeface="Noto Sans TC"/>
-              </a:rPr>
-              <a:t>execute frontier P0s</a:t>
+              <a:rPr sz="1600" b="0">
+                <a:solidFill>
+                  <a:srgbClr val="151515"/>
+                </a:solidFill>
+                <a:latin typeface="Noto Sans TC"/>
+                <a:ea typeface="Noto Sans TC"/>
+                <a:cs typeface="Noto Sans TC"/>
+              </a:rPr>
+              <a:t>frontier P0s</a:t>
             </a:r>
           </a:p>
           <a:p xmlns:a="http://schemas.openxmlformats.org/drawingml/2006/main">
             <a:pPr algn="ctr">
+              <a:buNone/>
               <a:defRPr sz="1125" b="0">
                 <a:solidFill>
                   <a:srgbClr val="111111"/>
@@ -10900,9 +11056,9 @@
               </a:defRPr>
             </a:pPr>
             <a:r>
-              <a:rPr sz="1125" b="0">
-                <a:solidFill>
-                  <a:srgbClr val="111111"/>
+              <a:rPr sz="1600" b="0">
+                <a:solidFill>
+                  <a:srgbClr val="151515"/>
                 </a:solidFill>
                 <a:latin typeface="Noto Sans TC"/>
                 <a:ea typeface="Noto Sans TC"/>
@@ -10981,6 +11137,7 @@
           <a:lstStyle xmlns:a="http://schemas.openxmlformats.org/drawingml/2006/main"/>
           <a:p xmlns:a="http://schemas.openxmlformats.org/drawingml/2006/main">
             <a:pPr algn="ctr">
+              <a:buNone/>
               <a:defRPr sz="1125" b="0">
                 <a:solidFill>
                   <a:srgbClr val="111111"/>
@@ -10991,19 +11148,20 @@
               </a:defRPr>
             </a:pPr>
             <a:r>
-              <a:rPr sz="1125" b="0">
-                <a:solidFill>
-                  <a:srgbClr val="111111"/>
-                </a:solidFill>
-                <a:latin typeface="Noto Sans TC"/>
-                <a:ea typeface="Noto Sans TC"/>
-                <a:cs typeface="Noto Sans TC"/>
-              </a:rPr>
-              <a:t>TDD + bounded execution</a:t>
+              <a:rPr sz="1600" b="0">
+                <a:solidFill>
+                  <a:srgbClr val="151515"/>
+                </a:solidFill>
+                <a:latin typeface="Noto Sans TC"/>
+                <a:ea typeface="Noto Sans TC"/>
+                <a:cs typeface="Noto Sans TC"/>
+              </a:rPr>
+              <a:t>TDD execution</a:t>
             </a:r>
           </a:p>
           <a:p xmlns:a="http://schemas.openxmlformats.org/drawingml/2006/main">
             <a:pPr algn="ctr">
+              <a:buNone/>
               <a:defRPr sz="1125" b="0">
                 <a:solidFill>
                   <a:srgbClr val="111111"/>
@@ -11014,9 +11172,9 @@
               </a:defRPr>
             </a:pPr>
             <a:r>
-              <a:rPr sz="1125" b="0">
-                <a:solidFill>
-                  <a:srgbClr val="111111"/>
+              <a:rPr sz="1600" b="0">
+                <a:solidFill>
+                  <a:srgbClr val="151515"/>
                 </a:solidFill>
                 <a:latin typeface="Noto Sans TC"/>
                 <a:ea typeface="Noto Sans TC"/>
@@ -11095,6 +11253,7 @@
           <a:lstStyle xmlns:a="http://schemas.openxmlformats.org/drawingml/2006/main"/>
           <a:p xmlns:a="http://schemas.openxmlformats.org/drawingml/2006/main">
             <a:pPr algn="l">
+              <a:buNone/>
               <a:defRPr sz="1275" b="1">
                 <a:solidFill>
                   <a:srgbClr val="111111"/>
@@ -11186,6 +11345,7 @@
           <a:lstStyle xmlns:a="http://schemas.openxmlformats.org/drawingml/2006/main"/>
           <a:p xmlns:a="http://schemas.openxmlformats.org/drawingml/2006/main">
             <a:pPr algn="ctr">
+              <a:buNone/>
               <a:defRPr sz="1125" b="0">
                 <a:solidFill>
                   <a:srgbClr val="111111"/>
@@ -11196,19 +11356,20 @@
               </a:defRPr>
             </a:pPr>
             <a:r>
-              <a:rPr sz="1125" b="0">
-                <a:solidFill>
-                  <a:srgbClr val="111111"/>
-                </a:solidFill>
-                <a:latin typeface="Noto Sans TC"/>
-                <a:ea typeface="Noto Sans TC"/>
-                <a:cs typeface="Noto Sans TC"/>
-              </a:rPr>
-              <a:t>outcome / NFR / cutover</a:t>
+              <a:rPr sz="1600" b="0">
+                <a:solidFill>
+                  <a:srgbClr val="151515"/>
+                </a:solidFill>
+                <a:latin typeface="Noto Sans TC"/>
+                <a:ea typeface="Noto Sans TC"/>
+                <a:cs typeface="Noto Sans TC"/>
+              </a:rPr>
+              <a:t>outcome + NFR</a:t>
             </a:r>
           </a:p>
           <a:p xmlns:a="http://schemas.openxmlformats.org/drawingml/2006/main">
             <a:pPr algn="ctr">
+              <a:buNone/>
               <a:defRPr sz="1125" b="0">
                 <a:solidFill>
                   <a:srgbClr val="111111"/>
@@ -11219,9 +11380,9 @@
               </a:defRPr>
             </a:pPr>
             <a:r>
-              <a:rPr sz="1125" b="0">
-                <a:solidFill>
-                  <a:srgbClr val="111111"/>
+              <a:rPr sz="1600" b="0">
+                <a:solidFill>
+                  <a:srgbClr val="151515"/>
                 </a:solidFill>
                 <a:latin typeface="Noto Sans TC"/>
                 <a:ea typeface="Noto Sans TC"/>
@@ -11300,6 +11461,7 @@
           <a:lstStyle xmlns:a="http://schemas.openxmlformats.org/drawingml/2006/main"/>
           <a:p xmlns:a="http://schemas.openxmlformats.org/drawingml/2006/main">
             <a:pPr algn="ctr">
+              <a:buNone/>
               <a:defRPr sz="1125" b="0">
                 <a:solidFill>
                   <a:srgbClr val="111111"/>
@@ -11310,19 +11472,20 @@
               </a:defRPr>
             </a:pPr>
             <a:r>
-              <a:rPr sz="1125" b="0">
-                <a:solidFill>
-                  <a:srgbClr val="111111"/>
-                </a:solidFill>
-                <a:latin typeface="Noto Sans TC"/>
-                <a:ea typeface="Noto Sans TC"/>
-                <a:cs typeface="Noto Sans TC"/>
-              </a:rPr>
-              <a:t>E2E / contract / rollout</a:t>
+              <a:rPr sz="1600" b="0">
+                <a:solidFill>
+                  <a:srgbClr val="151515"/>
+                </a:solidFill>
+                <a:latin typeface="Noto Sans TC"/>
+                <a:ea typeface="Noto Sans TC"/>
+                <a:cs typeface="Noto Sans TC"/>
+              </a:rPr>
+              <a:t>E2E + rollout</a:t>
             </a:r>
           </a:p>
           <a:p xmlns:a="http://schemas.openxmlformats.org/drawingml/2006/main">
             <a:pPr algn="ctr">
+              <a:buNone/>
               <a:defRPr sz="1125" b="0">
                 <a:solidFill>
                   <a:srgbClr val="111111"/>
@@ -11333,9 +11496,9 @@
               </a:defRPr>
             </a:pPr>
             <a:r>
-              <a:rPr sz="1125" b="0">
-                <a:solidFill>
-                  <a:srgbClr val="111111"/>
+              <a:rPr sz="1600" b="0">
+                <a:solidFill>
+                  <a:srgbClr val="151515"/>
                 </a:solidFill>
                 <a:latin typeface="Noto Sans TC"/>
                 <a:ea typeface="Noto Sans TC"/>
@@ -11414,6 +11577,7 @@
           <a:lstStyle xmlns:a="http://schemas.openxmlformats.org/drawingml/2006/main"/>
           <a:p xmlns:a="http://schemas.openxmlformats.org/drawingml/2006/main">
             <a:pPr algn="ctr">
+              <a:buNone/>
               <a:defRPr sz="1125" b="0">
                 <a:solidFill>
                   <a:srgbClr val="111111"/>
@@ -11424,9 +11588,9 @@
               </a:defRPr>
             </a:pPr>
             <a:r>
-              <a:rPr sz="1125" b="0">
-                <a:solidFill>
-                  <a:srgbClr val="111111"/>
+              <a:rPr sz="1600" b="0">
+                <a:solidFill>
+                  <a:srgbClr val="151515"/>
                 </a:solidFill>
                 <a:latin typeface="Noto Sans TC"/>
                 <a:ea typeface="Noto Sans TC"/>
@@ -11437,6 +11601,7 @@
           </a:p>
           <a:p xmlns:a="http://schemas.openxmlformats.org/drawingml/2006/main">
             <a:pPr algn="ctr">
+              <a:buNone/>
               <a:defRPr sz="1125" b="0">
                 <a:solidFill>
                   <a:srgbClr val="111111"/>
@@ -11447,15 +11612,15 @@
               </a:defRPr>
             </a:pPr>
             <a:r>
-              <a:rPr sz="1125" b="0">
-                <a:solidFill>
-                  <a:srgbClr val="111111"/>
-                </a:solidFill>
-                <a:latin typeface="Noto Sans TC"/>
-                <a:ea typeface="Noto Sans TC"/>
-                <a:cs typeface="Noto Sans TC"/>
-              </a:rPr>
-              <a:t>→ Feature validation</a:t>
+              <a:rPr sz="1600" b="0">
+                <a:solidFill>
+                  <a:srgbClr val="151515"/>
+                </a:solidFill>
+                <a:latin typeface="Noto Sans TC"/>
+                <a:ea typeface="Noto Sans TC"/>
+                <a:cs typeface="Noto Sans TC"/>
+              </a:rPr>
+              <a:t>→ Feature evidence</a:t>
             </a:r>
           </a:p>
         </p:txBody>
@@ -11528,6 +11693,7 @@
           <a:lstStyle xmlns:a="http://schemas.openxmlformats.org/drawingml/2006/main"/>
           <a:p xmlns:a="http://schemas.openxmlformats.org/drawingml/2006/main">
             <a:pPr algn="ctr">
+              <a:buNone/>
               <a:defRPr sz="1125" b="0">
                 <a:solidFill>
                   <a:srgbClr val="111111"/>
@@ -11538,19 +11704,20 @@
               </a:defRPr>
             </a:pPr>
             <a:r>
-              <a:rPr sz="1125" b="0">
-                <a:solidFill>
-                  <a:srgbClr val="111111"/>
-                </a:solidFill>
-                <a:latin typeface="Noto Sans TC"/>
-                <a:ea typeface="Noto Sans TC"/>
-                <a:cs typeface="Noto Sans TC"/>
-              </a:rPr>
-              <a:t>review + fresh verify</a:t>
+              <a:rPr sz="1600" b="0">
+                <a:solidFill>
+                  <a:srgbClr val="151515"/>
+                </a:solidFill>
+                <a:latin typeface="Noto Sans TC"/>
+                <a:ea typeface="Noto Sans TC"/>
+                <a:cs typeface="Noto Sans TC"/>
+              </a:rPr>
+              <a:t>review + verify</a:t>
             </a:r>
           </a:p>
           <a:p xmlns:a="http://schemas.openxmlformats.org/drawingml/2006/main">
             <a:pPr algn="ctr">
+              <a:buNone/>
               <a:defRPr sz="1125" b="0">
                 <a:solidFill>
                   <a:srgbClr val="111111"/>
@@ -11561,9 +11728,9 @@
               </a:defRPr>
             </a:pPr>
             <a:r>
-              <a:rPr sz="1125" b="0">
-                <a:solidFill>
-                  <a:srgbClr val="111111"/>
+              <a:rPr sz="1600" b="0">
+                <a:solidFill>
+                  <a:srgbClr val="151515"/>
                 </a:solidFill>
                 <a:latin typeface="Noto Sans TC"/>
                 <a:ea typeface="Noto Sans TC"/>
@@ -11590,8 +11757,8 @@
         </p:nvSpPr>
         <p:spPr>
           <a:xfrm xmlns:a="http://schemas.openxmlformats.org/drawingml/2006/main">
-            <a:off x="400050" y="6057900"/>
-            <a:ext cx="9525000" cy="209550"/>
+            <a:off x="400050" y="6038850"/>
+            <a:ext cx="9525000" cy="247650"/>
           </a:xfrm>
           <a:prstGeom xmlns:a="http://schemas.openxmlformats.org/drawingml/2006/main" prst="rect">
             <a:avLst/>
@@ -11609,6 +11776,7 @@
           <a:lstStyle xmlns:a="http://schemas.openxmlformats.org/drawingml/2006/main"/>
           <a:p xmlns:a="http://schemas.openxmlformats.org/drawingml/2006/main">
             <a:pPr algn="l">
+              <a:buNone/>
               <a:defRPr sz="1050" b="0">
                 <a:solidFill>
                   <a:srgbClr val="5C6570"/>
@@ -11619,15 +11787,15 @@
               </a:defRPr>
             </a:pPr>
             <a:r>
-              <a:rPr sz="1050" b="0">
-                <a:solidFill>
-                  <a:srgbClr val="5C6570"/>
-                </a:solidFill>
-                <a:latin typeface="Noto Sans TC"/>
-                <a:ea typeface="Noto Sans TC"/>
-                <a:cs typeface="Noto Sans TC"/>
-              </a:rPr>
-              <a:t>Output 可以存在既有 ticket、OpenSpec、ADR、PR 或 test report；不要求新增文件。</a:t>
+              <a:rPr sz="1600" b="0">
+                <a:solidFill>
+                  <a:srgbClr val="606B7A"/>
+                </a:solidFill>
+                <a:latin typeface="Noto Sans TC"/>
+                <a:ea typeface="Noto Sans TC"/>
+                <a:cs typeface="Noto Sans TC"/>
+              </a:rPr>
+              <a:t>Output 留在既有 ticket、OpenSpec、ADR、PR 或 test report；不新增文件。</a:t>
             </a:r>
           </a:p>
         </p:txBody>
@@ -11696,6 +11864,7 @@
           <a:lstStyle xmlns:a="http://schemas.openxmlformats.org/drawingml/2006/main"/>
           <a:p xmlns:a="http://schemas.openxmlformats.org/drawingml/2006/main">
             <a:pPr algn="l">
+              <a:buNone/>
               <a:defRPr sz="2850" b="1">
                 <a:solidFill>
                   <a:srgbClr val="111111"/>
@@ -11721,7 +11890,7 @@
       </p:sp>
       <p:cxnSp>
         <p:nvCxnSpPr>
-          <p:cNvPr id="28" name=""/>
+          <p:cNvPr id="49" name=""/>
           <p:cNvCxnSpPr/>
           <p:nvPr/>
         </p:nvCxnSpPr>
@@ -11776,6 +11945,7 @@
           <a:lstStyle xmlns:a="http://schemas.openxmlformats.org/drawingml/2006/main"/>
           <a:p xmlns:a="http://schemas.openxmlformats.org/drawingml/2006/main">
             <a:pPr algn="r">
+              <a:buNone/>
               <a:defRPr sz="900" b="0">
                 <a:solidFill>
                   <a:srgbClr val="5C6570"/>
@@ -11801,7 +11971,7 @@
       </p:sp>
       <p:cxnSp>
         <p:nvCxnSpPr>
-          <p:cNvPr id="30" name=""/>
+          <p:cNvPr id="51" name=""/>
           <p:cNvCxnSpPr/>
           <p:nvPr/>
         </p:nvCxnSpPr>
@@ -11823,7 +11993,7 @@
       </p:cxnSp>
       <p:cxnSp>
         <p:nvCxnSpPr>
-          <p:cNvPr id="31" name=""/>
+          <p:cNvPr id="52" name=""/>
           <p:cNvCxnSpPr/>
           <p:nvPr/>
         </p:nvCxnSpPr>
@@ -11845,7 +12015,7 @@
       </p:cxnSp>
       <p:cxnSp>
         <p:nvCxnSpPr>
-          <p:cNvPr id="32" name=""/>
+          <p:cNvPr id="53" name=""/>
           <p:cNvCxnSpPr/>
           <p:nvPr/>
         </p:nvCxnSpPr>
@@ -11867,7 +12037,7 @@
       </p:cxnSp>
       <p:cxnSp>
         <p:nvCxnSpPr>
-          <p:cNvPr id="33" name=""/>
+          <p:cNvPr id="54" name=""/>
           <p:cNvCxnSpPr/>
           <p:nvPr/>
         </p:nvCxnSpPr>
@@ -11953,6 +12123,7 @@
           <a:lstStyle xmlns:a="http://schemas.openxmlformats.org/drawingml/2006/main"/>
           <a:p xmlns:a="http://schemas.openxmlformats.org/drawingml/2006/main">
             <a:pPr algn="ctr">
+              <a:buNone/>
               <a:defRPr sz="1425" b="1">
                 <a:solidFill>
                   <a:srgbClr val="111111"/>
@@ -11976,6 +12147,7 @@
           </a:p>
           <a:p xmlns:a="http://schemas.openxmlformats.org/drawingml/2006/main">
             <a:pPr algn="ctr">
+              <a:buNone/>
               <a:defRPr sz="1425" b="1">
                 <a:solidFill>
                   <a:srgbClr val="111111"/>
@@ -12065,6 +12237,7 @@
           <a:lstStyle xmlns:a="http://schemas.openxmlformats.org/drawingml/2006/main"/>
           <a:p xmlns:a="http://schemas.openxmlformats.org/drawingml/2006/main">
             <a:pPr algn="ctr">
+              <a:buNone/>
               <a:defRPr sz="1425" b="1">
                 <a:solidFill>
                   <a:srgbClr val="111111"/>
@@ -12154,6 +12327,7 @@
           <a:lstStyle xmlns:a="http://schemas.openxmlformats.org/drawingml/2006/main"/>
           <a:p xmlns:a="http://schemas.openxmlformats.org/drawingml/2006/main">
             <a:pPr algn="ctr">
+              <a:buNone/>
               <a:defRPr sz="1425" b="1">
                 <a:solidFill>
                   <a:srgbClr val="111111"/>
@@ -12177,6 +12351,7 @@
           </a:p>
           <a:p xmlns:a="http://schemas.openxmlformats.org/drawingml/2006/main">
             <a:pPr algn="ctr">
+              <a:buNone/>
               <a:defRPr sz="1425" b="1">
                 <a:solidFill>
                   <a:srgbClr val="111111"/>
@@ -12266,6 +12441,7 @@
           <a:lstStyle xmlns:a="http://schemas.openxmlformats.org/drawingml/2006/main"/>
           <a:p xmlns:a="http://schemas.openxmlformats.org/drawingml/2006/main">
             <a:pPr algn="ctr">
+              <a:buNone/>
               <a:defRPr sz="1425" b="1">
                 <a:solidFill>
                   <a:srgbClr val="111111"/>
@@ -12355,6 +12531,7 @@
           <a:lstStyle xmlns:a="http://schemas.openxmlformats.org/drawingml/2006/main"/>
           <a:p xmlns:a="http://schemas.openxmlformats.org/drawingml/2006/main">
             <a:pPr algn="ctr">
+              <a:buNone/>
               <a:defRPr sz="1425" b="1">
                 <a:solidFill>
                   <a:srgbClr val="111111"/>
@@ -12378,6 +12555,7 @@
           </a:p>
           <a:p xmlns:a="http://schemas.openxmlformats.org/drawingml/2006/main">
             <a:pPr algn="ctr">
+              <a:buNone/>
               <a:defRPr sz="1425" b="1">
                 <a:solidFill>
                   <a:srgbClr val="111111"/>
@@ -12467,6 +12645,7 @@
           <a:lstStyle xmlns:a="http://schemas.openxmlformats.org/drawingml/2006/main"/>
           <a:p xmlns:a="http://schemas.openxmlformats.org/drawingml/2006/main">
             <a:pPr algn="l">
+              <a:buNone/>
               <a:defRPr sz="975" b="1">
                 <a:solidFill>
                   <a:srgbClr val="FFFFFF"/>
@@ -12525,6 +12704,7 @@
           <a:lstStyle xmlns:a="http://schemas.openxmlformats.org/drawingml/2006/main"/>
           <a:p xmlns:a="http://schemas.openxmlformats.org/drawingml/2006/main">
             <a:pPr algn="l">
+              <a:buNone/>
               <a:defRPr sz="1350" b="0">
                 <a:solidFill>
                   <a:srgbClr val="111111"/>
@@ -12614,6 +12794,7 @@
           <a:lstStyle xmlns:a="http://schemas.openxmlformats.org/drawingml/2006/main"/>
           <a:p xmlns:a="http://schemas.openxmlformats.org/drawingml/2006/main">
             <a:pPr algn="l">
+              <a:buNone/>
               <a:defRPr sz="975" b="1">
                 <a:solidFill>
                   <a:srgbClr val="FFFFFF"/>
@@ -12672,6 +12853,7 @@
           <a:lstStyle xmlns:a="http://schemas.openxmlformats.org/drawingml/2006/main"/>
           <a:p xmlns:a="http://schemas.openxmlformats.org/drawingml/2006/main">
             <a:pPr algn="l">
+              <a:buNone/>
               <a:defRPr sz="1350" b="0">
                 <a:solidFill>
                   <a:srgbClr val="111111"/>
@@ -12761,6 +12943,7 @@
           <a:lstStyle xmlns:a="http://schemas.openxmlformats.org/drawingml/2006/main"/>
           <a:p xmlns:a="http://schemas.openxmlformats.org/drawingml/2006/main">
             <a:pPr algn="l">
+              <a:buNone/>
               <a:defRPr sz="1275" b="1">
                 <a:solidFill>
                   <a:srgbClr val="111111"/>
@@ -12819,6 +13002,7 @@
           <a:lstStyle xmlns:a="http://schemas.openxmlformats.org/drawingml/2006/main"/>
           <a:p xmlns:a="http://schemas.openxmlformats.org/drawingml/2006/main">
             <a:pPr algn="l">
+              <a:buNone/>
               <a:defRPr sz="1050" b="0">
                 <a:solidFill>
                   <a:srgbClr val="5C6570"/>
@@ -12906,6 +13090,7 @@
           <a:lstStyle xmlns:a="http://schemas.openxmlformats.org/drawingml/2006/main"/>
           <a:p xmlns:a="http://schemas.openxmlformats.org/drawingml/2006/main">
             <a:pPr algn="l">
+              <a:buNone/>
               <a:defRPr sz="2850" b="1">
                 <a:solidFill>
                   <a:srgbClr val="111111"/>
@@ -12931,7 +13116,7 @@
       </p:sp>
       <p:cxnSp>
         <p:nvCxnSpPr>
-          <p:cNvPr id="27" name=""/>
+          <p:cNvPr id="33" name=""/>
           <p:cNvCxnSpPr/>
           <p:nvPr/>
         </p:nvCxnSpPr>
@@ -12986,6 +13171,7 @@
           <a:lstStyle xmlns:a="http://schemas.openxmlformats.org/drawingml/2006/main"/>
           <a:p xmlns:a="http://schemas.openxmlformats.org/drawingml/2006/main">
             <a:pPr algn="r">
+              <a:buNone/>
               <a:defRPr sz="900" b="0">
                 <a:solidFill>
                   <a:srgbClr val="5C6570"/>
@@ -13044,6 +13230,7 @@
           <a:lstStyle xmlns:a="http://schemas.openxmlformats.org/drawingml/2006/main"/>
           <a:p xmlns:a="http://schemas.openxmlformats.org/drawingml/2006/main">
             <a:pPr algn="l">
+              <a:buNone/>
               <a:defRPr sz="1350" b="0">
                 <a:solidFill>
                   <a:srgbClr val="5C6570"/>
@@ -13135,6 +13322,7 @@
           <a:lstStyle xmlns:a="http://schemas.openxmlformats.org/drawingml/2006/main"/>
           <a:p xmlns:a="http://schemas.openxmlformats.org/drawingml/2006/main">
             <a:pPr algn="l">
+              <a:buNone/>
               <a:defRPr sz="1500" b="1">
                 <a:solidFill>
                   <a:srgbClr val="2478E5"/>
@@ -13174,8 +13362,8 @@
         </p:nvSpPr>
         <p:spPr>
           <a:xfrm xmlns:a="http://schemas.openxmlformats.org/drawingml/2006/main">
-            <a:off x="2619375" y="2028825"/>
-            <a:ext cx="5095875" cy="400050"/>
+            <a:off x="2619375" y="1952625"/>
+            <a:ext cx="5095875" cy="533400"/>
           </a:xfrm>
           <a:prstGeom xmlns:a="http://schemas.openxmlformats.org/drawingml/2006/main" prst="rect">
             <a:avLst/>
@@ -13193,6 +13381,7 @@
           <a:lstStyle xmlns:a="http://schemas.openxmlformats.org/drawingml/2006/main"/>
           <a:p xmlns:a="http://schemas.openxmlformats.org/drawingml/2006/main">
             <a:pPr algn="l">
+              <a:buNone/>
               <a:defRPr sz="1125" b="0">
                 <a:solidFill>
                   <a:srgbClr val="111111"/>
@@ -13203,15 +13392,39 @@
               </a:defRPr>
             </a:pPr>
             <a:r>
-              <a:rPr sz="1125" b="0">
-                <a:solidFill>
-                  <a:srgbClr val="111111"/>
-                </a:solidFill>
-                <a:latin typeface="Noto Sans TC"/>
-                <a:ea typeface="Noto Sans TC"/>
-                <a:cs typeface="Noto Sans TC"/>
-              </a:rPr>
-              <a:t>Understand Anything · codebase-research · grill-me · systematic-debugging</a:t>
+              <a:rPr sz="1600" b="0">
+                <a:solidFill>
+                  <a:srgbClr val="151515"/>
+                </a:solidFill>
+                <a:latin typeface="Noto Sans TC"/>
+                <a:ea typeface="Noto Sans TC"/>
+                <a:cs typeface="Noto Sans TC"/>
+              </a:rPr>
+              <a:t>Understand Anything · codebase-research</a:t>
+            </a:r>
+          </a:p>
+          <a:p xmlns:a="http://schemas.openxmlformats.org/drawingml/2006/main">
+            <a:pPr algn="l">
+              <a:buNone/>
+              <a:defRPr sz="1125" b="0">
+                <a:solidFill>
+                  <a:srgbClr val="111111"/>
+                </a:solidFill>
+                <a:latin typeface="Noto Sans TC"/>
+                <a:ea typeface="Noto Sans TC"/>
+                <a:cs typeface="Noto Sans TC"/>
+              </a:defRPr>
+            </a:pPr>
+            <a:r>
+              <a:rPr sz="1600" b="0">
+                <a:solidFill>
+                  <a:srgbClr val="151515"/>
+                </a:solidFill>
+                <a:latin typeface="Noto Sans TC"/>
+                <a:ea typeface="Noto Sans TC"/>
+                <a:cs typeface="Noto Sans TC"/>
+              </a:rPr>
+              <a:t>grill-me · systematic-debugging</a:t>
             </a:r>
           </a:p>
         </p:txBody>
@@ -13232,8 +13445,8 @@
         </p:nvSpPr>
         <p:spPr>
           <a:xfrm xmlns:a="http://schemas.openxmlformats.org/drawingml/2006/main">
-            <a:off x="7953375" y="2028825"/>
-            <a:ext cx="3571875" cy="400050"/>
+            <a:off x="7953375" y="1952625"/>
+            <a:ext cx="3571875" cy="533400"/>
           </a:xfrm>
           <a:prstGeom xmlns:a="http://schemas.openxmlformats.org/drawingml/2006/main" prst="rect">
             <a:avLst/>
@@ -13251,6 +13464,7 @@
           <a:lstStyle xmlns:a="http://schemas.openxmlformats.org/drawingml/2006/main"/>
           <a:p xmlns:a="http://schemas.openxmlformats.org/drawingml/2006/main">
             <a:pPr algn="l">
+              <a:buNone/>
               <a:defRPr sz="1125" b="0">
                 <a:solidFill>
                   <a:srgbClr val="5C6570"/>
@@ -13261,9 +13475,9 @@
               </a:defRPr>
             </a:pPr>
             <a:r>
-              <a:rPr sz="1125" b="0">
-                <a:solidFill>
-                  <a:srgbClr val="5C6570"/>
+              <a:rPr sz="1600" b="0">
+                <a:solidFill>
+                  <a:srgbClr val="606B7A"/>
                 </a:solidFill>
                 <a:latin typeface="Noto Sans TC"/>
                 <a:ea typeface="Noto Sans TC"/>
@@ -13342,6 +13556,7 @@
           <a:lstStyle xmlns:a="http://schemas.openxmlformats.org/drawingml/2006/main"/>
           <a:p xmlns:a="http://schemas.openxmlformats.org/drawingml/2006/main">
             <a:pPr algn="l">
+              <a:buNone/>
               <a:defRPr sz="1500" b="1">
                 <a:solidFill>
                   <a:srgbClr val="2478E5"/>
@@ -13381,8 +13596,8 @@
         </p:nvSpPr>
         <p:spPr>
           <a:xfrm xmlns:a="http://schemas.openxmlformats.org/drawingml/2006/main">
-            <a:off x="2619375" y="2847975"/>
-            <a:ext cx="5095875" cy="400050"/>
+            <a:off x="2619375" y="2771775"/>
+            <a:ext cx="5095875" cy="533400"/>
           </a:xfrm>
           <a:prstGeom xmlns:a="http://schemas.openxmlformats.org/drawingml/2006/main" prst="rect">
             <a:avLst/>
@@ -13400,6 +13615,7 @@
           <a:lstStyle xmlns:a="http://schemas.openxmlformats.org/drawingml/2006/main"/>
           <a:p xmlns:a="http://schemas.openxmlformats.org/drawingml/2006/main">
             <a:pPr algn="l">
+              <a:buNone/>
               <a:defRPr sz="1125" b="0">
                 <a:solidFill>
                   <a:srgbClr val="111111"/>
@@ -13410,15 +13626,39 @@
               </a:defRPr>
             </a:pPr>
             <a:r>
-              <a:rPr sz="1125" b="0">
-                <a:solidFill>
-                  <a:srgbClr val="111111"/>
-                </a:solidFill>
-                <a:latin typeface="Noto Sans TC"/>
-                <a:ea typeface="Noto Sans TC"/>
-                <a:cs typeface="Noto Sans TC"/>
-              </a:rPr>
-              <a:t>/opsx:explore → propose / new / continue → apply → verify → sync / archive</a:t>
+              <a:rPr sz="1600" b="0">
+                <a:solidFill>
+                  <a:srgbClr val="151515"/>
+                </a:solidFill>
+                <a:latin typeface="Noto Sans TC"/>
+                <a:ea typeface="Noto Sans TC"/>
+                <a:cs typeface="Noto Sans TC"/>
+              </a:rPr>
+              <a:t>Explore E0 optional: /opsx:explore</a:t>
+            </a:r>
+          </a:p>
+          <a:p xmlns:a="http://schemas.openxmlformats.org/drawingml/2006/main">
+            <a:pPr algn="l">
+              <a:buNone/>
+              <a:defRPr sz="1125" b="0">
+                <a:solidFill>
+                  <a:srgbClr val="111111"/>
+                </a:solidFill>
+                <a:latin typeface="Noto Sans TC"/>
+                <a:ea typeface="Noto Sans TC"/>
+                <a:cs typeface="Noto Sans TC"/>
+              </a:defRPr>
+            </a:pPr>
+            <a:r>
+              <a:rPr sz="1600" b="0">
+                <a:solidFill>
+                  <a:srgbClr val="151515"/>
+                </a:solidFill>
+                <a:latin typeface="Noto Sans TC"/>
+                <a:ea typeface="Noto Sans TC"/>
+                <a:cs typeface="Noto Sans TC"/>
+              </a:rPr>
+              <a:t>Durable: /opsx:propose or /opsx:new + /opsx:continue</a:t>
             </a:r>
           </a:p>
         </p:txBody>
@@ -13439,8 +13679,8 @@
         </p:nvSpPr>
         <p:spPr>
           <a:xfrm xmlns:a="http://schemas.openxmlformats.org/drawingml/2006/main">
-            <a:off x="7953375" y="2847975"/>
-            <a:ext cx="3571875" cy="400050"/>
+            <a:off x="7953375" y="2771775"/>
+            <a:ext cx="3571875" cy="533400"/>
           </a:xfrm>
           <a:prstGeom xmlns:a="http://schemas.openxmlformats.org/drawingml/2006/main" prst="rect">
             <a:avLst/>
@@ -13458,6 +13698,7 @@
           <a:lstStyle xmlns:a="http://schemas.openxmlformats.org/drawingml/2006/main"/>
           <a:p xmlns:a="http://schemas.openxmlformats.org/drawingml/2006/main">
             <a:pPr algn="l">
+              <a:buNone/>
               <a:defRPr sz="1125" b="0">
                 <a:solidFill>
                   <a:srgbClr val="5C6570"/>
@@ -13468,15 +13709,39 @@
               </a:defRPr>
             </a:pPr>
             <a:r>
-              <a:rPr sz="1125" b="0">
+              <a:rPr sz="1600" b="0">
+                <a:solidFill>
+                  <a:srgbClr val="606B7A"/>
+                </a:solidFill>
+                <a:latin typeface="Noto Sans TC"/>
+                <a:ea typeface="Noto Sans TC"/>
+                <a:cs typeface="Noto Sans TC"/>
+              </a:rPr>
+              <a:t>Execute: /opsx:apply → /opsx:verify</a:t>
+            </a:r>
+          </a:p>
+          <a:p xmlns:a="http://schemas.openxmlformats.org/drawingml/2006/main">
+            <a:pPr algn="l">
+              <a:buNone/>
+              <a:defRPr sz="1125" b="0">
                 <a:solidFill>
                   <a:srgbClr val="5C6570"/>
                 </a:solidFill>
                 <a:latin typeface="Noto Sans TC"/>
                 <a:ea typeface="Noto Sans TC"/>
                 <a:cs typeface="Noto Sans TC"/>
-              </a:rPr>
-              <a:t>管理 P1/P0 durable change agreement；Explore 保持 E0 / ephemeral</a:t>
+              </a:defRPr>
+            </a:pPr>
+            <a:r>
+              <a:rPr sz="1600" b="0">
+                <a:solidFill>
+                  <a:srgbClr val="606B7A"/>
+                </a:solidFill>
+                <a:latin typeface="Noto Sans TC"/>
+                <a:ea typeface="Noto Sans TC"/>
+                <a:cs typeface="Noto Sans TC"/>
+              </a:rPr>
+              <a:t>Close: /opsx:sync → /opsx:archive</a:t>
             </a:r>
           </a:p>
         </p:txBody>
@@ -13549,6 +13814,7 @@
           <a:lstStyle xmlns:a="http://schemas.openxmlformats.org/drawingml/2006/main"/>
           <a:p xmlns:a="http://schemas.openxmlformats.org/drawingml/2006/main">
             <a:pPr algn="l">
+              <a:buNone/>
               <a:defRPr sz="1500" b="1">
                 <a:solidFill>
                   <a:srgbClr val="2478E5"/>
@@ -13588,8 +13854,8 @@
         </p:nvSpPr>
         <p:spPr>
           <a:xfrm xmlns:a="http://schemas.openxmlformats.org/drawingml/2006/main">
-            <a:off x="2619375" y="3667125"/>
-            <a:ext cx="5095875" cy="400050"/>
+            <a:off x="2619375" y="3590925"/>
+            <a:ext cx="5095875" cy="533400"/>
           </a:xfrm>
           <a:prstGeom xmlns:a="http://schemas.openxmlformats.org/drawingml/2006/main" prst="rect">
             <a:avLst/>
@@ -13607,6 +13873,7 @@
           <a:lstStyle xmlns:a="http://schemas.openxmlformats.org/drawingml/2006/main"/>
           <a:p xmlns:a="http://schemas.openxmlformats.org/drawingml/2006/main">
             <a:pPr algn="l">
+              <a:buNone/>
               <a:defRPr sz="1125" b="1">
                 <a:solidFill>
                   <a:srgbClr val="111111"/>
@@ -13617,9 +13884,9 @@
               </a:defRPr>
             </a:pPr>
             <a:r>
-              <a:rPr sz="1125" b="1">
-                <a:solidFill>
-                  <a:srgbClr val="111111"/>
+              <a:rPr sz="1600" b="1">
+                <a:solidFill>
+                  <a:srgbClr val="151515"/>
                 </a:solidFill>
                 <a:latin typeface="Noto Sans TC"/>
                 <a:ea typeface="Noto Sans TC"/>
@@ -13646,8 +13913,8 @@
         </p:nvSpPr>
         <p:spPr>
           <a:xfrm xmlns:a="http://schemas.openxmlformats.org/drawingml/2006/main">
-            <a:off x="7953375" y="3667125"/>
-            <a:ext cx="3571875" cy="400050"/>
+            <a:off x="7953375" y="3590925"/>
+            <a:ext cx="3571875" cy="533400"/>
           </a:xfrm>
           <a:prstGeom xmlns:a="http://schemas.openxmlformats.org/drawingml/2006/main" prst="rect">
             <a:avLst/>
@@ -13665,6 +13932,7 @@
           <a:lstStyle xmlns:a="http://schemas.openxmlformats.org/drawingml/2006/main"/>
           <a:p xmlns:a="http://schemas.openxmlformats.org/drawingml/2006/main">
             <a:pPr algn="l">
+              <a:buNone/>
               <a:defRPr sz="1125" b="0">
                 <a:solidFill>
                   <a:srgbClr val="5C6570"/>
@@ -13675,9 +13943,9 @@
               </a:defRPr>
             </a:pPr>
             <a:r>
-              <a:rPr sz="1125" b="0">
-                <a:solidFill>
-                  <a:srgbClr val="5C6570"/>
+              <a:rPr sz="1600" b="0">
+                <a:solidFill>
+                  <a:srgbClr val="606B7A"/>
                 </a:solidFill>
                 <a:latin typeface="Noto Sans TC"/>
                 <a:ea typeface="Noto Sans TC"/>
@@ -13756,6 +14024,7 @@
           <a:lstStyle xmlns:a="http://schemas.openxmlformats.org/drawingml/2006/main"/>
           <a:p xmlns:a="http://schemas.openxmlformats.org/drawingml/2006/main">
             <a:pPr algn="l">
+              <a:buNone/>
               <a:defRPr sz="1500" b="1">
                 <a:solidFill>
                   <a:srgbClr val="2478E5"/>
@@ -13795,8 +14064,8 @@
         </p:nvSpPr>
         <p:spPr>
           <a:xfrm xmlns:a="http://schemas.openxmlformats.org/drawingml/2006/main">
-            <a:off x="2619375" y="4486275"/>
-            <a:ext cx="5095875" cy="400050"/>
+            <a:off x="2619375" y="4410075"/>
+            <a:ext cx="5095875" cy="533400"/>
           </a:xfrm>
           <a:prstGeom xmlns:a="http://schemas.openxmlformats.org/drawingml/2006/main" prst="rect">
             <a:avLst/>
@@ -13814,6 +14083,7 @@
           <a:lstStyle xmlns:a="http://schemas.openxmlformats.org/drawingml/2006/main"/>
           <a:p xmlns:a="http://schemas.openxmlformats.org/drawingml/2006/main">
             <a:pPr algn="l">
+              <a:buNone/>
               <a:defRPr sz="1125" b="0">
                 <a:solidFill>
                   <a:srgbClr val="111111"/>
@@ -13824,15 +14094,39 @@
               </a:defRPr>
             </a:pPr>
             <a:r>
-              <a:rPr sz="1125" b="0">
-                <a:solidFill>
-                  <a:srgbClr val="111111"/>
-                </a:solidFill>
-                <a:latin typeface="Noto Sans TC"/>
-                <a:ea typeface="Noto Sans TC"/>
-                <a:cs typeface="Noto Sans TC"/>
-              </a:rPr>
-              <a:t>brainstorming · writing-plans · TDD · execution · review · verification</a:t>
+              <a:rPr sz="1600" b="0">
+                <a:solidFill>
+                  <a:srgbClr val="151515"/>
+                </a:solidFill>
+                <a:latin typeface="Noto Sans TC"/>
+                <a:ea typeface="Noto Sans TC"/>
+                <a:cs typeface="Noto Sans TC"/>
+              </a:rPr>
+              <a:t>brainstorming · writing-plans · TDD</a:t>
+            </a:r>
+          </a:p>
+          <a:p xmlns:a="http://schemas.openxmlformats.org/drawingml/2006/main">
+            <a:pPr algn="l">
+              <a:buNone/>
+              <a:defRPr sz="1125" b="0">
+                <a:solidFill>
+                  <a:srgbClr val="111111"/>
+                </a:solidFill>
+                <a:latin typeface="Noto Sans TC"/>
+                <a:ea typeface="Noto Sans TC"/>
+                <a:cs typeface="Noto Sans TC"/>
+              </a:defRPr>
+            </a:pPr>
+            <a:r>
+              <a:rPr sz="1600" b="0">
+                <a:solidFill>
+                  <a:srgbClr val="151515"/>
+                </a:solidFill>
+                <a:latin typeface="Noto Sans TC"/>
+                <a:ea typeface="Noto Sans TC"/>
+                <a:cs typeface="Noto Sans TC"/>
+              </a:rPr>
+              <a:t>execution · review · verification</a:t>
             </a:r>
           </a:p>
         </p:txBody>
@@ -13853,8 +14147,8 @@
         </p:nvSpPr>
         <p:spPr>
           <a:xfrm xmlns:a="http://schemas.openxmlformats.org/drawingml/2006/main">
-            <a:off x="7953375" y="4486275"/>
-            <a:ext cx="3571875" cy="400050"/>
+            <a:off x="7953375" y="4410075"/>
+            <a:ext cx="3571875" cy="533400"/>
           </a:xfrm>
           <a:prstGeom xmlns:a="http://schemas.openxmlformats.org/drawingml/2006/main" prst="rect">
             <a:avLst/>
@@ -13872,6 +14166,7 @@
           <a:lstStyle xmlns:a="http://schemas.openxmlformats.org/drawingml/2006/main"/>
           <a:p xmlns:a="http://schemas.openxmlformats.org/drawingml/2006/main">
             <a:pPr algn="l">
+              <a:buNone/>
               <a:defRPr sz="1125" b="0">
                 <a:solidFill>
                   <a:srgbClr val="5C6570"/>
@@ -13882,15 +14177,15 @@
               </a:defRPr>
             </a:pPr>
             <a:r>
-              <a:rPr sz="1125" b="0">
-                <a:solidFill>
-                  <a:srgbClr val="5C6570"/>
-                </a:solidFill>
-                <a:latin typeface="Noto Sans TC"/>
-                <a:ea typeface="Noto Sans TC"/>
-                <a:cs typeface="Noto Sans TC"/>
-              </a:rPr>
-              <a:t>擁有 design 與單一 P0 的 execution discipline</a:t>
+              <a:rPr sz="1600" b="0">
+                <a:solidFill>
+                  <a:srgbClr val="606B7A"/>
+                </a:solidFill>
+                <a:latin typeface="Noto Sans TC"/>
+                <a:ea typeface="Noto Sans TC"/>
+                <a:cs typeface="Noto Sans TC"/>
+              </a:rPr>
+              <a:t>擁有 design 與單一 P0 execution discipline</a:t>
             </a:r>
           </a:p>
         </p:txBody>
@@ -13961,6 +14256,7 @@
           <a:lstStyle xmlns:a="http://schemas.openxmlformats.org/drawingml/2006/main"/>
           <a:p xmlns:a="http://schemas.openxmlformats.org/drawingml/2006/main">
             <a:pPr algn="l">
+              <a:buNone/>
               <a:defRPr sz="1500" b="1">
                 <a:solidFill>
                   <a:srgbClr val="6DCBF4"/>
@@ -14000,8 +14296,8 @@
         </p:nvSpPr>
         <p:spPr>
           <a:xfrm xmlns:a="http://schemas.openxmlformats.org/drawingml/2006/main">
-            <a:off x="2619375" y="5305425"/>
-            <a:ext cx="5095875" cy="400050"/>
+            <a:off x="2619375" y="5229225"/>
+            <a:ext cx="5095875" cy="533400"/>
           </a:xfrm>
           <a:prstGeom xmlns:a="http://schemas.openxmlformats.org/drawingml/2006/main" prst="rect">
             <a:avLst/>
@@ -14019,6 +14315,7 @@
           <a:lstStyle xmlns:a="http://schemas.openxmlformats.org/drawingml/2006/main"/>
           <a:p xmlns:a="http://schemas.openxmlformats.org/drawingml/2006/main">
             <a:pPr algn="l">
+              <a:buNone/>
               <a:defRPr sz="1125" b="0">
                 <a:solidFill>
                   <a:srgbClr val="FFFFFF"/>
@@ -14029,7 +14326,7 @@
               </a:defRPr>
             </a:pPr>
             <a:r>
-              <a:rPr sz="1125" b="0">
+              <a:rPr sz="1600" b="0">
                 <a:solidFill>
                   <a:srgbClr val="FFFFFF"/>
                 </a:solidFill>
@@ -14037,7 +14334,31 @@
                 <a:ea typeface="Noto Sans TC"/>
                 <a:cs typeface="Noto Sans TC"/>
               </a:rPr>
-              <a:t>Direction · trade-off · authorization · risk acceptance · release</a:t>
+              <a:t>Direction · trade-off · authorization</a:t>
+            </a:r>
+          </a:p>
+          <a:p xmlns:a="http://schemas.openxmlformats.org/drawingml/2006/main">
+            <a:pPr algn="l">
+              <a:buNone/>
+              <a:defRPr sz="1125" b="0">
+                <a:solidFill>
+                  <a:srgbClr val="FFFFFF"/>
+                </a:solidFill>
+                <a:latin typeface="Noto Sans TC"/>
+                <a:ea typeface="Noto Sans TC"/>
+                <a:cs typeface="Noto Sans TC"/>
+              </a:defRPr>
+            </a:pPr>
+            <a:r>
+              <a:rPr sz="1600" b="0">
+                <a:solidFill>
+                  <a:srgbClr val="FFFFFF"/>
+                </a:solidFill>
+                <a:latin typeface="Noto Sans TC"/>
+                <a:ea typeface="Noto Sans TC"/>
+                <a:cs typeface="Noto Sans TC"/>
+              </a:rPr>
+              <a:t>risk acceptance · release</a:t>
             </a:r>
           </a:p>
         </p:txBody>
@@ -14058,8 +14379,8 @@
         </p:nvSpPr>
         <p:spPr>
           <a:xfrm xmlns:a="http://schemas.openxmlformats.org/drawingml/2006/main">
-            <a:off x="7953375" y="5305425"/>
-            <a:ext cx="3571875" cy="400050"/>
+            <a:off x="7953375" y="5229225"/>
+            <a:ext cx="3571875" cy="533400"/>
           </a:xfrm>
           <a:prstGeom xmlns:a="http://schemas.openxmlformats.org/drawingml/2006/main" prst="rect">
             <a:avLst/>
@@ -14077,6 +14398,7 @@
           <a:lstStyle xmlns:a="http://schemas.openxmlformats.org/drawingml/2006/main"/>
           <a:p xmlns:a="http://schemas.openxmlformats.org/drawingml/2006/main">
             <a:pPr algn="l">
+              <a:buNone/>
               <a:defRPr sz="1125" b="0">
                 <a:solidFill>
                   <a:srgbClr val="FFFFFF"/>
@@ -14087,7 +14409,7 @@
               </a:defRPr>
             </a:pPr>
             <a:r>
-              <a:rPr sz="1125" b="0">
+              <a:rPr sz="1600" b="0">
                 <a:solidFill>
                   <a:srgbClr val="FFFFFF"/>
                 </a:solidFill>
@@ -14095,7 +14417,7 @@
                 <a:ea typeface="Noto Sans TC"/>
                 <a:cs typeface="Noto Sans TC"/>
               </a:rPr>
-              <a:t>對 outcome 與 production decision 保持 accountable</a:t>
+              <a:t>對 outcome 與 production decision accountable</a:t>
             </a:r>
           </a:p>
         </p:txBody>
@@ -14116,8 +14438,8 @@
         </p:nvSpPr>
         <p:spPr>
           <a:xfrm xmlns:a="http://schemas.openxmlformats.org/drawingml/2006/main">
-            <a:off x="400050" y="6153150"/>
-            <a:ext cx="10953750" cy="209550"/>
+            <a:off x="400050" y="6076950"/>
+            <a:ext cx="10953750" cy="247650"/>
           </a:xfrm>
           <a:prstGeom xmlns:a="http://schemas.openxmlformats.org/drawingml/2006/main" prst="rect">
             <a:avLst/>
@@ -14135,6 +14457,7 @@
           <a:lstStyle xmlns:a="http://schemas.openxmlformats.org/drawingml/2006/main"/>
           <a:p xmlns:a="http://schemas.openxmlformats.org/drawingml/2006/main">
             <a:pPr algn="l">
+              <a:buNone/>
               <a:defRPr sz="1050" b="0">
                 <a:solidFill>
                   <a:srgbClr val="5C6570"/>
@@ -14145,15 +14468,15 @@
               </a:defRPr>
             </a:pPr>
             <a:r>
-              <a:rPr sz="1050" b="0">
-                <a:solidFill>
-                  <a:srgbClr val="5C6570"/>
-                </a:solidFill>
-                <a:latin typeface="Noto Sans TC"/>
-                <a:ea typeface="Noto Sans TC"/>
-                <a:cs typeface="Noto Sans TC"/>
-              </a:rPr>
-              <a:t>SSOT rule：P3/P2 architecture 留在 Product / Architecture artifacts；OpenSpec 只承載 bounded P1/P0 delta。</a:t>
+              <a:rPr sz="1600" b="0">
+                <a:solidFill>
+                  <a:srgbClr val="606B7A"/>
+                </a:solidFill>
+                <a:latin typeface="Noto Sans TC"/>
+                <a:ea typeface="Noto Sans TC"/>
+                <a:cs typeface="Noto Sans TC"/>
+              </a:rPr>
+              <a:t>SSOT：P3/P2 architecture 留在 Product/Architecture artifacts；OpenSpec 只承載 bounded P1/P0 delta。</a:t>
             </a:r>
           </a:p>
         </p:txBody>
@@ -14222,6 +14545,7 @@
           <a:lstStyle xmlns:a="http://schemas.openxmlformats.org/drawingml/2006/main"/>
           <a:p xmlns:a="http://schemas.openxmlformats.org/drawingml/2006/main">
             <a:pPr algn="l">
+              <a:buNone/>
               <a:defRPr sz="2850" b="1">
                 <a:solidFill>
                   <a:srgbClr val="111111"/>
@@ -14247,7 +14571,7 @@
       </p:sp>
       <p:cxnSp>
         <p:nvCxnSpPr>
-          <p:cNvPr id="32" name=""/>
+          <p:cNvPr id="38" name=""/>
           <p:cNvCxnSpPr/>
           <p:nvPr/>
         </p:nvCxnSpPr>
@@ -14302,6 +14626,7 @@
           <a:lstStyle xmlns:a="http://schemas.openxmlformats.org/drawingml/2006/main"/>
           <a:p xmlns:a="http://schemas.openxmlformats.org/drawingml/2006/main">
             <a:pPr algn="r">
+              <a:buNone/>
               <a:defRPr sz="900" b="0">
                 <a:solidFill>
                   <a:srgbClr val="5C6570"/>
@@ -14360,6 +14685,7 @@
           <a:lstStyle xmlns:a="http://schemas.openxmlformats.org/drawingml/2006/main"/>
           <a:p xmlns:a="http://schemas.openxmlformats.org/drawingml/2006/main">
             <a:pPr algn="l">
+              <a:buNone/>
               <a:defRPr sz="1125" b="1">
                 <a:solidFill>
                   <a:srgbClr val="2478E5"/>
@@ -14418,6 +14744,7 @@
           <a:lstStyle xmlns:a="http://schemas.openxmlformats.org/drawingml/2006/main"/>
           <a:p xmlns:a="http://schemas.openxmlformats.org/drawingml/2006/main">
             <a:pPr algn="l">
+              <a:buNone/>
               <a:defRPr sz="1875" b="1">
                 <a:solidFill>
                   <a:srgbClr val="173B57"/>
@@ -14507,6 +14834,7 @@
           <a:lstStyle xmlns:a="http://schemas.openxmlformats.org/drawingml/2006/main"/>
           <a:p xmlns:a="http://schemas.openxmlformats.org/drawingml/2006/main">
             <a:pPr algn="l">
+              <a:buNone/>
               <a:defRPr sz="1500" b="1">
                 <a:solidFill>
                   <a:srgbClr val="2478E5"/>
@@ -14565,6 +14893,7 @@
           <a:lstStyle xmlns:a="http://schemas.openxmlformats.org/drawingml/2006/main"/>
           <a:p xmlns:a="http://schemas.openxmlformats.org/drawingml/2006/main">
             <a:pPr algn="l">
+              <a:buNone/>
               <a:defRPr sz="1200" b="0">
                 <a:solidFill>
                   <a:srgbClr val="5C6570"/>
@@ -14654,6 +14983,7 @@
           <a:lstStyle xmlns:a="http://schemas.openxmlformats.org/drawingml/2006/main"/>
           <a:p xmlns:a="http://schemas.openxmlformats.org/drawingml/2006/main">
             <a:pPr algn="l">
+              <a:buNone/>
               <a:defRPr sz="1500" b="1">
                 <a:solidFill>
                   <a:srgbClr val="2478E5"/>
@@ -14712,6 +15042,7 @@
           <a:lstStyle xmlns:a="http://schemas.openxmlformats.org/drawingml/2006/main"/>
           <a:p xmlns:a="http://schemas.openxmlformats.org/drawingml/2006/main">
             <a:pPr algn="l">
+              <a:buNone/>
               <a:defRPr sz="1200" b="0">
                 <a:solidFill>
                   <a:srgbClr val="5C6570"/>
@@ -14801,6 +15132,7 @@
           <a:lstStyle xmlns:a="http://schemas.openxmlformats.org/drawingml/2006/main"/>
           <a:p xmlns:a="http://schemas.openxmlformats.org/drawingml/2006/main">
             <a:pPr algn="l">
+              <a:buNone/>
               <a:defRPr sz="1500" b="1">
                 <a:solidFill>
                   <a:srgbClr val="2478E5"/>
@@ -14859,6 +15191,7 @@
           <a:lstStyle xmlns:a="http://schemas.openxmlformats.org/drawingml/2006/main"/>
           <a:p xmlns:a="http://schemas.openxmlformats.org/drawingml/2006/main">
             <a:pPr algn="l">
+              <a:buNone/>
               <a:defRPr sz="1200" b="0">
                 <a:solidFill>
                   <a:srgbClr val="5C6570"/>
@@ -14948,6 +15281,7 @@
           <a:lstStyle xmlns:a="http://schemas.openxmlformats.org/drawingml/2006/main"/>
           <a:p xmlns:a="http://schemas.openxmlformats.org/drawingml/2006/main">
             <a:pPr algn="l">
+              <a:buNone/>
               <a:defRPr sz="1200" b="1">
                 <a:solidFill>
                   <a:srgbClr val="111111"/>
@@ -15006,6 +15340,7 @@
           <a:lstStyle xmlns:a="http://schemas.openxmlformats.org/drawingml/2006/main"/>
           <a:p xmlns:a="http://schemas.openxmlformats.org/drawingml/2006/main">
             <a:pPr algn="l">
+              <a:buNone/>
               <a:defRPr sz="1125" b="1">
                 <a:solidFill>
                   <a:srgbClr val="2478E5"/>
@@ -15095,6 +15430,7 @@
           <a:lstStyle xmlns:a="http://schemas.openxmlformats.org/drawingml/2006/main"/>
           <a:p xmlns:a="http://schemas.openxmlformats.org/drawingml/2006/main">
             <a:pPr algn="l">
+              <a:buNone/>
               <a:defRPr sz="2025" b="1">
                 <a:solidFill>
                   <a:srgbClr val="2478E5"/>
@@ -15153,6 +15489,7 @@
           <a:lstStyle xmlns:a="http://schemas.openxmlformats.org/drawingml/2006/main"/>
           <a:p xmlns:a="http://schemas.openxmlformats.org/drawingml/2006/main">
             <a:pPr algn="l">
+              <a:buNone/>
               <a:defRPr sz="1650" b="1">
                 <a:solidFill>
                   <a:srgbClr val="111111"/>
@@ -15211,6 +15548,7 @@
           <a:lstStyle xmlns:a="http://schemas.openxmlformats.org/drawingml/2006/main"/>
           <a:p xmlns:a="http://schemas.openxmlformats.org/drawingml/2006/main">
             <a:pPr algn="l">
+              <a:buNone/>
               <a:defRPr sz="1125" b="0">
                 <a:solidFill>
                   <a:srgbClr val="5C6570"/>
@@ -15300,6 +15638,7 @@
           <a:lstStyle xmlns:a="http://schemas.openxmlformats.org/drawingml/2006/main"/>
           <a:p xmlns:a="http://schemas.openxmlformats.org/drawingml/2006/main">
             <a:pPr algn="l">
+              <a:buNone/>
               <a:defRPr sz="2025" b="1">
                 <a:solidFill>
                   <a:srgbClr val="2478E5"/>
@@ -15358,6 +15697,7 @@
           <a:lstStyle xmlns:a="http://schemas.openxmlformats.org/drawingml/2006/main"/>
           <a:p xmlns:a="http://schemas.openxmlformats.org/drawingml/2006/main">
             <a:pPr algn="l">
+              <a:buNone/>
               <a:defRPr sz="1650" b="1">
                 <a:solidFill>
                   <a:srgbClr val="111111"/>
@@ -15416,6 +15756,7 @@
           <a:lstStyle xmlns:a="http://schemas.openxmlformats.org/drawingml/2006/main"/>
           <a:p xmlns:a="http://schemas.openxmlformats.org/drawingml/2006/main">
             <a:pPr algn="l">
+              <a:buNone/>
               <a:defRPr sz="1125" b="0">
                 <a:solidFill>
                   <a:srgbClr val="5C6570"/>
@@ -15505,6 +15846,7 @@
           <a:lstStyle xmlns:a="http://schemas.openxmlformats.org/drawingml/2006/main"/>
           <a:p xmlns:a="http://schemas.openxmlformats.org/drawingml/2006/main">
             <a:pPr algn="l">
+              <a:buNone/>
               <a:defRPr sz="2025" b="1">
                 <a:solidFill>
                   <a:srgbClr val="2478E5"/>
@@ -15563,6 +15905,7 @@
           <a:lstStyle xmlns:a="http://schemas.openxmlformats.org/drawingml/2006/main"/>
           <a:p xmlns:a="http://schemas.openxmlformats.org/drawingml/2006/main">
             <a:pPr algn="l">
+              <a:buNone/>
               <a:defRPr sz="1650" b="1">
                 <a:solidFill>
                   <a:srgbClr val="111111"/>
@@ -15621,6 +15964,7 @@
           <a:lstStyle xmlns:a="http://schemas.openxmlformats.org/drawingml/2006/main"/>
           <a:p xmlns:a="http://schemas.openxmlformats.org/drawingml/2006/main">
             <a:pPr algn="l">
+              <a:buNone/>
               <a:defRPr sz="1125" b="0">
                 <a:solidFill>
                   <a:srgbClr val="5C6570"/>
@@ -15679,6 +16023,7 @@
           <a:lstStyle xmlns:a="http://schemas.openxmlformats.org/drawingml/2006/main"/>
           <a:p xmlns:a="http://schemas.openxmlformats.org/drawingml/2006/main">
             <a:pPr algn="l">
+              <a:buNone/>
               <a:defRPr sz="1200" b="1">
                 <a:solidFill>
                   <a:srgbClr val="173B57"/>
@@ -15766,6 +16111,7 @@
           <a:lstStyle xmlns:a="http://schemas.openxmlformats.org/drawingml/2006/main"/>
           <a:p xmlns:a="http://schemas.openxmlformats.org/drawingml/2006/main">
             <a:pPr algn="l">
+              <a:buNone/>
               <a:defRPr sz="2850" b="1">
                 <a:solidFill>
                   <a:srgbClr val="111111"/>
@@ -15791,7 +16137,7 @@
       </p:sp>
       <p:cxnSp>
         <p:nvCxnSpPr>
-          <p:cNvPr id="30" name=""/>
+          <p:cNvPr id="105" name=""/>
           <p:cNvCxnSpPr/>
           <p:nvPr/>
         </p:nvCxnSpPr>
@@ -15846,6 +16192,7 @@
           <a:lstStyle xmlns:a="http://schemas.openxmlformats.org/drawingml/2006/main"/>
           <a:p xmlns:a="http://schemas.openxmlformats.org/drawingml/2006/main">
             <a:pPr algn="r">
+              <a:buNone/>
               <a:defRPr sz="900" b="0">
                 <a:solidFill>
                   <a:srgbClr val="5C6570"/>
@@ -15966,6 +16313,7 @@
           <a:lstStyle xmlns:a="http://schemas.openxmlformats.org/drawingml/2006/main"/>
           <a:p xmlns:a="http://schemas.openxmlformats.org/drawingml/2006/main">
             <a:pPr algn="l">
+              <a:buNone/>
               <a:defRPr sz="975" b="1">
                 <a:solidFill>
                   <a:srgbClr val="FFFFFF"/>
@@ -16024,6 +16372,7 @@
           <a:lstStyle xmlns:a="http://schemas.openxmlformats.org/drawingml/2006/main"/>
           <a:p xmlns:a="http://schemas.openxmlformats.org/drawingml/2006/main">
             <a:pPr algn="l">
+              <a:buNone/>
               <a:defRPr sz="1725" b="1">
                 <a:solidFill>
                   <a:srgbClr val="111111"/>
@@ -16082,6 +16431,7 @@
           <a:lstStyle xmlns:a="http://schemas.openxmlformats.org/drawingml/2006/main"/>
           <a:p xmlns:a="http://schemas.openxmlformats.org/drawingml/2006/main">
             <a:pPr algn="l">
+              <a:buNone/>
               <a:defRPr sz="1275" b="0">
                 <a:solidFill>
                   <a:srgbClr val="111111"/>
@@ -16105,6 +16455,7 @@
           </a:p>
           <a:p xmlns:a="http://schemas.openxmlformats.org/drawingml/2006/main">
             <a:pPr algn="l">
+              <a:buNone/>
               <a:defRPr sz="1275" b="0">
                 <a:solidFill>
                   <a:srgbClr val="111111"/>
@@ -16128,6 +16479,7 @@
           </a:p>
           <a:p xmlns:a="http://schemas.openxmlformats.org/drawingml/2006/main">
             <a:pPr algn="l">
+              <a:buNone/>
               <a:defRPr sz="1275" b="0">
                 <a:solidFill>
                   <a:srgbClr val="111111"/>
@@ -16151,6 +16503,7 @@
           </a:p>
           <a:p xmlns:a="http://schemas.openxmlformats.org/drawingml/2006/main">
             <a:pPr algn="l">
+              <a:buNone/>
               <a:defRPr sz="1275" b="0">
                 <a:solidFill>
                   <a:srgbClr val="111111"/>
@@ -16174,6 +16527,7 @@
           </a:p>
           <a:p xmlns:a="http://schemas.openxmlformats.org/drawingml/2006/main">
             <a:pPr algn="l">
+              <a:buNone/>
               <a:defRPr sz="1275" b="0">
                 <a:solidFill>
                   <a:srgbClr val="111111"/>
@@ -16199,7 +16553,7 @@
       </p:sp>
       <p:cxnSp>
         <p:nvCxnSpPr>
-          <p:cNvPr id="37" name=""/>
+          <p:cNvPr id="112" name=""/>
           <p:cNvCxnSpPr/>
           <p:nvPr/>
         </p:nvCxnSpPr>
@@ -16254,6 +16608,7 @@
           <a:lstStyle xmlns:a="http://schemas.openxmlformats.org/drawingml/2006/main"/>
           <a:p xmlns:a="http://schemas.openxmlformats.org/drawingml/2006/main">
             <a:pPr algn="l">
+              <a:buNone/>
               <a:defRPr sz="975" b="1">
                 <a:solidFill>
                   <a:srgbClr val="2478E5"/>
@@ -16312,6 +16667,7 @@
           <a:lstStyle xmlns:a="http://schemas.openxmlformats.org/drawingml/2006/main"/>
           <a:p xmlns:a="http://schemas.openxmlformats.org/drawingml/2006/main">
             <a:pPr algn="l">
+              <a:buNone/>
               <a:defRPr sz="1125" b="1">
                 <a:solidFill>
                   <a:srgbClr val="173B57"/>
@@ -16432,6 +16788,7 @@
           <a:lstStyle xmlns:a="http://schemas.openxmlformats.org/drawingml/2006/main"/>
           <a:p xmlns:a="http://schemas.openxmlformats.org/drawingml/2006/main">
             <a:pPr algn="l">
+              <a:buNone/>
               <a:defRPr sz="975" b="1">
                 <a:solidFill>
                   <a:srgbClr val="FFFFFF"/>
@@ -16490,6 +16847,7 @@
           <a:lstStyle xmlns:a="http://schemas.openxmlformats.org/drawingml/2006/main"/>
           <a:p xmlns:a="http://schemas.openxmlformats.org/drawingml/2006/main">
             <a:pPr algn="l">
+              <a:buNone/>
               <a:defRPr sz="1725" b="1">
                 <a:solidFill>
                   <a:srgbClr val="111111"/>
@@ -16548,6 +16906,7 @@
           <a:lstStyle xmlns:a="http://schemas.openxmlformats.org/drawingml/2006/main"/>
           <a:p xmlns:a="http://schemas.openxmlformats.org/drawingml/2006/main">
             <a:pPr algn="l">
+              <a:buNone/>
               <a:defRPr sz="1275" b="0">
                 <a:solidFill>
                   <a:srgbClr val="111111"/>
@@ -16571,6 +16930,7 @@
           </a:p>
           <a:p xmlns:a="http://schemas.openxmlformats.org/drawingml/2006/main">
             <a:pPr algn="l">
+              <a:buNone/>
               <a:defRPr sz="1275" b="0">
                 <a:solidFill>
                   <a:srgbClr val="111111"/>
@@ -16594,6 +16954,7 @@
           </a:p>
           <a:p xmlns:a="http://schemas.openxmlformats.org/drawingml/2006/main">
             <a:pPr algn="l">
+              <a:buNone/>
               <a:defRPr sz="1275" b="0">
                 <a:solidFill>
                   <a:srgbClr val="111111"/>
@@ -16617,6 +16978,7 @@
           </a:p>
           <a:p xmlns:a="http://schemas.openxmlformats.org/drawingml/2006/main">
             <a:pPr algn="l">
+              <a:buNone/>
               <a:defRPr sz="1275" b="0">
                 <a:solidFill>
                   <a:srgbClr val="111111"/>
@@ -16640,6 +17002,7 @@
           </a:p>
           <a:p xmlns:a="http://schemas.openxmlformats.org/drawingml/2006/main">
             <a:pPr algn="l">
+              <a:buNone/>
               <a:defRPr sz="1275" b="0">
                 <a:solidFill>
                   <a:srgbClr val="111111"/>
@@ -16665,7 +17028,7 @@
       </p:sp>
       <p:cxnSp>
         <p:nvCxnSpPr>
-          <p:cNvPr id="45" name=""/>
+          <p:cNvPr id="120" name=""/>
           <p:cNvCxnSpPr/>
           <p:nvPr/>
         </p:nvCxnSpPr>
@@ -16720,6 +17083,7 @@
           <a:lstStyle xmlns:a="http://schemas.openxmlformats.org/drawingml/2006/main"/>
           <a:p xmlns:a="http://schemas.openxmlformats.org/drawingml/2006/main">
             <a:pPr algn="l">
+              <a:buNone/>
               <a:defRPr sz="975" b="1">
                 <a:solidFill>
                   <a:srgbClr val="2478E5"/>
@@ -16778,6 +17142,7 @@
           <a:lstStyle xmlns:a="http://schemas.openxmlformats.org/drawingml/2006/main"/>
           <a:p xmlns:a="http://schemas.openxmlformats.org/drawingml/2006/main">
             <a:pPr algn="l">
+              <a:buNone/>
               <a:defRPr sz="1125" b="1">
                 <a:solidFill>
                   <a:srgbClr val="173B57"/>
@@ -16898,6 +17263,7 @@
           <a:lstStyle xmlns:a="http://schemas.openxmlformats.org/drawingml/2006/main"/>
           <a:p xmlns:a="http://schemas.openxmlformats.org/drawingml/2006/main">
             <a:pPr algn="l">
+              <a:buNone/>
               <a:defRPr sz="975" b="1">
                 <a:solidFill>
                   <a:srgbClr val="FFFFFF"/>
@@ -16956,6 +17322,7 @@
           <a:lstStyle xmlns:a="http://schemas.openxmlformats.org/drawingml/2006/main"/>
           <a:p xmlns:a="http://schemas.openxmlformats.org/drawingml/2006/main">
             <a:pPr algn="l">
+              <a:buNone/>
               <a:defRPr sz="1725" b="1">
                 <a:solidFill>
                   <a:srgbClr val="111111"/>
@@ -17014,6 +17381,7 @@
           <a:lstStyle xmlns:a="http://schemas.openxmlformats.org/drawingml/2006/main"/>
           <a:p xmlns:a="http://schemas.openxmlformats.org/drawingml/2006/main">
             <a:pPr algn="l">
+              <a:buNone/>
               <a:defRPr sz="1275" b="0">
                 <a:solidFill>
                   <a:srgbClr val="111111"/>
@@ -17037,6 +17405,7 @@
           </a:p>
           <a:p xmlns:a="http://schemas.openxmlformats.org/drawingml/2006/main">
             <a:pPr algn="l">
+              <a:buNone/>
               <a:defRPr sz="1275" b="0">
                 <a:solidFill>
                   <a:srgbClr val="111111"/>
@@ -17060,6 +17429,7 @@
           </a:p>
           <a:p xmlns:a="http://schemas.openxmlformats.org/drawingml/2006/main">
             <a:pPr algn="l">
+              <a:buNone/>
               <a:defRPr sz="1275" b="0">
                 <a:solidFill>
                   <a:srgbClr val="111111"/>
@@ -17083,6 +17453,7 @@
           </a:p>
           <a:p xmlns:a="http://schemas.openxmlformats.org/drawingml/2006/main">
             <a:pPr algn="l">
+              <a:buNone/>
               <a:defRPr sz="1275" b="0">
                 <a:solidFill>
                   <a:srgbClr val="111111"/>
@@ -17106,6 +17477,7 @@
           </a:p>
           <a:p xmlns:a="http://schemas.openxmlformats.org/drawingml/2006/main">
             <a:pPr algn="l">
+              <a:buNone/>
               <a:defRPr sz="1275" b="0">
                 <a:solidFill>
                   <a:srgbClr val="111111"/>
@@ -17131,7 +17503,7 @@
       </p:sp>
       <p:cxnSp>
         <p:nvCxnSpPr>
-          <p:cNvPr id="53" name=""/>
+          <p:cNvPr id="128" name=""/>
           <p:cNvCxnSpPr/>
           <p:nvPr/>
         </p:nvCxnSpPr>
@@ -17186,6 +17558,7 @@
           <a:lstStyle xmlns:a="http://schemas.openxmlformats.org/drawingml/2006/main"/>
           <a:p xmlns:a="http://schemas.openxmlformats.org/drawingml/2006/main">
             <a:pPr algn="l">
+              <a:buNone/>
               <a:defRPr sz="975" b="1">
                 <a:solidFill>
                   <a:srgbClr val="2478E5"/>
@@ -17244,6 +17617,7 @@
           <a:lstStyle xmlns:a="http://schemas.openxmlformats.org/drawingml/2006/main"/>
           <a:p xmlns:a="http://schemas.openxmlformats.org/drawingml/2006/main">
             <a:pPr algn="l">
+              <a:buNone/>
               <a:defRPr sz="1125" b="1">
                 <a:solidFill>
                   <a:srgbClr val="173B57"/>
@@ -17283,13 +17657,15 @@
         </p:nvSpPr>
         <p:spPr>
           <a:xfrm xmlns:a="http://schemas.openxmlformats.org/drawingml/2006/main">
-            <a:off x="400050" y="5962650"/>
-            <a:ext cx="10668000" cy="285750"/>
-          </a:xfrm>
-          <a:prstGeom xmlns:a="http://schemas.openxmlformats.org/drawingml/2006/main" prst="rect">
-            <a:avLst/>
-          </a:prstGeom>
-          <a:noFill xmlns:a="http://schemas.openxmlformats.org/drawingml/2006/main"/>
+            <a:off x="400050" y="5676900"/>
+            <a:ext cx="11391900" cy="571500"/>
+          </a:xfrm>
+          <a:prstGeom xmlns:a="http://schemas.openxmlformats.org/drawingml/2006/main" prst="rect">
+            <a:avLst/>
+          </a:prstGeom>
+          <a:solidFill xmlns:a="http://schemas.openxmlformats.org/drawingml/2006/main">
+            <a:srgbClr val="FFF1CC"/>
+          </a:solidFill>
           <a:ln xmlns:a="http://schemas.openxmlformats.org/drawingml/2006/main" w="0">
             <a:noFill/>
             <a:prstDash val="solid"/>
@@ -17302,6 +17678,7 @@
           <a:lstStyle xmlns:a="http://schemas.openxmlformats.org/drawingml/2006/main"/>
           <a:p xmlns:a="http://schemas.openxmlformats.org/drawingml/2006/main">
             <a:pPr algn="l">
+              <a:buNone/>
               <a:defRPr sz="1425" b="1">
                 <a:solidFill>
                   <a:srgbClr val="111111"/>
@@ -17312,15 +17689,15 @@
               </a:defRPr>
             </a:pPr>
             <a:r>
-              <a:rPr sz="1425" b="1">
-                <a:solidFill>
-                  <a:srgbClr val="111111"/>
-                </a:solidFill>
-                <a:latin typeface="Noto Sans TC"/>
-                <a:ea typeface="Noto Sans TC"/>
-                <a:cs typeface="Noto Sans TC"/>
-              </a:rPr>
-              <a:t>First unknown wins：從第一個不能可靠回答的 stage 開始；一次只啟動一個 lead action。</a:t>
+              <a:rPr sz="1600" b="1">
+                <a:solidFill>
+                  <a:srgbClr val="151515"/>
+                </a:solidFill>
+                <a:latin typeface="Noto Sans TC"/>
+                <a:ea typeface="Noto Sans TC"/>
+                <a:cs typeface="Noto Sans TC"/>
+              </a:rPr>
+              <a:t>First unknown wins。Evidence Gate 後，shared / production change → existing release process（E3 · observe · recover）。</a:t>
             </a:r>
           </a:p>
         </p:txBody>

</xml_diff>

<commit_message>
Correct Golden Matrix training slide
</commit_message>
<xml_diff>
--- a/presentation/06_Training_Presentation.pptx
+++ b/presentation/06_Training_Presentation.pptx
@@ -2,22 +2,22 @@
 <file path=ppt/presentation.xml><?xml version="1.0" encoding="utf-8"?>
 <p:presentation xmlns:p="http://schemas.openxmlformats.org/presentationml/2006/main">
   <p:sldMasterIdLst>
-    <p:sldMasterId xmlns:r="http://schemas.openxmlformats.org/officeDocument/2006/relationships" id="2147483648" r:id="R32d07d1937244c8d"/>
+    <p:sldMasterId xmlns:r="http://schemas.openxmlformats.org/officeDocument/2006/relationships" id="2147483648" r:id="Rbd2b5d38c8ac4e61"/>
   </p:sldMasterIdLst>
   <p:notesMasterIdLst>
-    <p:notesMasterId xmlns:r="http://schemas.openxmlformats.org/officeDocument/2006/relationships" r:id="Rafa9f2f7fa314e32"/>
+    <p:notesMasterId xmlns:r="http://schemas.openxmlformats.org/officeDocument/2006/relationships" r:id="Ra54a3ddc9adb45c9"/>
   </p:notesMasterIdLst>
   <p:sldIdLst>
-    <p:sldId xmlns:r="http://schemas.openxmlformats.org/officeDocument/2006/relationships" id="256" r:id="Rbe72169caeeb4e5f"/>
-    <p:sldId xmlns:r="http://schemas.openxmlformats.org/officeDocument/2006/relationships" id="257" r:id="R471ab88cfc3b4fe8"/>
-    <p:sldId xmlns:r="http://schemas.openxmlformats.org/officeDocument/2006/relationships" id="258" r:id="R3c3d1ece4f1c4079"/>
-    <p:sldId xmlns:r="http://schemas.openxmlformats.org/officeDocument/2006/relationships" id="259" r:id="R7462725418c2404f"/>
-    <p:sldId xmlns:r="http://schemas.openxmlformats.org/officeDocument/2006/relationships" id="260" r:id="Rb5b9afc9fca54736"/>
-    <p:sldId xmlns:r="http://schemas.openxmlformats.org/officeDocument/2006/relationships" id="261" r:id="Rd71a937202d04098"/>
-    <p:sldId xmlns:r="http://schemas.openxmlformats.org/officeDocument/2006/relationships" id="262" r:id="R22429fea4df541a4"/>
-    <p:sldId xmlns:r="http://schemas.openxmlformats.org/officeDocument/2006/relationships" id="263" r:id="R485c8a5e203e47cd"/>
-    <p:sldId xmlns:r="http://schemas.openxmlformats.org/officeDocument/2006/relationships" id="264" r:id="Rcb6965780dda4833"/>
-    <p:sldId xmlns:r="http://schemas.openxmlformats.org/officeDocument/2006/relationships" id="265" r:id="Rdbd329adaf8f4843"/>
+    <p:sldId xmlns:r="http://schemas.openxmlformats.org/officeDocument/2006/relationships" id="256" r:id="R33d1db4246034d22"/>
+    <p:sldId xmlns:r="http://schemas.openxmlformats.org/officeDocument/2006/relationships" id="257" r:id="R1ab2c926f94b4c9e"/>
+    <p:sldId xmlns:r="http://schemas.openxmlformats.org/officeDocument/2006/relationships" id="258" r:id="R5eae3d06adfc49ba"/>
+    <p:sldId xmlns:r="http://schemas.openxmlformats.org/officeDocument/2006/relationships" id="259" r:id="Rd4c7effb1c3d42f5"/>
+    <p:sldId xmlns:r="http://schemas.openxmlformats.org/officeDocument/2006/relationships" id="260" r:id="Rdd7acb73e5de4d9e"/>
+    <p:sldId xmlns:r="http://schemas.openxmlformats.org/officeDocument/2006/relationships" id="261" r:id="R1dd17bf9a25348c7"/>
+    <p:sldId xmlns:r="http://schemas.openxmlformats.org/officeDocument/2006/relationships" id="262" r:id="Rb98738003c47409a"/>
+    <p:sldId xmlns:r="http://schemas.openxmlformats.org/officeDocument/2006/relationships" id="263" r:id="R2f7987e584ad425b"/>
+    <p:sldId xmlns:r="http://schemas.openxmlformats.org/officeDocument/2006/relationships" id="264" r:id="R2e62dbe84aa14511"/>
+    <p:sldId xmlns:r="http://schemas.openxmlformats.org/officeDocument/2006/relationships" id="265" r:id="Rb4f53dce95b34d32"/>
   </p:sldIdLst>
   <p:sldSz cx="12192000" cy="6858000"/>
   <p:notesSz cx="6858000" cy="9144000"/>
@@ -1204,7 +1204,7 @@
   </p:cSld>
   <p:clrMap bg1="lt1" tx1="dk1" bg2="lt2" tx2="dk2" accent1="accent1" accent2="accent2" accent3="accent3" accent4="accent4" accent5="accent5" accent6="accent6" hlink="hlink" folHlink="folHlink"/>
   <p:sldLayoutIdLst>
-    <p:sldLayoutId xmlns:r="http://schemas.openxmlformats.org/officeDocument/2006/relationships" id="2147483649" r:id="R14c74f2389d3429e"/>
+    <p:sldLayoutId xmlns:r="http://schemas.openxmlformats.org/officeDocument/2006/relationships" id="2147483649" r:id="R111d965d6f2e4ddf"/>
   </p:sldLayoutIdLst>
   <p:txStyles>
     <p:titleStyle>
@@ -2095,7 +2095,7 @@
                 <a:ea typeface="Noto Sans TC"/>
                 <a:cs typeface="Noto Sans TC"/>
               </a:rPr>
-              <a:t>v1.1 Baseline Candidate</a:t>
+              <a:t>v1.2 Baseline Candidate</a:t>
             </a:r>
           </a:p>
         </p:txBody>
@@ -2249,7 +2249,7 @@
       </p:sp>
       <p:cxnSp>
         <p:nvCxnSpPr>
-          <p:cNvPr id="97" name=""/>
+          <p:cNvPr id="137" name=""/>
           <p:cNvCxnSpPr/>
           <p:nvPr/>
         </p:nvCxnSpPr>
@@ -2507,7 +2507,7 @@
       </p:sp>
       <p:cxnSp>
         <p:nvCxnSpPr>
-          <p:cNvPr id="102" name=""/>
+          <p:cNvPr id="142" name=""/>
           <p:cNvCxnSpPr/>
           <p:nvPr/>
         </p:nvCxnSpPr>
@@ -2647,7 +2647,7 @@
       </p:sp>
       <p:cxnSp>
         <p:nvCxnSpPr>
-          <p:cNvPr id="105" name=""/>
+          <p:cNvPr id="145" name=""/>
           <p:cNvCxnSpPr/>
           <p:nvPr/>
         </p:nvCxnSpPr>
@@ -2787,7 +2787,7 @@
       </p:sp>
       <p:cxnSp>
         <p:nvCxnSpPr>
-          <p:cNvPr id="108" name=""/>
+          <p:cNvPr id="148" name=""/>
           <p:cNvCxnSpPr/>
           <p:nvPr/>
         </p:nvCxnSpPr>
@@ -2927,7 +2927,7 @@
       </p:sp>
       <p:cxnSp>
         <p:nvCxnSpPr>
-          <p:cNvPr id="111" name=""/>
+          <p:cNvPr id="151" name=""/>
           <p:cNvCxnSpPr/>
           <p:nvPr/>
         </p:nvCxnSpPr>
@@ -3067,7 +3067,7 @@
       </p:sp>
       <p:cxnSp>
         <p:nvCxnSpPr>
-          <p:cNvPr id="114" name=""/>
+          <p:cNvPr id="154" name=""/>
           <p:cNvCxnSpPr/>
           <p:nvPr/>
         </p:nvCxnSpPr>
@@ -3915,7 +3915,7 @@
       </p:sp>
       <p:cxnSp>
         <p:nvCxnSpPr>
-          <p:cNvPr id="25" name=""/>
+          <p:cNvPr id="29" name=""/>
           <p:cNvCxnSpPr/>
           <p:nvPr/>
         </p:nvCxnSpPr>
@@ -4826,7 +4826,7 @@
       </p:sp>
       <p:cxnSp>
         <p:nvCxnSpPr>
-          <p:cNvPr id="130" name=""/>
+          <p:cNvPr id="192" name=""/>
           <p:cNvCxnSpPr/>
           <p:nvPr/>
         </p:nvCxnSpPr>
@@ -5056,7 +5056,7 @@
       </p:sp>
       <p:cxnSp>
         <p:nvCxnSpPr>
-          <p:cNvPr id="135" name=""/>
+          <p:cNvPr id="197" name=""/>
           <p:cNvCxnSpPr/>
           <p:nvPr/>
         </p:nvCxnSpPr>
@@ -5078,7 +5078,7 @@
       </p:cxnSp>
       <p:cxnSp>
         <p:nvCxnSpPr>
-          <p:cNvPr id="136" name=""/>
+          <p:cNvPr id="198" name=""/>
           <p:cNvCxnSpPr/>
           <p:nvPr/>
         </p:nvCxnSpPr>
@@ -5100,7 +5100,7 @@
       </p:cxnSp>
       <p:cxnSp>
         <p:nvCxnSpPr>
-          <p:cNvPr id="137" name=""/>
+          <p:cNvPr id="199" name=""/>
           <p:cNvCxnSpPr/>
           <p:nvPr/>
         </p:nvCxnSpPr>
@@ -5122,7 +5122,7 @@
       </p:cxnSp>
       <p:cxnSp>
         <p:nvCxnSpPr>
-          <p:cNvPr id="138" name=""/>
+          <p:cNvPr id="200" name=""/>
           <p:cNvCxnSpPr/>
           <p:nvPr/>
         </p:nvCxnSpPr>
@@ -6184,7 +6184,7 @@
       </p:sp>
       <p:cxnSp>
         <p:nvCxnSpPr>
-          <p:cNvPr id="159" name=""/>
+          <p:cNvPr id="221" name=""/>
           <p:cNvCxnSpPr/>
           <p:nvPr/>
         </p:nvCxnSpPr>
@@ -6502,7 +6502,7 @@
       </p:sp>
       <p:cxnSp>
         <p:nvCxnSpPr>
-          <p:cNvPr id="58" name=""/>
+          <p:cNvPr id="70" name=""/>
           <p:cNvCxnSpPr/>
           <p:nvPr/>
         </p:nvCxnSpPr>
@@ -6583,7 +6583,7 @@
       </p:sp>
       <p:cxnSp>
         <p:nvCxnSpPr>
-          <p:cNvPr id="60" name=""/>
+          <p:cNvPr id="72" name=""/>
           <p:cNvCxnSpPr/>
           <p:nvPr/>
         </p:nvCxnSpPr>
@@ -6605,7 +6605,7 @@
       </p:cxnSp>
       <p:cxnSp>
         <p:nvCxnSpPr>
-          <p:cNvPr id="61" name=""/>
+          <p:cNvPr id="73" name=""/>
           <p:cNvCxnSpPr/>
           <p:nvPr/>
         </p:nvCxnSpPr>
@@ -6627,7 +6627,7 @@
       </p:cxnSp>
       <p:cxnSp>
         <p:nvCxnSpPr>
-          <p:cNvPr id="62" name=""/>
+          <p:cNvPr id="74" name=""/>
           <p:cNvCxnSpPr/>
           <p:nvPr/>
         </p:nvCxnSpPr>
@@ -8373,7 +8373,7 @@
       </p:sp>
       <p:cxnSp>
         <p:nvCxnSpPr>
-          <p:cNvPr id="73" name=""/>
+          <p:cNvPr id="77" name=""/>
           <p:cNvCxnSpPr/>
           <p:nvPr/>
         </p:nvCxnSpPr>
@@ -8498,15 +8498,15 @@
               </a:defRPr>
             </a:pPr>
             <a:r>
-              <a:rPr sz="1350" b="0">
-                <a:solidFill>
-                  <a:srgbClr val="5C6570"/>
-                </a:solidFill>
-                <a:latin typeface="Noto Sans TC"/>
-                <a:ea typeface="Noto Sans TC"/>
-                <a:cs typeface="Noto Sans TC"/>
-              </a:rPr>
-              <a:t>每個 cell 都是：Lead skill / action → minimum output</a:t>
+              <a:rPr sz="1600" b="0">
+                <a:solidFill>
+                  <a:srgbClr val="606B7A"/>
+                </a:solidFill>
+                <a:latin typeface="Noto Sans TC"/>
+                <a:ea typeface="Noto Sans TC"/>
+                <a:cs typeface="Noto Sans TC"/>
+              </a:rPr>
+              <a:t>每格：lead action → minimum output · no blocker = execution frontier</a:t>
             </a:r>
           </a:p>
         </p:txBody>
@@ -8662,7 +8662,7 @@
         </p:spPr>
         <p:txBody>
           <a:bodyPr xmlns:a="http://schemas.openxmlformats.org/drawingml/2006/main" wrap="square" lIns="0" tIns="0" rIns="0" bIns="0" anchor="t">
-            <a:normAutofit fontScale="100000"/>
+            <a:normAutofit fontScale="85938"/>
           </a:bodyPr>
           <a:lstStyle xmlns:a="http://schemas.openxmlformats.org/drawingml/2006/main"/>
           <a:p xmlns:a="http://schemas.openxmlformats.org/drawingml/2006/main">
@@ -8678,15 +8678,15 @@
               </a:defRPr>
             </a:pPr>
             <a:r>
-              <a:rPr sz="1200" b="1">
-                <a:solidFill>
-                  <a:srgbClr val="111111"/>
-                </a:solidFill>
-                <a:latin typeface="Noto Sans TC"/>
-                <a:ea typeface="Noto Sans TC"/>
-                <a:cs typeface="Noto Sans TC"/>
-              </a:rPr>
-              <a:t>P3 Product</a:t>
+              <a:rPr sz="1600" b="1">
+                <a:solidFill>
+                  <a:srgbClr val="151515"/>
+                </a:solidFill>
+                <a:latin typeface="Noto Sans TC"/>
+                <a:ea typeface="Noto Sans TC"/>
+                <a:cs typeface="Noto Sans TC"/>
+              </a:rPr>
+              <a:t>P3 Product / Program</a:t>
             </a:r>
           </a:p>
         </p:txBody>
@@ -9140,7 +9140,7 @@
                 <a:ea typeface="Noto Sans TC"/>
                 <a:cs typeface="Noto Sans TC"/>
               </a:rPr>
-              <a:t>grill + understand</a:t>
+              <a:t>understand + grill</a:t>
             </a:r>
           </a:p>
           <a:p xmlns:a="http://schemas.openxmlformats.org/drawingml/2006/main">
@@ -9164,7 +9164,7 @@
                 <a:ea typeface="Noto Sans TC"/>
                 <a:cs typeface="Noto Sans TC"/>
               </a:rPr>
-              <a:t>→ As-Is Brief</a:t>
+              <a:t>→ Product / As-Is Brief</a:t>
             </a:r>
           </a:p>
         </p:txBody>
@@ -9396,7 +9396,7 @@
                 <a:ea typeface="Noto Sans TC"/>
                 <a:cs typeface="Noto Sans TC"/>
               </a:rPr>
-              <a:t>→ Research Brief</a:t>
+              <a:t>→ Feature Research Brief</a:t>
             </a:r>
           </a:p>
         </p:txBody>
@@ -9488,7 +9488,7 @@
                 <a:ea typeface="Noto Sans TC"/>
                 <a:cs typeface="Noto Sans TC"/>
               </a:rPr>
-              <a:t>targeted research</a:t>
+              <a:t>research / debug</a:t>
             </a:r>
           </a:p>
           <a:p xmlns:a="http://schemas.openxmlformats.org/drawingml/2006/main">
@@ -10068,7 +10068,7 @@
                 <a:ea typeface="Noto Sans TC"/>
                 <a:cs typeface="Noto Sans TC"/>
               </a:rPr>
-              <a:t>→ approach + tests</a:t>
+              <a:t>→ approach + test intent</a:t>
             </a:r>
           </a:p>
         </p:txBody>
@@ -10252,7 +10252,7 @@
                 <a:ea typeface="Noto Sans TC"/>
                 <a:cs typeface="Noto Sans TC"/>
               </a:rPr>
-              <a:t>portfolio split</a:t>
+              <a:t>roadmap decomposition</a:t>
             </a:r>
           </a:p>
           <a:p xmlns:a="http://schemas.openxmlformats.org/drawingml/2006/main">
@@ -10276,7 +10276,7 @@
                 <a:ea typeface="Noto Sans TC"/>
                 <a:cs typeface="Noto Sans TC"/>
               </a:rPr>
-              <a:t>→ Roadmap / Waves</a:t>
+              <a:t>→ Epics / Waves</a:t>
             </a:r>
           </a:p>
         </p:txBody>
@@ -10368,7 +10368,7 @@
                 <a:ea typeface="Noto Sans TC"/>
                 <a:cs typeface="Noto Sans TC"/>
               </a:rPr>
-              <a:t>feature split</a:t>
+              <a:t>feature decomposition</a:t>
             </a:r>
           </a:p>
           <a:p xmlns:a="http://schemas.openxmlformats.org/drawingml/2006/main">
@@ -10508,7 +10508,7 @@
                 <a:ea typeface="Noto Sans TC"/>
                 <a:cs typeface="Noto Sans TC"/>
               </a:rPr>
-              <a:t>→ P0 + Blocked by</a:t>
+              <a:t>→ P0 slices + blockers</a:t>
             </a:r>
           </a:p>
         </p:txBody>
@@ -10600,7 +10600,7 @@
                 <a:ea typeface="Noto Sans TC"/>
                 <a:cs typeface="Noto Sans TC"/>
               </a:rPr>
-              <a:t>writing-plans JIT</a:t>
+              <a:t>inline / JIT plan</a:t>
             </a:r>
           </a:p>
           <a:p xmlns:a="http://schemas.openxmlformats.org/drawingml/2006/main">
@@ -10624,7 +10624,7 @@
                 <a:ea typeface="Noto Sans TC"/>
                 <a:cs typeface="Noto Sans TC"/>
               </a:rPr>
-              <a:t>→ files + tests</a:t>
+              <a:t>→ tasks + files/tests</a:t>
             </a:r>
           </a:p>
         </p:txBody>
@@ -10808,7 +10808,7 @@
                 <a:ea typeface="Noto Sans TC"/>
                 <a:cs typeface="Noto Sans TC"/>
               </a:rPr>
-              <a:t>through P2/P1/P0</a:t>
+              <a:t>run P2/P1/P0 flows</a:t>
             </a:r>
           </a:p>
           <a:p xmlns:a="http://schemas.openxmlformats.org/drawingml/2006/main">
@@ -10832,7 +10832,7 @@
                 <a:ea typeface="Noto Sans TC"/>
                 <a:cs typeface="Noto Sans TC"/>
               </a:rPr>
-              <a:t>→ increments</a:t>
+              <a:t>→ working increments</a:t>
             </a:r>
           </a:p>
         </p:txBody>
@@ -10924,7 +10924,7 @@
                 <a:ea typeface="Noto Sans TC"/>
                 <a:cs typeface="Noto Sans TC"/>
               </a:rPr>
-              <a:t>through P1/P0</a:t>
+              <a:t>run P1/P0 flows</a:t>
             </a:r>
           </a:p>
           <a:p xmlns:a="http://schemas.openxmlformats.org/drawingml/2006/main">
@@ -10948,7 +10948,7 @@
                 <a:ea typeface="Noto Sans TC"/>
                 <a:cs typeface="Noto Sans TC"/>
               </a:rPr>
-              <a:t>→ increments</a:t>
+              <a:t>→ feature increments</a:t>
             </a:r>
           </a:p>
         </p:txBody>
@@ -11040,7 +11040,7 @@
                 <a:ea typeface="Noto Sans TC"/>
                 <a:cs typeface="Noto Sans TC"/>
               </a:rPr>
-              <a:t>frontier P0s</a:t>
+              <a:t>run frontier P0s</a:t>
             </a:r>
           </a:p>
           <a:p xmlns:a="http://schemas.openxmlformats.org/drawingml/2006/main">
@@ -11064,7 +11064,7 @@
                 <a:ea typeface="Noto Sans TC"/>
                 <a:cs typeface="Noto Sans TC"/>
               </a:rPr>
-              <a:t>→ accepted slices</a:t>
+              <a:t>→ increments + tests</a:t>
             </a:r>
           </a:p>
         </p:txBody>
@@ -11480,7 +11480,7 @@
                 <a:ea typeface="Noto Sans TC"/>
                 <a:cs typeface="Noto Sans TC"/>
               </a:rPr>
-              <a:t>E2E + rollout</a:t>
+              <a:t>E2E + contract/NFR</a:t>
             </a:r>
           </a:p>
           <a:p xmlns:a="http://schemas.openxmlformats.org/drawingml/2006/main">
@@ -11596,7 +11596,7 @@
                 <a:ea typeface="Noto Sans TC"/>
                 <a:cs typeface="Noto Sans TC"/>
               </a:rPr>
-              <a:t>P0 rollup + review</a:t>
+              <a:t>P0 evidence rollup</a:t>
             </a:r>
           </a:p>
           <a:p xmlns:a="http://schemas.openxmlformats.org/drawingml/2006/main">
@@ -11757,8 +11757,8 @@
         </p:nvSpPr>
         <p:spPr>
           <a:xfrm xmlns:a="http://schemas.openxmlformats.org/drawingml/2006/main">
-            <a:off x="400050" y="6038850"/>
-            <a:ext cx="9525000" cy="247650"/>
+            <a:off x="400050" y="5943600"/>
+            <a:ext cx="10572750" cy="514350"/>
           </a:xfrm>
           <a:prstGeom xmlns:a="http://schemas.openxmlformats.org/drawingml/2006/main" prst="rect">
             <a:avLst/>
@@ -11795,7 +11795,31 @@
                 <a:ea typeface="Noto Sans TC"/>
                 <a:cs typeface="Noto Sans TC"/>
               </a:rPr>
-              <a:t>Output 留在既有 ticket、OpenSpec、ADR、PR 或 test report；不新增文件。</a:t>
+              <a:t>* SD：P3/P2 required · P1 risk-triggered · P0 normally skip</a:t>
+            </a:r>
+          </a:p>
+          <a:p xmlns:a="http://schemas.openxmlformats.org/drawingml/2006/main">
+            <a:pPr algn="l">
+              <a:buNone/>
+              <a:defRPr sz="1050" b="0">
+                <a:solidFill>
+                  <a:srgbClr val="5C6570"/>
+                </a:solidFill>
+                <a:latin typeface="Noto Sans TC"/>
+                <a:ea typeface="Noto Sans TC"/>
+                <a:cs typeface="Noto Sans TC"/>
+              </a:defRPr>
+            </a:pPr>
+            <a:r>
+              <a:rPr sz="1600" b="0">
+                <a:solidFill>
+                  <a:srgbClr val="606B7A"/>
+                </a:solidFill>
+                <a:latin typeface="Noto Sans TC"/>
+                <a:ea typeface="Noto Sans TC"/>
+                <a:cs typeface="Noto Sans TC"/>
+              </a:rPr>
+              <a:t>Default route：Archetype / Control Profile 調整 rigor 與 evidence。Output 留在既有 artifacts，不新增文件。</a:t>
             </a:r>
           </a:p>
         </p:txBody>
@@ -11890,7 +11914,7 @@
       </p:sp>
       <p:cxnSp>
         <p:nvCxnSpPr>
-          <p:cNvPr id="49" name=""/>
+          <p:cNvPr id="63" name=""/>
           <p:cNvCxnSpPr/>
           <p:nvPr/>
         </p:nvCxnSpPr>
@@ -11971,7 +11995,7 @@
       </p:sp>
       <p:cxnSp>
         <p:nvCxnSpPr>
-          <p:cNvPr id="51" name=""/>
+          <p:cNvPr id="65" name=""/>
           <p:cNvCxnSpPr/>
           <p:nvPr/>
         </p:nvCxnSpPr>
@@ -11993,7 +12017,7 @@
       </p:cxnSp>
       <p:cxnSp>
         <p:nvCxnSpPr>
-          <p:cNvPr id="52" name=""/>
+          <p:cNvPr id="66" name=""/>
           <p:cNvCxnSpPr/>
           <p:nvPr/>
         </p:nvCxnSpPr>
@@ -12015,7 +12039,7 @@
       </p:cxnSp>
       <p:cxnSp>
         <p:nvCxnSpPr>
-          <p:cNvPr id="53" name=""/>
+          <p:cNvPr id="67" name=""/>
           <p:cNvCxnSpPr/>
           <p:nvPr/>
         </p:nvCxnSpPr>
@@ -12037,7 +12061,7 @@
       </p:cxnSp>
       <p:cxnSp>
         <p:nvCxnSpPr>
-          <p:cNvPr id="54" name=""/>
+          <p:cNvPr id="68" name=""/>
           <p:cNvCxnSpPr/>
           <p:nvPr/>
         </p:nvCxnSpPr>
@@ -13116,7 +13140,7 @@
       </p:sp>
       <p:cxnSp>
         <p:nvCxnSpPr>
-          <p:cNvPr id="33" name=""/>
+          <p:cNvPr id="37" name=""/>
           <p:cNvCxnSpPr/>
           <p:nvPr/>
         </p:nvCxnSpPr>
@@ -14571,7 +14595,7 @@
       </p:sp>
       <p:cxnSp>
         <p:nvCxnSpPr>
-          <p:cNvPr id="38" name=""/>
+          <p:cNvPr id="42" name=""/>
           <p:cNvCxnSpPr/>
           <p:nvPr/>
         </p:nvCxnSpPr>
@@ -16137,7 +16161,7 @@
       </p:sp>
       <p:cxnSp>
         <p:nvCxnSpPr>
-          <p:cNvPr id="105" name=""/>
+          <p:cNvPr id="155" name=""/>
           <p:cNvCxnSpPr/>
           <p:nvPr/>
         </p:nvCxnSpPr>
@@ -16553,7 +16577,7 @@
       </p:sp>
       <p:cxnSp>
         <p:nvCxnSpPr>
-          <p:cNvPr id="112" name=""/>
+          <p:cNvPr id="162" name=""/>
           <p:cNvCxnSpPr/>
           <p:nvPr/>
         </p:nvCxnSpPr>
@@ -17028,7 +17052,7 @@
       </p:sp>
       <p:cxnSp>
         <p:nvCxnSpPr>
-          <p:cNvPr id="120" name=""/>
+          <p:cNvPr id="170" name=""/>
           <p:cNvCxnSpPr/>
           <p:nvPr/>
         </p:nvCxnSpPr>
@@ -17503,7 +17527,7 @@
       </p:sp>
       <p:cxnSp>
         <p:nvCxnSpPr>
-          <p:cNvPr id="128" name=""/>
+          <p:cNvPr id="178" name=""/>
           <p:cNvCxnSpPr/>
           <p:nvPr/>
         </p:nvCxnSpPr>

</xml_diff>

<commit_message>
Add AI Engineering target outcome slide
</commit_message>
<xml_diff>
--- a/presentation/06_Training_Presentation.pptx
+++ b/presentation/06_Training_Presentation.pptx
@@ -2,22 +2,23 @@
 <file path=ppt/presentation.xml><?xml version="1.0" encoding="utf-8"?>
 <p:presentation xmlns:p="http://schemas.openxmlformats.org/presentationml/2006/main">
   <p:sldMasterIdLst>
-    <p:sldMasterId xmlns:r="http://schemas.openxmlformats.org/officeDocument/2006/relationships" id="2147483648" r:id="Rbd2b5d38c8ac4e61"/>
+    <p:sldMasterId xmlns:r="http://schemas.openxmlformats.org/officeDocument/2006/relationships" id="2147483648" r:id="R6902ea8fb1424bcc"/>
   </p:sldMasterIdLst>
   <p:notesMasterIdLst>
-    <p:notesMasterId xmlns:r="http://schemas.openxmlformats.org/officeDocument/2006/relationships" r:id="Ra54a3ddc9adb45c9"/>
+    <p:notesMasterId xmlns:r="http://schemas.openxmlformats.org/officeDocument/2006/relationships" r:id="R5192e9d091c140a4"/>
   </p:notesMasterIdLst>
   <p:sldIdLst>
-    <p:sldId xmlns:r="http://schemas.openxmlformats.org/officeDocument/2006/relationships" id="256" r:id="R33d1db4246034d22"/>
-    <p:sldId xmlns:r="http://schemas.openxmlformats.org/officeDocument/2006/relationships" id="257" r:id="R1ab2c926f94b4c9e"/>
-    <p:sldId xmlns:r="http://schemas.openxmlformats.org/officeDocument/2006/relationships" id="258" r:id="R5eae3d06adfc49ba"/>
-    <p:sldId xmlns:r="http://schemas.openxmlformats.org/officeDocument/2006/relationships" id="259" r:id="Rd4c7effb1c3d42f5"/>
-    <p:sldId xmlns:r="http://schemas.openxmlformats.org/officeDocument/2006/relationships" id="260" r:id="Rdd7acb73e5de4d9e"/>
-    <p:sldId xmlns:r="http://schemas.openxmlformats.org/officeDocument/2006/relationships" id="261" r:id="R1dd17bf9a25348c7"/>
-    <p:sldId xmlns:r="http://schemas.openxmlformats.org/officeDocument/2006/relationships" id="262" r:id="Rb98738003c47409a"/>
-    <p:sldId xmlns:r="http://schemas.openxmlformats.org/officeDocument/2006/relationships" id="263" r:id="R2f7987e584ad425b"/>
-    <p:sldId xmlns:r="http://schemas.openxmlformats.org/officeDocument/2006/relationships" id="264" r:id="R2e62dbe84aa14511"/>
-    <p:sldId xmlns:r="http://schemas.openxmlformats.org/officeDocument/2006/relationships" id="265" r:id="Rb4f53dce95b34d32"/>
+    <p:sldId xmlns:r="http://schemas.openxmlformats.org/officeDocument/2006/relationships" id="256" r:id="R50a988b24d04466e"/>
+    <p:sldId xmlns:r="http://schemas.openxmlformats.org/officeDocument/2006/relationships" id="257" r:id="R9ba16b42ebf34437"/>
+    <p:sldId xmlns:r="http://schemas.openxmlformats.org/officeDocument/2006/relationships" id="258" r:id="R8639e1e630bc4f03"/>
+    <p:sldId xmlns:r="http://schemas.openxmlformats.org/officeDocument/2006/relationships" id="259" r:id="R311c6c901d38475a"/>
+    <p:sldId xmlns:r="http://schemas.openxmlformats.org/officeDocument/2006/relationships" id="260" r:id="R9f486f1a06104806"/>
+    <p:sldId xmlns:r="http://schemas.openxmlformats.org/officeDocument/2006/relationships" id="261" r:id="R09c52771eb894b36"/>
+    <p:sldId xmlns:r="http://schemas.openxmlformats.org/officeDocument/2006/relationships" id="262" r:id="Ra9c8c97b737940d7"/>
+    <p:sldId xmlns:r="http://schemas.openxmlformats.org/officeDocument/2006/relationships" id="263" r:id="Rf4510ca3911f4122"/>
+    <p:sldId xmlns:r="http://schemas.openxmlformats.org/officeDocument/2006/relationships" id="264" r:id="R60893d42da734280"/>
+    <p:sldId xmlns:r="http://schemas.openxmlformats.org/officeDocument/2006/relationships" id="265" r:id="Rb5e6e338a256444a"/>
+    <p:sldId xmlns:r="http://schemas.openxmlformats.org/officeDocument/2006/relationships" id="266" r:id="R2c39608964f04472"/>
   </p:sldIdLst>
   <p:sldSz cx="12192000" cy="6858000"/>
   <p:notesSz cx="6858000" cy="9144000"/>
@@ -638,6 +639,72 @@
 </p:notes>
 </file>
 
+<file path=ppt/notesSlides/notesSlide11.xml><?xml version="1.0" encoding="utf-8"?>
+<p:notes xmlns:p="http://schemas.openxmlformats.org/presentationml/2006/main">
+  <p:cSld>
+    <p:spTree>
+      <p:nvGrpSpPr>
+        <p:cNvPr id="1" name=""/>
+        <p:cNvGrpSpPr/>
+        <p:nvPr/>
+      </p:nvGrpSpPr>
+      <p:grpSpPr>
+        <a:xfrm xmlns:a="http://schemas.openxmlformats.org/drawingml/2006/main"/>
+      </p:grpSpPr>
+      <p:sp>
+        <p:nvSpPr>
+          <p:cNvPr id="2" name="Slide Image Placeholder 1"/>
+          <p:cNvSpPr>
+            <a:spLocks xmlns:a="http://schemas.openxmlformats.org/drawingml/2006/main" noGrp="1"/>
+          </p:cNvSpPr>
+          <p:nvPr>
+            <p:ph type="sldImg" idx="0"/>
+          </p:nvPr>
+        </p:nvSpPr>
+        <p:spPr/>
+      </p:sp>
+      <p:sp>
+        <p:nvSpPr>
+          <p:cNvPr id="3" name="Notes Placeholder 2"/>
+          <p:cNvSpPr>
+            <a:spLocks xmlns:a="http://schemas.openxmlformats.org/drawingml/2006/main" noGrp="1"/>
+          </p:cNvSpPr>
+          <p:nvPr>
+            <p:ph type="body" idx="1"/>
+          </p:nvPr>
+        </p:nvSpPr>
+        <p:spPr/>
+        <p:txBody>
+          <a:bodyPr xmlns:a="http://schemas.openxmlformats.org/drawingml/2006/main"/>
+          <a:lstStyle xmlns:a="http://schemas.openxmlformats.org/drawingml/2006/main"/>
+          <a:p xmlns:a="http://schemas.openxmlformats.org/drawingml/2006/main"/>
+        </p:txBody>
+      </p:sp>
+      <p:sp>
+        <p:nvSpPr>
+          <p:cNvPr id="4" name="Slide Number Placeholder 3"/>
+          <p:cNvSpPr>
+            <a:spLocks xmlns:a="http://schemas.openxmlformats.org/drawingml/2006/main" noGrp="1"/>
+          </p:cNvSpPr>
+          <p:nvPr>
+            <p:ph type="sldNum" idx="5"/>
+          </p:nvPr>
+        </p:nvSpPr>
+        <p:spPr/>
+        <p:txBody>
+          <a:bodyPr xmlns:a="http://schemas.openxmlformats.org/drawingml/2006/main"/>
+          <a:lstStyle xmlns:a="http://schemas.openxmlformats.org/drawingml/2006/main"/>
+          <a:p xmlns:a="http://schemas.openxmlformats.org/drawingml/2006/main"/>
+        </p:txBody>
+      </p:sp>
+    </p:spTree>
+  </p:cSld>
+  <p:clrMapOvr>
+    <a:masterClrMapping xmlns:a="http://schemas.openxmlformats.org/drawingml/2006/main"/>
+  </p:clrMapOvr>
+</p:notes>
+</file>
+
 <file path=ppt/notesSlides/notesSlide2.xml><?xml version="1.0" encoding="utf-8"?>
 <p:notes xmlns:p="http://schemas.openxmlformats.org/presentationml/2006/main">
   <p:cSld>
@@ -1204,7 +1271,7 @@
   </p:cSld>
   <p:clrMap bg1="lt1" tx1="dk1" bg2="lt2" tx2="dk2" accent1="accent1" accent2="accent2" accent3="accent3" accent4="accent4" accent5="accent5" accent6="accent6" hlink="hlink" folHlink="folHlink"/>
   <p:sldLayoutIdLst>
-    <p:sldLayoutId xmlns:r="http://schemas.openxmlformats.org/officeDocument/2006/relationships" id="2147483649" r:id="R111d965d6f2e4ddf"/>
+    <p:sldLayoutId xmlns:r="http://schemas.openxmlformats.org/officeDocument/2006/relationships" id="2147483649" r:id="R05725fae5108411f"/>
   </p:sldLayoutIdLst>
   <p:txStyles>
     <p:titleStyle>
@@ -1731,6 +1798,311 @@
 </a:theme>
 </file>
 
+<file path=ppt/slides/charts/chart1.xml><?xml version="1.0" encoding="utf-8"?>
+<c:chartSpace xmlns:c="http://schemas.openxmlformats.org/drawingml/2006/chart">
+  <c:lang val="en-US"/>
+  <c:chart>
+    <c:plotArea>
+      <c:barChart>
+        <c:barDir val="bar"/>
+        <c:grouping val="stacked"/>
+        <c:varyColors val="0"/>
+        <c:ser>
+          <c:idx val="0"/>
+          <c:order val="0"/>
+          <c:tx>
+            <c:v>Research</c:v>
+          </c:tx>
+          <c:spPr>
+            <a:solidFill xmlns:a="http://schemas.openxmlformats.org/drawingml/2006/main">
+              <a:srgbClr val="163A53"/>
+            </a:solidFill>
+          </c:spPr>
+          <c:cat>
+            <c:strLit>
+              <c:ptCount val="2"/>
+              <c:pt idx="0">
+                <c:v> </c:v>
+              </c:pt>
+              <c:pt idx="1">
+                <c:v>  </c:v>
+              </c:pt>
+            </c:strLit>
+          </c:cat>
+          <c:val>
+            <c:numLit>
+              <c:formatCode>General</c:formatCode>
+              <c:ptCount val="2"/>
+              <c:pt idx="0">
+                <c:v>22</c:v>
+              </c:pt>
+              <c:pt idx="1">
+                <c:v>12</c:v>
+              </c:pt>
+            </c:numLit>
+          </c:val>
+        </c:ser>
+        <c:ser>
+          <c:idx val="1"/>
+          <c:order val="1"/>
+          <c:tx>
+            <c:v>Design</c:v>
+          </c:tx>
+          <c:spPr>
+            <a:solidFill xmlns:a="http://schemas.openxmlformats.org/drawingml/2006/main">
+              <a:srgbClr val="4D80B8"/>
+            </a:solidFill>
+          </c:spPr>
+          <c:cat>
+            <c:strLit>
+              <c:ptCount val="2"/>
+              <c:pt idx="0">
+                <c:v> </c:v>
+              </c:pt>
+              <c:pt idx="1">
+                <c:v>  </c:v>
+              </c:pt>
+            </c:strLit>
+          </c:cat>
+          <c:val>
+            <c:numLit>
+              <c:formatCode>General</c:formatCode>
+              <c:ptCount val="2"/>
+              <c:pt idx="0">
+                <c:v>24</c:v>
+              </c:pt>
+              <c:pt idx="1">
+                <c:v>10</c:v>
+              </c:pt>
+            </c:numLit>
+          </c:val>
+        </c:ser>
+        <c:ser>
+          <c:idx val="2"/>
+          <c:order val="2"/>
+          <c:tx>
+            <c:v>Plan</c:v>
+          </c:tx>
+          <c:spPr>
+            <a:solidFill xmlns:a="http://schemas.openxmlformats.org/drawingml/2006/main">
+              <a:srgbClr val="A7B4BE"/>
+            </a:solidFill>
+          </c:spPr>
+          <c:cat>
+            <c:strLit>
+              <c:ptCount val="2"/>
+              <c:pt idx="0">
+                <c:v> </c:v>
+              </c:pt>
+              <c:pt idx="1">
+                <c:v>  </c:v>
+              </c:pt>
+            </c:strLit>
+          </c:cat>
+          <c:val>
+            <c:numLit>
+              <c:formatCode>General</c:formatCode>
+              <c:ptCount val="2"/>
+              <c:pt idx="0">
+                <c:v>10</c:v>
+              </c:pt>
+              <c:pt idx="1">
+                <c:v>5</c:v>
+              </c:pt>
+            </c:numLit>
+          </c:val>
+        </c:ser>
+        <c:ser>
+          <c:idx val="3"/>
+          <c:order val="3"/>
+          <c:tx>
+            <c:v>Implement</c:v>
+          </c:tx>
+          <c:spPr>
+            <a:solidFill xmlns:a="http://schemas.openxmlformats.org/drawingml/2006/main">
+              <a:srgbClr val="5C6570"/>
+            </a:solidFill>
+          </c:spPr>
+          <c:cat>
+            <c:strLit>
+              <c:ptCount val="2"/>
+              <c:pt idx="0">
+                <c:v> </c:v>
+              </c:pt>
+              <c:pt idx="1">
+                <c:v>  </c:v>
+              </c:pt>
+            </c:strLit>
+          </c:cat>
+          <c:val>
+            <c:numLit>
+              <c:formatCode>General</c:formatCode>
+              <c:ptCount val="2"/>
+              <c:pt idx="0">
+                <c:v>8</c:v>
+              </c:pt>
+              <c:pt idx="1">
+                <c:v>55</c:v>
+              </c:pt>
+            </c:numLit>
+          </c:val>
+        </c:ser>
+        <c:ser>
+          <c:idx val="4"/>
+          <c:order val="4"/>
+          <c:tx>
+            <c:v>Validate</c:v>
+          </c:tx>
+          <c:spPr>
+            <a:solidFill xmlns:a="http://schemas.openxmlformats.org/drawingml/2006/main">
+              <a:srgbClr val="46B8DF"/>
+            </a:solidFill>
+          </c:spPr>
+          <c:cat>
+            <c:strLit>
+              <c:ptCount val="2"/>
+              <c:pt idx="0">
+                <c:v> </c:v>
+              </c:pt>
+              <c:pt idx="1">
+                <c:v>  </c:v>
+              </c:pt>
+            </c:strLit>
+          </c:cat>
+          <c:val>
+            <c:numLit>
+              <c:formatCode>General</c:formatCode>
+              <c:ptCount val="2"/>
+              <c:pt idx="0">
+                <c:v>36</c:v>
+              </c:pt>
+              <c:pt idx="1">
+                <c:v>18</c:v>
+              </c:pt>
+            </c:numLit>
+          </c:val>
+        </c:ser>
+        <c:gapWidth val="48"/>
+        <c:overlap val="100"/>
+        <c:axId val="48650112"/>
+        <c:axId val="48672768"/>
+      </c:barChart>
+      <c:catAx>
+        <c:axId val="48650112"/>
+        <c:scaling>
+          <c:orientation val="minMax"/>
+        </c:scaling>
+        <c:delete val="0"/>
+        <c:axPos val="l"/>
+        <c:numFmt formatCode="General"/>
+        <c:majorTickMark val="none"/>
+        <c:minorTickMark val="none"/>
+        <c:spPr>
+          <a:ln xmlns:a="http://schemas.openxmlformats.org/drawingml/2006/main" w="9525">
+            <a:solidFill>
+              <a:srgbClr val="D4D4D4"/>
+            </a:solidFill>
+            <a:prstDash val="solid"/>
+          </a:ln>
+        </c:spPr>
+        <c:txPr>
+          <a:bodyPr xmlns:a="http://schemas.openxmlformats.org/drawingml/2006/main" anchorCtr="1"/>
+          <a:lstStyle xmlns:a="http://schemas.openxmlformats.org/drawingml/2006/main"/>
+          <a:p xmlns:a="http://schemas.openxmlformats.org/drawingml/2006/main">
+            <a:pPr>
+              <a:defRPr>
+                <a:solidFill>
+                  <a:srgbClr val="666666"/>
+                </a:solidFill>
+              </a:defRPr>
+            </a:pPr>
+          </a:p>
+        </c:txPr>
+        <c:crossAx val="48672768"/>
+        <c:lblAlgn val="ctr"/>
+        <c:lblOffset val="100"/>
+        <c:noMultiLvlLbl val="0"/>
+      </c:catAx>
+      <c:valAx>
+        <c:axId val="48672768"/>
+        <c:scaling>
+          <c:orientation val="minMax"/>
+        </c:scaling>
+        <c:delete val="0"/>
+        <c:axPos val="b"/>
+        <c:numFmt formatCode="General"/>
+        <c:majorTickMark val="none"/>
+        <c:minorTickMark val="none"/>
+        <c:tickLblPos val="none"/>
+        <c:spPr>
+          <a:ln xmlns:a="http://schemas.openxmlformats.org/drawingml/2006/main" w="0">
+            <a:solidFill>
+              <a:srgbClr val="FFFFFF"/>
+            </a:solidFill>
+            <a:prstDash val="solid"/>
+          </a:ln>
+        </c:spPr>
+        <c:txPr>
+          <a:bodyPr xmlns:a="http://schemas.openxmlformats.org/drawingml/2006/main" anchorCtr="1"/>
+          <a:lstStyle xmlns:a="http://schemas.openxmlformats.org/drawingml/2006/main"/>
+          <a:p xmlns:a="http://schemas.openxmlformats.org/drawingml/2006/main">
+            <a:pPr>
+              <a:defRPr sz="100">
+                <a:solidFill>
+                  <a:srgbClr val="FFFFFF"/>
+                </a:solidFill>
+              </a:defRPr>
+            </a:pPr>
+          </a:p>
+        </c:txPr>
+        <c:crossAx val="48650112"/>
+        <c:crossBetween val="between"/>
+      </c:valAx>
+      <c:spPr>
+        <a:solidFill xmlns:a="http://schemas.openxmlformats.org/drawingml/2006/main">
+          <a:srgbClr val="FFFFFF"/>
+        </a:solidFill>
+        <a:ln xmlns:a="http://schemas.openxmlformats.org/drawingml/2006/main" w="0">
+          <a:solidFill>
+            <a:srgbClr val="FFFFFF"/>
+          </a:solidFill>
+          <a:prstDash val="solid"/>
+        </a:ln>
+      </c:spPr>
+    </c:plotArea>
+    <c:legend>
+      <c:legendPos val="t"/>
+      <c:overlay val="0"/>
+      <c:txPr>
+        <a:bodyPr xmlns:a="http://schemas.openxmlformats.org/drawingml/2006/main" anchorCtr="1"/>
+        <a:lstStyle xmlns:a="http://schemas.openxmlformats.org/drawingml/2006/main"/>
+        <a:p xmlns:a="http://schemas.openxmlformats.org/drawingml/2006/main">
+          <a:pPr>
+            <a:defRPr sz="1125">
+              <a:solidFill>
+                <a:srgbClr val="4F5B66"/>
+              </a:solidFill>
+            </a:defRPr>
+          </a:pPr>
+        </a:p>
+      </c:txPr>
+    </c:legend>
+    <c:plotVisOnly val="1"/>
+  </c:chart>
+  <c:spPr>
+    <a:solidFill xmlns:a="http://schemas.openxmlformats.org/drawingml/2006/main">
+      <a:srgbClr val="FFFFFF"/>
+    </a:solidFill>
+    <a:ln xmlns:a="http://schemas.openxmlformats.org/drawingml/2006/main" w="0">
+      <a:solidFill>
+        <a:srgbClr val="FFFFFF"/>
+      </a:solidFill>
+      <a:prstDash val="solid"/>
+    </a:ln>
+  </c:spPr>
+</c:chartSpace>
+</file>
+
 <file path=ppt/slides/slide1.xml><?xml version="1.0" encoding="utf-8"?>
 <p:sld xmlns:p="http://schemas.openxmlformats.org/presentationml/2006/main">
   <p:cSld>
@@ -2095,7 +2467,7 @@
                 <a:ea typeface="Noto Sans TC"/>
                 <a:cs typeface="Noto Sans TC"/>
               </a:rPr>
-              <a:t>v1.2 Baseline Candidate</a:t>
+              <a:t>v1.3 Baseline Candidate</a:t>
             </a:r>
           </a:p>
         </p:txBody>
@@ -2134,66 +2506,7 @@
           <p:cNvPr id="1" name="">
             <a:extLst xmlns:a="http://schemas.openxmlformats.org/drawingml/2006/main">
               <a:ext uri="{FF2B5EF4-FFF2-40B4-BE49-F238E27FC236}">
-                <a16:creationId xmlns:a16="http://schemas.microsoft.com/office/drawing/2014/main" id="{B983216B-B198-4B14-A0A9-6CF04FB5A868}"/>
-              </a:ext>
-            </a:extLst>
-          </p:cNvPr>
-          <p:cNvSpPr>
-            <a:spLocks xmlns:a="http://schemas.openxmlformats.org/drawingml/2006/main" noGrp="1"/>
-          </p:cNvSpPr>
-          <p:nvPr/>
-        </p:nvSpPr>
-        <p:spPr>
-          <a:xfrm xmlns:a="http://schemas.openxmlformats.org/drawingml/2006/main">
-            <a:off x="400050" y="247650"/>
-            <a:ext cx="4953000" cy="228600"/>
-          </a:xfrm>
-          <a:prstGeom xmlns:a="http://schemas.openxmlformats.org/drawingml/2006/main" prst="rect">
-            <a:avLst/>
-          </a:prstGeom>
-          <a:noFill xmlns:a="http://schemas.openxmlformats.org/drawingml/2006/main"/>
-          <a:ln xmlns:a="http://schemas.openxmlformats.org/drawingml/2006/main" w="0">
-            <a:noFill/>
-            <a:prstDash val="solid"/>
-          </a:ln>
-        </p:spPr>
-        <p:txBody>
-          <a:bodyPr xmlns:a="http://schemas.openxmlformats.org/drawingml/2006/main" wrap="square" lIns="0" tIns="0" rIns="0" bIns="0" anchor="t">
-            <a:normAutofit fontScale="100000"/>
-          </a:bodyPr>
-          <a:lstStyle xmlns:a="http://schemas.openxmlformats.org/drawingml/2006/main"/>
-          <a:p xmlns:a="http://schemas.openxmlformats.org/drawingml/2006/main">
-            <a:pPr algn="l">
-              <a:buNone/>
-              <a:defRPr sz="900" b="1">
-                <a:solidFill>
-                  <a:srgbClr val="2478E5"/>
-                </a:solidFill>
-                <a:latin typeface="Nimbus Sans"/>
-                <a:ea typeface="Nimbus Sans"/>
-                <a:cs typeface="Nimbus Sans"/>
-              </a:defRPr>
-            </a:pPr>
-            <a:r>
-              <a:rPr sz="900" b="1">
-                <a:solidFill>
-                  <a:srgbClr val="2478E5"/>
-                </a:solidFill>
-                <a:latin typeface="Nimbus Sans"/>
-                <a:ea typeface="Nimbus Sans"/>
-                <a:cs typeface="Nimbus Sans"/>
-              </a:rPr>
-              <a:t>START USING IT</a:t>
-            </a:r>
-          </a:p>
-        </p:txBody>
-      </p:sp>
-      <p:sp>
-        <p:nvSpPr>
-          <p:cNvPr id="2" name="">
-            <a:extLst xmlns:a="http://schemas.openxmlformats.org/drawingml/2006/main">
-              <a:ext uri="{FF2B5EF4-FFF2-40B4-BE49-F238E27FC236}">
-                <a16:creationId xmlns:a16="http://schemas.microsoft.com/office/drawing/2014/main" id="{1D367F9D-C209-4CBC-B9DD-AB7A7D101EB1}"/>
+                <a16:creationId xmlns:a16="http://schemas.microsoft.com/office/drawing/2014/main" id="{93FE033D-66FD-48F9-BD5B-BB55095EECC8}"/>
               </a:ext>
             </a:extLst>
           </p:cNvPr>
@@ -2242,14 +2555,14 @@
                 <a:ea typeface="Noto Sans TC"/>
                 <a:cs typeface="Noto Sans TC"/>
               </a:rPr>
-              <a:t>從下一張真實 work item 開始，而不是先建立新 ceremony</a:t>
+              <a:t>把時間從 coding 移向 research、design 與 evidence</a:t>
             </a:r>
           </a:p>
         </p:txBody>
       </p:sp>
       <p:cxnSp>
         <p:nvCxnSpPr>
-          <p:cNvPr id="137" name=""/>
+          <p:cNvPr id="183" name=""/>
           <p:cNvCxnSpPr/>
           <p:nvPr/>
         </p:nvCxnSpPr>
@@ -2271,10 +2584,10 @@
       </p:cxnSp>
       <p:sp>
         <p:nvSpPr>
-          <p:cNvPr id="4" name="">
-            <a:extLst xmlns:a="http://schemas.openxmlformats.org/drawingml/2006/main">
-              <a:ext uri="{FF2B5EF4-FFF2-40B4-BE49-F238E27FC236}">
-                <a16:creationId xmlns:a16="http://schemas.microsoft.com/office/drawing/2014/main" id="{05575A72-5745-4C7E-B098-7D5AF62AE39C}"/>
+          <p:cNvPr id="3" name="">
+            <a:extLst xmlns:a="http://schemas.openxmlformats.org/drawingml/2006/main">
+              <a:ext uri="{FF2B5EF4-FFF2-40B4-BE49-F238E27FC236}">
+                <a16:creationId xmlns:a16="http://schemas.microsoft.com/office/drawing/2014/main" id="{572C6BFC-F52C-44C1-8405-957119A62B73}"/>
               </a:ext>
             </a:extLst>
           </p:cNvPr>
@@ -2315,7 +2628,7 @@
               </a:defRPr>
             </a:pPr>
             <a:r>
-              <a:rPr sz="900" b="0">
+              <a:rPr sz="1200" b="0">
                 <a:solidFill>
                   <a:srgbClr val="5C6570"/>
                 </a:solidFill>
@@ -2330,22 +2643,204 @@
       </p:sp>
       <p:sp>
         <p:nvSpPr>
+          <p:cNvPr id="4" name="">
+            <a:extLst xmlns:a="http://schemas.openxmlformats.org/drawingml/2006/main">
+              <a:ext uri="{FF2B5EF4-FFF2-40B4-BE49-F238E27FC236}">
+                <a16:creationId xmlns:a16="http://schemas.microsoft.com/office/drawing/2014/main" id="{2CA4A3A1-68E1-4207-AFA4-D8A95211607B}"/>
+              </a:ext>
+            </a:extLst>
+          </p:cNvPr>
+          <p:cNvSpPr>
+            <a:spLocks xmlns:a="http://schemas.openxmlformats.org/drawingml/2006/main" noGrp="1"/>
+          </p:cNvSpPr>
+          <p:nvPr/>
+        </p:nvSpPr>
+        <p:spPr>
+          <a:xfrm xmlns:a="http://schemas.openxmlformats.org/drawingml/2006/main">
+            <a:off x="400050" y="4552950"/>
+            <a:ext cx="3476625" cy="1295400"/>
+          </a:xfrm>
+          <a:prstGeom xmlns:a="http://schemas.openxmlformats.org/drawingml/2006/main" prst="rect">
+            <a:avLst/>
+          </a:prstGeom>
+          <a:noFill xmlns:a="http://schemas.openxmlformats.org/drawingml/2006/main"/>
+          <a:ln xmlns:a="http://schemas.openxmlformats.org/drawingml/2006/main" w="9525">
+            <a:solidFill>
+              <a:srgbClr val="D6DCE1"/>
+            </a:solidFill>
+            <a:prstDash val="solid"/>
+          </a:ln>
+        </p:spPr>
+      </p:sp>
+      <p:sp>
+        <p:nvSpPr>
           <p:cNvPr id="5" name="">
             <a:extLst xmlns:a="http://schemas.openxmlformats.org/drawingml/2006/main">
               <a:ext uri="{FF2B5EF4-FFF2-40B4-BE49-F238E27FC236}">
-                <a16:creationId xmlns:a16="http://schemas.microsoft.com/office/drawing/2014/main" id="{013AD55B-C19C-4B6C-A349-C2B0CC0D8EDE}"/>
-              </a:ext>
-            </a:extLst>
-          </p:cNvPr>
-          <p:cNvSpPr>
-            <a:spLocks xmlns:a="http://schemas.openxmlformats.org/drawingml/2006/main" noGrp="1"/>
-          </p:cNvSpPr>
-          <p:nvPr/>
-        </p:nvSpPr>
-        <p:spPr>
-          <a:xfrm xmlns:a="http://schemas.openxmlformats.org/drawingml/2006/main">
-            <a:off x="400050" y="1504950"/>
-            <a:ext cx="4191000" cy="266700"/>
+                <a16:creationId xmlns:a16="http://schemas.microsoft.com/office/drawing/2014/main" id="{63B5A021-266B-4788-9BBC-1258BEEF17F3}"/>
+              </a:ext>
+            </a:extLst>
+          </p:cNvPr>
+          <p:cNvSpPr>
+            <a:spLocks xmlns:a="http://schemas.openxmlformats.org/drawingml/2006/main" noGrp="1"/>
+          </p:cNvSpPr>
+          <p:nvPr/>
+        </p:nvSpPr>
+        <p:spPr>
+          <a:xfrm xmlns:a="http://schemas.openxmlformats.org/drawingml/2006/main">
+            <a:off x="400050" y="4552950"/>
+            <a:ext cx="3476625" cy="285750"/>
+          </a:xfrm>
+          <a:prstGeom xmlns:a="http://schemas.openxmlformats.org/drawingml/2006/main" prst="rect">
+            <a:avLst/>
+          </a:prstGeom>
+          <a:solidFill xmlns:a="http://schemas.openxmlformats.org/drawingml/2006/main">
+            <a:srgbClr val="163A53"/>
+          </a:solidFill>
+          <a:ln xmlns:a="http://schemas.openxmlformats.org/drawingml/2006/main" w="0">
+            <a:solidFill>
+              <a:srgbClr val="163A53"/>
+            </a:solidFill>
+            <a:prstDash val="solid"/>
+          </a:ln>
+        </p:spPr>
+      </p:sp>
+      <p:sp>
+        <p:nvSpPr>
+          <p:cNvPr id="6" name="">
+            <a:extLst xmlns:a="http://schemas.openxmlformats.org/drawingml/2006/main">
+              <a:ext uri="{FF2B5EF4-FFF2-40B4-BE49-F238E27FC236}">
+                <a16:creationId xmlns:a16="http://schemas.microsoft.com/office/drawing/2014/main" id="{47981578-E369-4BAE-B560-5A7E75603A74}"/>
+              </a:ext>
+            </a:extLst>
+          </p:cNvPr>
+          <p:cNvSpPr>
+            <a:spLocks xmlns:a="http://schemas.openxmlformats.org/drawingml/2006/main" noGrp="1"/>
+          </p:cNvSpPr>
+          <p:nvPr/>
+        </p:nvSpPr>
+        <p:spPr>
+          <a:xfrm xmlns:a="http://schemas.openxmlformats.org/drawingml/2006/main">
+            <a:off x="495300" y="4610100"/>
+            <a:ext cx="3286125" cy="171450"/>
+          </a:xfrm>
+          <a:prstGeom xmlns:a="http://schemas.openxmlformats.org/drawingml/2006/main" prst="rect">
+            <a:avLst/>
+          </a:prstGeom>
+          <a:noFill xmlns:a="http://schemas.openxmlformats.org/drawingml/2006/main"/>
+          <a:ln xmlns:a="http://schemas.openxmlformats.org/drawingml/2006/main" w="0">
+            <a:noFill/>
+            <a:prstDash val="solid"/>
+          </a:ln>
+        </p:spPr>
+        <p:txBody>
+          <a:bodyPr xmlns:a="http://schemas.openxmlformats.org/drawingml/2006/main" wrap="square" lIns="0" tIns="0" rIns="0" bIns="0" anchor="ctr">
+            <a:normAutofit fontScale="100000"/>
+          </a:bodyPr>
+          <a:lstStyle xmlns:a="http://schemas.openxmlformats.org/drawingml/2006/main"/>
+          <a:p xmlns:a="http://schemas.openxmlformats.org/drawingml/2006/main">
+            <a:pPr algn="l">
+              <a:buNone/>
+              <a:defRPr sz="975" b="1">
+                <a:solidFill>
+                  <a:srgbClr val="FFFFFF"/>
+                </a:solidFill>
+                <a:latin typeface="Noto Sans TC"/>
+                <a:ea typeface="Noto Sans TC"/>
+                <a:cs typeface="Noto Sans TC"/>
+              </a:defRPr>
+            </a:pPr>
+            <a:r>
+              <a:rPr sz="1100" b="1">
+                <a:solidFill>
+                  <a:srgbClr val="FFFFFF"/>
+                </a:solidFill>
+                <a:latin typeface="Noto Sans TC"/>
+                <a:ea typeface="Noto Sans TC"/>
+                <a:cs typeface="Noto Sans TC"/>
+              </a:rPr>
+              <a:t>DESIGN QUALITY</a:t>
+            </a:r>
+          </a:p>
+        </p:txBody>
+      </p:sp>
+      <p:sp>
+        <p:nvSpPr>
+          <p:cNvPr id="7" name="">
+            <a:extLst xmlns:a="http://schemas.openxmlformats.org/drawingml/2006/main">
+              <a:ext uri="{FF2B5EF4-FFF2-40B4-BE49-F238E27FC236}">
+                <a16:creationId xmlns:a16="http://schemas.microsoft.com/office/drawing/2014/main" id="{FAF7302B-A3EB-48CC-B6F5-DB990F5A9326}"/>
+              </a:ext>
+            </a:extLst>
+          </p:cNvPr>
+          <p:cNvSpPr>
+            <a:spLocks xmlns:a="http://schemas.openxmlformats.org/drawingml/2006/main" noGrp="1"/>
+          </p:cNvSpPr>
+          <p:nvPr/>
+        </p:nvSpPr>
+        <p:spPr>
+          <a:xfrm xmlns:a="http://schemas.openxmlformats.org/drawingml/2006/main">
+            <a:off x="628650" y="4962525"/>
+            <a:ext cx="3019425" cy="285750"/>
+          </a:xfrm>
+          <a:prstGeom xmlns:a="http://schemas.openxmlformats.org/drawingml/2006/main" prst="rect">
+            <a:avLst/>
+          </a:prstGeom>
+          <a:noFill xmlns:a="http://schemas.openxmlformats.org/drawingml/2006/main"/>
+          <a:ln xmlns:a="http://schemas.openxmlformats.org/drawingml/2006/main" w="0">
+            <a:noFill/>
+            <a:prstDash val="solid"/>
+          </a:ln>
+        </p:spPr>
+        <p:txBody>
+          <a:bodyPr xmlns:a="http://schemas.openxmlformats.org/drawingml/2006/main" wrap="square" lIns="0" tIns="0" rIns="0" bIns="0" anchor="t">
+            <a:normAutofit fontScale="89286"/>
+          </a:bodyPr>
+          <a:lstStyle xmlns:a="http://schemas.openxmlformats.org/drawingml/2006/main"/>
+          <a:p xmlns:a="http://schemas.openxmlformats.org/drawingml/2006/main">
+            <a:pPr algn="l">
+              <a:buNone/>
+              <a:defRPr sz="1725" b="1">
+                <a:solidFill>
+                  <a:srgbClr val="111111"/>
+                </a:solidFill>
+                <a:latin typeface="Noto Sans TC"/>
+                <a:ea typeface="Noto Sans TC"/>
+                <a:cs typeface="Noto Sans TC"/>
+              </a:defRPr>
+            </a:pPr>
+            <a:r>
+              <a:rPr sz="2100" b="1">
+                <a:solidFill>
+                  <a:srgbClr val="111111"/>
+                </a:solidFill>
+                <a:latin typeface="Noto Sans TC"/>
+                <a:ea typeface="Noto Sans TC"/>
+                <a:cs typeface="Noto Sans TC"/>
+              </a:rPr>
+              <a:t>↑ System-wide</a:t>
+            </a:r>
+          </a:p>
+        </p:txBody>
+      </p:sp>
+      <p:sp>
+        <p:nvSpPr>
+          <p:cNvPr id="8" name="">
+            <a:extLst xmlns:a="http://schemas.openxmlformats.org/drawingml/2006/main">
+              <a:ext uri="{FF2B5EF4-FFF2-40B4-BE49-F238E27FC236}">
+                <a16:creationId xmlns:a16="http://schemas.microsoft.com/office/drawing/2014/main" id="{E8F4F60F-AB8B-4625-B263-C6722302A3DF}"/>
+              </a:ext>
+            </a:extLst>
+          </p:cNvPr>
+          <p:cNvSpPr>
+            <a:spLocks xmlns:a="http://schemas.openxmlformats.org/drawingml/2006/main" noGrp="1"/>
+          </p:cNvSpPr>
+          <p:nvPr/>
+        </p:nvSpPr>
+        <p:spPr>
+          <a:xfrm xmlns:a="http://schemas.openxmlformats.org/drawingml/2006/main">
+            <a:off x="628650" y="5295900"/>
+            <a:ext cx="3019425" cy="495300"/>
           </a:xfrm>
           <a:prstGeom xmlns:a="http://schemas.openxmlformats.org/drawingml/2006/main" prst="rect">
             <a:avLst/>
@@ -2364,47 +2859,71 @@
           <a:p xmlns:a="http://schemas.openxmlformats.org/drawingml/2006/main">
             <a:pPr algn="l">
               <a:buNone/>
-              <a:defRPr sz="1125" b="1">
-                <a:solidFill>
-                  <a:srgbClr val="2478E5"/>
-                </a:solidFill>
-                <a:latin typeface="Noto Sans TC"/>
-                <a:ea typeface="Noto Sans TC"/>
-                <a:cs typeface="Noto Sans TC"/>
-              </a:defRPr>
-            </a:pPr>
-            <a:r>
-              <a:rPr sz="1125" b="1">
-                <a:solidFill>
-                  <a:srgbClr val="2478E5"/>
-                </a:solidFill>
-                <a:latin typeface="Noto Sans TC"/>
-                <a:ea typeface="Noto Sans TC"/>
-                <a:cs typeface="Noto Sans TC"/>
-              </a:rPr>
-              <a:t>ENGINEER · 60-SECOND START</a:t>
-            </a:r>
-          </a:p>
-        </p:txBody>
-      </p:sp>
-      <p:sp>
-        <p:nvSpPr>
-          <p:cNvPr id="6" name="">
-            <a:extLst xmlns:a="http://schemas.openxmlformats.org/drawingml/2006/main">
-              <a:ext uri="{FF2B5EF4-FFF2-40B4-BE49-F238E27FC236}">
-                <a16:creationId xmlns:a16="http://schemas.microsoft.com/office/drawing/2014/main" id="{9630A5C1-B68D-47AD-9009-56B9A69D36BE}"/>
-              </a:ext>
-            </a:extLst>
-          </p:cNvPr>
-          <p:cNvSpPr>
-            <a:spLocks xmlns:a="http://schemas.openxmlformats.org/drawingml/2006/main" noGrp="1"/>
-          </p:cNvSpPr>
-          <p:nvPr/>
-        </p:nvSpPr>
-        <p:spPr>
-          <a:xfrm xmlns:a="http://schemas.openxmlformats.org/drawingml/2006/main">
-            <a:off x="400050" y="2019300"/>
-            <a:ext cx="400050" cy="323850"/>
+              <a:defRPr sz="1275" b="0">
+                <a:solidFill>
+                  <a:srgbClr val="111111"/>
+                </a:solidFill>
+                <a:latin typeface="Noto Sans TC"/>
+                <a:ea typeface="Noto Sans TC"/>
+                <a:cs typeface="Noto Sans TC"/>
+              </a:defRPr>
+            </a:pPr>
+            <a:r>
+              <a:rPr sz="1600" b="0">
+                <a:solidFill>
+                  <a:srgbClr val="4F5B66"/>
+                </a:solidFill>
+                <a:latin typeface="Noto Sans TC"/>
+                <a:ea typeface="Noto Sans TC"/>
+                <a:cs typeface="Noto Sans TC"/>
+              </a:rPr>
+              <a:t>FR / NFR / trade-off</a:t>
+            </a:r>
+          </a:p>
+          <a:p xmlns:a="http://schemas.openxmlformats.org/drawingml/2006/main">
+            <a:pPr algn="l">
+              <a:buNone/>
+              <a:defRPr sz="1275" b="0">
+                <a:solidFill>
+                  <a:srgbClr val="111111"/>
+                </a:solidFill>
+                <a:latin typeface="Noto Sans TC"/>
+                <a:ea typeface="Noto Sans TC"/>
+                <a:cs typeface="Noto Sans TC"/>
+              </a:defRPr>
+            </a:pPr>
+            <a:r>
+              <a:rPr sz="1600" b="0">
+                <a:solidFill>
+                  <a:srgbClr val="4F5B66"/>
+                </a:solidFill>
+                <a:latin typeface="Noto Sans TC"/>
+                <a:ea typeface="Noto Sans TC"/>
+                <a:cs typeface="Noto Sans TC"/>
+              </a:rPr>
+              <a:t>failure modes made explicit</a:t>
+            </a:r>
+          </a:p>
+        </p:txBody>
+      </p:sp>
+      <p:sp>
+        <p:nvSpPr>
+          <p:cNvPr id="10" name="">
+            <a:extLst xmlns:a="http://schemas.openxmlformats.org/drawingml/2006/main">
+              <a:ext uri="{FF2B5EF4-FFF2-40B4-BE49-F238E27FC236}">
+                <a16:creationId xmlns:a16="http://schemas.microsoft.com/office/drawing/2014/main" id="{3D5A33C3-2CCF-4A54-81FF-0EB401E4C8E6}"/>
+              </a:ext>
+            </a:extLst>
+          </p:cNvPr>
+          <p:cNvSpPr>
+            <a:spLocks xmlns:a="http://schemas.openxmlformats.org/drawingml/2006/main" noGrp="1"/>
+          </p:cNvSpPr>
+          <p:nvPr/>
+        </p:nvSpPr>
+        <p:spPr>
+          <a:xfrm xmlns:a="http://schemas.openxmlformats.org/drawingml/2006/main">
+            <a:off x="400050" y="1847850"/>
+            <a:ext cx="1952625" cy="209550"/>
           </a:xfrm>
           <a:prstGeom xmlns:a="http://schemas.openxmlformats.org/drawingml/2006/main" prst="rect">
             <a:avLst/>
@@ -2423,7 +2942,7 @@
           <a:p xmlns:a="http://schemas.openxmlformats.org/drawingml/2006/main">
             <a:pPr algn="l">
               <a:buNone/>
-              <a:defRPr sz="1800" b="1">
+              <a:defRPr sz="975" b="1">
                 <a:solidFill>
                   <a:srgbClr val="2478E5"/>
                 </a:solidFill>
@@ -2433,37 +2952,409 @@
               </a:defRPr>
             </a:pPr>
             <a:r>
-              <a:rPr sz="1800" b="1">
-                <a:solidFill>
-                  <a:srgbClr val="2478E5"/>
-                </a:solidFill>
-                <a:latin typeface="Noto Sans TC"/>
-                <a:ea typeface="Noto Sans TC"/>
-                <a:cs typeface="Noto Sans TC"/>
-              </a:rPr>
-              <a:t>1</a:t>
-            </a:r>
-          </a:p>
-        </p:txBody>
-      </p:sp>
-      <p:sp>
-        <p:nvSpPr>
-          <p:cNvPr id="7" name="">
-            <a:extLst xmlns:a="http://schemas.openxmlformats.org/drawingml/2006/main">
-              <a:ext uri="{FF2B5EF4-FFF2-40B4-BE49-F238E27FC236}">
-                <a16:creationId xmlns:a16="http://schemas.microsoft.com/office/drawing/2014/main" id="{90AD2C76-2802-408E-A12C-7AF062965AB4}"/>
-              </a:ext>
-            </a:extLst>
-          </p:cNvPr>
-          <p:cNvSpPr>
-            <a:spLocks xmlns:a="http://schemas.openxmlformats.org/drawingml/2006/main" noGrp="1"/>
-          </p:cNvSpPr>
-          <p:nvPr/>
-        </p:nvSpPr>
-        <p:spPr>
-          <a:xfrm xmlns:a="http://schemas.openxmlformats.org/drawingml/2006/main">
-            <a:off x="914400" y="2038350"/>
-            <a:ext cx="4476750" cy="323850"/>
+              <a:rPr sz="1200" b="1">
+                <a:solidFill>
+                  <a:srgbClr val="163A53"/>
+                </a:solidFill>
+                <a:latin typeface="Noto Sans TC"/>
+                <a:ea typeface="Noto Sans TC"/>
+                <a:cs typeface="Noto Sans TC"/>
+              </a:rPr>
+              <a:t>AS-IS</a:t>
+            </a:r>
+          </a:p>
+        </p:txBody>
+      </p:sp>
+      <p:sp>
+        <p:nvSpPr>
+          <p:cNvPr id="11" name="">
+            <a:extLst xmlns:a="http://schemas.openxmlformats.org/drawingml/2006/main">
+              <a:ext uri="{FF2B5EF4-FFF2-40B4-BE49-F238E27FC236}">
+                <a16:creationId xmlns:a16="http://schemas.microsoft.com/office/drawing/2014/main" id="{5436842B-ABB5-4FF4-A1FD-E1CDCA1BC010}"/>
+              </a:ext>
+            </a:extLst>
+          </p:cNvPr>
+          <p:cNvSpPr>
+            <a:spLocks xmlns:a="http://schemas.openxmlformats.org/drawingml/2006/main" noGrp="1"/>
+          </p:cNvSpPr>
+          <p:nvPr/>
+        </p:nvSpPr>
+        <p:spPr>
+          <a:xfrm xmlns:a="http://schemas.openxmlformats.org/drawingml/2006/main">
+            <a:off x="400050" y="2095500"/>
+            <a:ext cx="2095500" cy="685800"/>
+          </a:xfrm>
+          <a:prstGeom xmlns:a="http://schemas.openxmlformats.org/drawingml/2006/main" prst="rect">
+            <a:avLst/>
+          </a:prstGeom>
+          <a:noFill xmlns:a="http://schemas.openxmlformats.org/drawingml/2006/main"/>
+          <a:ln xmlns:a="http://schemas.openxmlformats.org/drawingml/2006/main" w="0">
+            <a:noFill/>
+            <a:prstDash val="solid"/>
+          </a:ln>
+        </p:spPr>
+        <p:txBody>
+          <a:bodyPr xmlns:a="http://schemas.openxmlformats.org/drawingml/2006/main" wrap="square" lIns="0" tIns="0" rIns="0" bIns="0" anchor="t">
+            <a:normAutofit fontScale="93750"/>
+          </a:bodyPr>
+          <a:lstStyle xmlns:a="http://schemas.openxmlformats.org/drawingml/2006/main"/>
+          <a:p xmlns:a="http://schemas.openxmlformats.org/drawingml/2006/main">
+            <a:pPr algn="l">
+              <a:buNone/>
+              <a:defRPr sz="1125" b="1">
+                <a:solidFill>
+                  <a:srgbClr val="173B57"/>
+                </a:solidFill>
+                <a:latin typeface="Noto Sans TC"/>
+                <a:ea typeface="Noto Sans TC"/>
+                <a:cs typeface="Noto Sans TC"/>
+              </a:defRPr>
+            </a:pPr>
+            <a:r>
+              <a:rPr sz="1600" b="1">
+                <a:solidFill>
+                  <a:srgbClr val="4F5B66"/>
+                </a:solidFill>
+                <a:latin typeface="Noto Sans TC"/>
+                <a:ea typeface="Noto Sans TC"/>
+                <a:cs typeface="Noto Sans TC"/>
+              </a:rPr>
+              <a:t>single-repo research</a:t>
+            </a:r>
+          </a:p>
+          <a:p xmlns:a="http://schemas.openxmlformats.org/drawingml/2006/main">
+            <a:pPr algn="l">
+              <a:buNone/>
+              <a:defRPr sz="1125" b="1">
+                <a:solidFill>
+                  <a:srgbClr val="173B57"/>
+                </a:solidFill>
+                <a:latin typeface="Noto Sans TC"/>
+                <a:ea typeface="Noto Sans TC"/>
+                <a:cs typeface="Noto Sans TC"/>
+              </a:defRPr>
+            </a:pPr>
+            <a:r>
+              <a:rPr sz="1600" b="1">
+                <a:solidFill>
+                  <a:srgbClr val="4F5B66"/>
+                </a:solidFill>
+                <a:latin typeface="Noto Sans TC"/>
+                <a:ea typeface="Noto Sans TC"/>
+                <a:cs typeface="Noto Sans TC"/>
+              </a:rPr>
+              <a:t>FR / NFR 不明確</a:t>
+            </a:r>
+          </a:p>
+          <a:p xmlns:a="http://schemas.openxmlformats.org/drawingml/2006/main">
+            <a:pPr algn="l">
+              <a:buNone/>
+              <a:defRPr sz="1125" b="1">
+                <a:solidFill>
+                  <a:srgbClr val="173B57"/>
+                </a:solidFill>
+                <a:latin typeface="Noto Sans TC"/>
+                <a:ea typeface="Noto Sans TC"/>
+                <a:cs typeface="Noto Sans TC"/>
+              </a:defRPr>
+            </a:pPr>
+            <a:r>
+              <a:rPr sz="1600" b="1">
+                <a:solidFill>
+                  <a:srgbClr val="4F5B66"/>
+                </a:solidFill>
+                <a:latin typeface="Noto Sans TC"/>
+                <a:ea typeface="Noto Sans TC"/>
+                <a:cs typeface="Noto Sans TC"/>
+              </a:rPr>
+              <a:t>thin tests</a:t>
+            </a:r>
+          </a:p>
+        </p:txBody>
+      </p:sp>
+      <p:sp>
+        <p:nvSpPr>
+          <p:cNvPr id="12" name="">
+            <a:extLst xmlns:a="http://schemas.openxmlformats.org/drawingml/2006/main">
+              <a:ext uri="{FF2B5EF4-FFF2-40B4-BE49-F238E27FC236}">
+                <a16:creationId xmlns:a16="http://schemas.microsoft.com/office/drawing/2014/main" id="{95B77F80-F62D-40D2-92E2-ED78BB1387EE}"/>
+              </a:ext>
+            </a:extLst>
+          </p:cNvPr>
+          <p:cNvSpPr>
+            <a:spLocks xmlns:a="http://schemas.openxmlformats.org/drawingml/2006/main" noGrp="1"/>
+          </p:cNvSpPr>
+          <p:nvPr/>
+        </p:nvSpPr>
+        <p:spPr>
+          <a:xfrm xmlns:a="http://schemas.openxmlformats.org/drawingml/2006/main">
+            <a:off x="4276725" y="4552950"/>
+            <a:ext cx="3476625" cy="1295400"/>
+          </a:xfrm>
+          <a:prstGeom xmlns:a="http://schemas.openxmlformats.org/drawingml/2006/main" prst="rect">
+            <a:avLst/>
+          </a:prstGeom>
+          <a:noFill xmlns:a="http://schemas.openxmlformats.org/drawingml/2006/main"/>
+          <a:ln xmlns:a="http://schemas.openxmlformats.org/drawingml/2006/main" w="9525">
+            <a:solidFill>
+              <a:srgbClr val="D6DCE1"/>
+            </a:solidFill>
+            <a:prstDash val="solid"/>
+          </a:ln>
+        </p:spPr>
+      </p:sp>
+      <p:sp>
+        <p:nvSpPr>
+          <p:cNvPr id="13" name="">
+            <a:extLst xmlns:a="http://schemas.openxmlformats.org/drawingml/2006/main">
+              <a:ext uri="{FF2B5EF4-FFF2-40B4-BE49-F238E27FC236}">
+                <a16:creationId xmlns:a16="http://schemas.microsoft.com/office/drawing/2014/main" id="{5BFCABB4-DC44-41E1-9F46-1D949A9B45CA}"/>
+              </a:ext>
+            </a:extLst>
+          </p:cNvPr>
+          <p:cNvSpPr>
+            <a:spLocks xmlns:a="http://schemas.openxmlformats.org/drawingml/2006/main" noGrp="1"/>
+          </p:cNvSpPr>
+          <p:nvPr/>
+        </p:nvSpPr>
+        <p:spPr>
+          <a:xfrm xmlns:a="http://schemas.openxmlformats.org/drawingml/2006/main">
+            <a:off x="4276725" y="4552950"/>
+            <a:ext cx="3476625" cy="285750"/>
+          </a:xfrm>
+          <a:prstGeom xmlns:a="http://schemas.openxmlformats.org/drawingml/2006/main" prst="rect">
+            <a:avLst/>
+          </a:prstGeom>
+          <a:solidFill xmlns:a="http://schemas.openxmlformats.org/drawingml/2006/main">
+            <a:srgbClr val="1D78C8"/>
+          </a:solidFill>
+          <a:ln xmlns:a="http://schemas.openxmlformats.org/drawingml/2006/main" w="0">
+            <a:solidFill>
+              <a:srgbClr val="1D78C8"/>
+            </a:solidFill>
+            <a:prstDash val="solid"/>
+          </a:ln>
+        </p:spPr>
+      </p:sp>
+      <p:sp>
+        <p:nvSpPr>
+          <p:cNvPr id="14" name="">
+            <a:extLst xmlns:a="http://schemas.openxmlformats.org/drawingml/2006/main">
+              <a:ext uri="{FF2B5EF4-FFF2-40B4-BE49-F238E27FC236}">
+                <a16:creationId xmlns:a16="http://schemas.microsoft.com/office/drawing/2014/main" id="{5792CCA2-507D-42DA-8734-85109C59457C}"/>
+              </a:ext>
+            </a:extLst>
+          </p:cNvPr>
+          <p:cNvSpPr>
+            <a:spLocks xmlns:a="http://schemas.openxmlformats.org/drawingml/2006/main" noGrp="1"/>
+          </p:cNvSpPr>
+          <p:nvPr/>
+        </p:nvSpPr>
+        <p:spPr>
+          <a:xfrm xmlns:a="http://schemas.openxmlformats.org/drawingml/2006/main">
+            <a:off x="4371975" y="4610100"/>
+            <a:ext cx="3286125" cy="171450"/>
+          </a:xfrm>
+          <a:prstGeom xmlns:a="http://schemas.openxmlformats.org/drawingml/2006/main" prst="rect">
+            <a:avLst/>
+          </a:prstGeom>
+          <a:noFill xmlns:a="http://schemas.openxmlformats.org/drawingml/2006/main"/>
+          <a:ln xmlns:a="http://schemas.openxmlformats.org/drawingml/2006/main" w="0">
+            <a:noFill/>
+            <a:prstDash val="solid"/>
+          </a:ln>
+        </p:spPr>
+        <p:txBody>
+          <a:bodyPr xmlns:a="http://schemas.openxmlformats.org/drawingml/2006/main" wrap="square" lIns="0" tIns="0" rIns="0" bIns="0" anchor="ctr">
+            <a:normAutofit fontScale="100000"/>
+          </a:bodyPr>
+          <a:lstStyle xmlns:a="http://schemas.openxmlformats.org/drawingml/2006/main"/>
+          <a:p xmlns:a="http://schemas.openxmlformats.org/drawingml/2006/main">
+            <a:pPr algn="l">
+              <a:buNone/>
+              <a:defRPr sz="975" b="1">
+                <a:solidFill>
+                  <a:srgbClr val="FFFFFF"/>
+                </a:solidFill>
+                <a:latin typeface="Noto Sans TC"/>
+                <a:ea typeface="Noto Sans TC"/>
+                <a:cs typeface="Noto Sans TC"/>
+              </a:defRPr>
+            </a:pPr>
+            <a:r>
+              <a:rPr sz="1100" b="1">
+                <a:solidFill>
+                  <a:srgbClr val="FFFFFF"/>
+                </a:solidFill>
+                <a:latin typeface="Noto Sans TC"/>
+                <a:ea typeface="Noto Sans TC"/>
+                <a:cs typeface="Noto Sans TC"/>
+              </a:rPr>
+              <a:t>IMPLEMENTATION EFFORT</a:t>
+            </a:r>
+          </a:p>
+        </p:txBody>
+      </p:sp>
+      <p:sp>
+        <p:nvSpPr>
+          <p:cNvPr id="15" name="">
+            <a:extLst xmlns:a="http://schemas.openxmlformats.org/drawingml/2006/main">
+              <a:ext uri="{FF2B5EF4-FFF2-40B4-BE49-F238E27FC236}">
+                <a16:creationId xmlns:a16="http://schemas.microsoft.com/office/drawing/2014/main" id="{2B86718B-9A73-4457-83A1-BB15F205710E}"/>
+              </a:ext>
+            </a:extLst>
+          </p:cNvPr>
+          <p:cNvSpPr>
+            <a:spLocks xmlns:a="http://schemas.openxmlformats.org/drawingml/2006/main" noGrp="1"/>
+          </p:cNvSpPr>
+          <p:nvPr/>
+        </p:nvSpPr>
+        <p:spPr>
+          <a:xfrm xmlns:a="http://schemas.openxmlformats.org/drawingml/2006/main">
+            <a:off x="4505325" y="4962525"/>
+            <a:ext cx="3019425" cy="285750"/>
+          </a:xfrm>
+          <a:prstGeom xmlns:a="http://schemas.openxmlformats.org/drawingml/2006/main" prst="rect">
+            <a:avLst/>
+          </a:prstGeom>
+          <a:noFill xmlns:a="http://schemas.openxmlformats.org/drawingml/2006/main"/>
+          <a:ln xmlns:a="http://schemas.openxmlformats.org/drawingml/2006/main" w="0">
+            <a:noFill/>
+            <a:prstDash val="solid"/>
+          </a:ln>
+        </p:spPr>
+        <p:txBody>
+          <a:bodyPr xmlns:a="http://schemas.openxmlformats.org/drawingml/2006/main" wrap="square" lIns="0" tIns="0" rIns="0" bIns="0" anchor="t">
+            <a:normAutofit fontScale="89286"/>
+          </a:bodyPr>
+          <a:lstStyle xmlns:a="http://schemas.openxmlformats.org/drawingml/2006/main"/>
+          <a:p xmlns:a="http://schemas.openxmlformats.org/drawingml/2006/main">
+            <a:pPr algn="l">
+              <a:buNone/>
+              <a:defRPr sz="1725" b="1">
+                <a:solidFill>
+                  <a:srgbClr val="111111"/>
+                </a:solidFill>
+                <a:latin typeface="Noto Sans TC"/>
+                <a:ea typeface="Noto Sans TC"/>
+                <a:cs typeface="Noto Sans TC"/>
+              </a:defRPr>
+            </a:pPr>
+            <a:r>
+              <a:rPr sz="2100" b="1">
+                <a:solidFill>
+                  <a:srgbClr val="111111"/>
+                </a:solidFill>
+                <a:latin typeface="Noto Sans TC"/>
+                <a:ea typeface="Noto Sans TC"/>
+                <a:cs typeface="Noto Sans TC"/>
+              </a:rPr>
+              <a:t>↓ 80–90%</a:t>
+            </a:r>
+          </a:p>
+        </p:txBody>
+      </p:sp>
+      <p:sp>
+        <p:nvSpPr>
+          <p:cNvPr id="16" name="">
+            <a:extLst xmlns:a="http://schemas.openxmlformats.org/drawingml/2006/main">
+              <a:ext uri="{FF2B5EF4-FFF2-40B4-BE49-F238E27FC236}">
+                <a16:creationId xmlns:a16="http://schemas.microsoft.com/office/drawing/2014/main" id="{0E1E8CF7-588E-4B22-B1D5-EBD03B72CF25}"/>
+              </a:ext>
+            </a:extLst>
+          </p:cNvPr>
+          <p:cNvSpPr>
+            <a:spLocks xmlns:a="http://schemas.openxmlformats.org/drawingml/2006/main" noGrp="1"/>
+          </p:cNvSpPr>
+          <p:nvPr/>
+        </p:nvSpPr>
+        <p:spPr>
+          <a:xfrm xmlns:a="http://schemas.openxmlformats.org/drawingml/2006/main">
+            <a:off x="4505325" y="5295900"/>
+            <a:ext cx="3019425" cy="495300"/>
+          </a:xfrm>
+          <a:prstGeom xmlns:a="http://schemas.openxmlformats.org/drawingml/2006/main" prst="rect">
+            <a:avLst/>
+          </a:prstGeom>
+          <a:noFill xmlns:a="http://schemas.openxmlformats.org/drawingml/2006/main"/>
+          <a:ln xmlns:a="http://schemas.openxmlformats.org/drawingml/2006/main" w="0">
+            <a:noFill/>
+            <a:prstDash val="solid"/>
+          </a:ln>
+        </p:spPr>
+        <p:txBody>
+          <a:bodyPr xmlns:a="http://schemas.openxmlformats.org/drawingml/2006/main" wrap="square" lIns="0" tIns="0" rIns="0" bIns="0" anchor="t">
+            <a:normAutofit fontScale="93457"/>
+          </a:bodyPr>
+          <a:lstStyle xmlns:a="http://schemas.openxmlformats.org/drawingml/2006/main"/>
+          <a:p xmlns:a="http://schemas.openxmlformats.org/drawingml/2006/main">
+            <a:pPr algn="l">
+              <a:buNone/>
+              <a:defRPr sz="1275" b="0">
+                <a:solidFill>
+                  <a:srgbClr val="111111"/>
+                </a:solidFill>
+                <a:latin typeface="Noto Sans TC"/>
+                <a:ea typeface="Noto Sans TC"/>
+                <a:cs typeface="Noto Sans TC"/>
+              </a:defRPr>
+            </a:pPr>
+            <a:r>
+              <a:rPr sz="1600" b="0">
+                <a:solidFill>
+                  <a:srgbClr val="4F5B66"/>
+                </a:solidFill>
+                <a:latin typeface="Noto Sans TC"/>
+                <a:ea typeface="Noto Sans TC"/>
+                <a:cs typeface="Noto Sans TC"/>
+              </a:rPr>
+              <a:t>code time target：降至約 1/5–1/10</a:t>
+            </a:r>
+          </a:p>
+          <a:p xmlns:a="http://schemas.openxmlformats.org/drawingml/2006/main">
+            <a:pPr algn="l">
+              <a:buNone/>
+              <a:defRPr sz="1275" b="0">
+                <a:solidFill>
+                  <a:srgbClr val="111111"/>
+                </a:solidFill>
+                <a:latin typeface="Noto Sans TC"/>
+                <a:ea typeface="Noto Sans TC"/>
+                <a:cs typeface="Noto Sans TC"/>
+              </a:defRPr>
+            </a:pPr>
+            <a:r>
+              <a:rPr sz="1600" b="0">
+                <a:solidFill>
+                  <a:srgbClr val="4F5B66"/>
+                </a:solidFill>
+                <a:latin typeface="Noto Sans TC"/>
+                <a:ea typeface="Noto Sans TC"/>
+                <a:cs typeface="Noto Sans TC"/>
+              </a:rPr>
+              <a:t>of current implementation effort</a:t>
+            </a:r>
+          </a:p>
+        </p:txBody>
+      </p:sp>
+      <p:sp>
+        <p:nvSpPr>
+          <p:cNvPr id="18" name="">
+            <a:extLst xmlns:a="http://schemas.openxmlformats.org/drawingml/2006/main">
+              <a:ext uri="{FF2B5EF4-FFF2-40B4-BE49-F238E27FC236}">
+                <a16:creationId xmlns:a16="http://schemas.microsoft.com/office/drawing/2014/main" id="{E50AAA05-C9F4-41A3-8E51-7516AD09246A}"/>
+              </a:ext>
+            </a:extLst>
+          </p:cNvPr>
+          <p:cNvSpPr>
+            <a:spLocks xmlns:a="http://schemas.openxmlformats.org/drawingml/2006/main" noGrp="1"/>
+          </p:cNvSpPr>
+          <p:nvPr/>
+        </p:nvSpPr>
+        <p:spPr>
+          <a:xfrm xmlns:a="http://schemas.openxmlformats.org/drawingml/2006/main">
+            <a:off x="400050" y="3076575"/>
+            <a:ext cx="2095500" cy="209550"/>
           </a:xfrm>
           <a:prstGeom xmlns:a="http://schemas.openxmlformats.org/drawingml/2006/main" prst="rect">
             <a:avLst/>
@@ -2482,39 +3373,635 @@
           <a:p xmlns:a="http://schemas.openxmlformats.org/drawingml/2006/main">
             <a:pPr algn="l">
               <a:buNone/>
-              <a:defRPr sz="1350" b="1">
-                <a:solidFill>
-                  <a:srgbClr val="111111"/>
-                </a:solidFill>
-                <a:latin typeface="Noto Sans TC"/>
-                <a:ea typeface="Noto Sans TC"/>
-                <a:cs typeface="Noto Sans TC"/>
-              </a:defRPr>
-            </a:pPr>
-            <a:r>
-              <a:rPr sz="1350" b="1">
-                <a:solidFill>
-                  <a:srgbClr val="111111"/>
-                </a:solidFill>
-                <a:latin typeface="Noto Sans TC"/>
-                <a:ea typeface="Noto Sans TC"/>
-                <a:cs typeface="Noto Sans TC"/>
-              </a:rPr>
-              <a:t>選 P3 / P2 / P1 / P0 與 P0 type</a:t>
+              <a:defRPr sz="975" b="1">
+                <a:solidFill>
+                  <a:srgbClr val="2478E5"/>
+                </a:solidFill>
+                <a:latin typeface="Noto Sans TC"/>
+                <a:ea typeface="Noto Sans TC"/>
+                <a:cs typeface="Noto Sans TC"/>
+              </a:defRPr>
+            </a:pPr>
+            <a:r>
+              <a:rPr sz="1200" b="1">
+                <a:solidFill>
+                  <a:srgbClr val="1D78C8"/>
+                </a:solidFill>
+                <a:latin typeface="Noto Sans TC"/>
+                <a:ea typeface="Noto Sans TC"/>
+                <a:cs typeface="Noto Sans TC"/>
+              </a:rPr>
+              <a:t>AI ENGINEERING</a:t>
+            </a:r>
+          </a:p>
+        </p:txBody>
+      </p:sp>
+      <p:sp>
+        <p:nvSpPr>
+          <p:cNvPr id="19" name="">
+            <a:extLst xmlns:a="http://schemas.openxmlformats.org/drawingml/2006/main">
+              <a:ext uri="{FF2B5EF4-FFF2-40B4-BE49-F238E27FC236}">
+                <a16:creationId xmlns:a16="http://schemas.microsoft.com/office/drawing/2014/main" id="{7F647F1E-5C6A-4C5D-9DA5-F8B7D34C4697}"/>
+              </a:ext>
+            </a:extLst>
+          </p:cNvPr>
+          <p:cNvSpPr>
+            <a:spLocks xmlns:a="http://schemas.openxmlformats.org/drawingml/2006/main" noGrp="1"/>
+          </p:cNvSpPr>
+          <p:nvPr/>
+        </p:nvSpPr>
+        <p:spPr>
+          <a:xfrm xmlns:a="http://schemas.openxmlformats.org/drawingml/2006/main">
+            <a:off x="400050" y="3324225"/>
+            <a:ext cx="2095500" cy="685800"/>
+          </a:xfrm>
+          <a:prstGeom xmlns:a="http://schemas.openxmlformats.org/drawingml/2006/main" prst="rect">
+            <a:avLst/>
+          </a:prstGeom>
+          <a:noFill xmlns:a="http://schemas.openxmlformats.org/drawingml/2006/main"/>
+          <a:ln xmlns:a="http://schemas.openxmlformats.org/drawingml/2006/main" w="0">
+            <a:noFill/>
+            <a:prstDash val="solid"/>
+          </a:ln>
+        </p:spPr>
+        <p:txBody>
+          <a:bodyPr xmlns:a="http://schemas.openxmlformats.org/drawingml/2006/main" wrap="square" lIns="0" tIns="0" rIns="0" bIns="0" anchor="t">
+            <a:normAutofit fontScale="88619"/>
+          </a:bodyPr>
+          <a:lstStyle xmlns:a="http://schemas.openxmlformats.org/drawingml/2006/main"/>
+          <a:p xmlns:a="http://schemas.openxmlformats.org/drawingml/2006/main">
+            <a:pPr algn="l">
+              <a:buNone/>
+              <a:defRPr sz="1125" b="1">
+                <a:solidFill>
+                  <a:srgbClr val="173B57"/>
+                </a:solidFill>
+                <a:latin typeface="Noto Sans TC"/>
+                <a:ea typeface="Noto Sans TC"/>
+                <a:cs typeface="Noto Sans TC"/>
+              </a:defRPr>
+            </a:pPr>
+            <a:r>
+              <a:rPr sz="1600" b="1">
+                <a:solidFill>
+                  <a:srgbClr val="4F5B66"/>
+                </a:solidFill>
+                <a:latin typeface="Noto Sans TC"/>
+                <a:ea typeface="Noto Sans TC"/>
+                <a:cs typeface="Noto Sans TC"/>
+              </a:rPr>
+              <a:t>system-wide research</a:t>
+            </a:r>
+          </a:p>
+          <a:p xmlns:a="http://schemas.openxmlformats.org/drawingml/2006/main">
+            <a:pPr algn="l">
+              <a:buNone/>
+              <a:defRPr sz="1125" b="1">
+                <a:solidFill>
+                  <a:srgbClr val="173B57"/>
+                </a:solidFill>
+                <a:latin typeface="Noto Sans TC"/>
+                <a:ea typeface="Noto Sans TC"/>
+                <a:cs typeface="Noto Sans TC"/>
+              </a:defRPr>
+            </a:pPr>
+            <a:r>
+              <a:rPr sz="1600" b="1">
+                <a:solidFill>
+                  <a:srgbClr val="4F5B66"/>
+                </a:solidFill>
+                <a:latin typeface="Noto Sans TC"/>
+                <a:ea typeface="Noto Sans TC"/>
+                <a:cs typeface="Noto Sans TC"/>
+              </a:rPr>
+              <a:t>explicit FR / NFR</a:t>
+            </a:r>
+          </a:p>
+          <a:p xmlns:a="http://schemas.openxmlformats.org/drawingml/2006/main">
+            <a:pPr algn="l">
+              <a:buNone/>
+              <a:defRPr sz="1125" b="1">
+                <a:solidFill>
+                  <a:srgbClr val="173B57"/>
+                </a:solidFill>
+                <a:latin typeface="Noto Sans TC"/>
+                <a:ea typeface="Noto Sans TC"/>
+                <a:cs typeface="Noto Sans TC"/>
+              </a:defRPr>
+            </a:pPr>
+            <a:r>
+              <a:rPr sz="1600" b="1">
+                <a:solidFill>
+                  <a:srgbClr val="4F5B66"/>
+                </a:solidFill>
+                <a:latin typeface="Noto Sans TC"/>
+                <a:ea typeface="Noto Sans TC"/>
+                <a:cs typeface="Noto Sans TC"/>
+              </a:rPr>
+              <a:t>TDD + broader evidence</a:t>
+            </a:r>
+          </a:p>
+        </p:txBody>
+      </p:sp>
+      <p:sp>
+        <p:nvSpPr>
+          <p:cNvPr id="20" name="">
+            <a:extLst xmlns:a="http://schemas.openxmlformats.org/drawingml/2006/main">
+              <a:ext uri="{FF2B5EF4-FFF2-40B4-BE49-F238E27FC236}">
+                <a16:creationId xmlns:a16="http://schemas.microsoft.com/office/drawing/2014/main" id="{8655014B-D426-4312-9964-BB50BC02442C}"/>
+              </a:ext>
+            </a:extLst>
+          </p:cNvPr>
+          <p:cNvSpPr>
+            <a:spLocks xmlns:a="http://schemas.openxmlformats.org/drawingml/2006/main" noGrp="1"/>
+          </p:cNvSpPr>
+          <p:nvPr/>
+        </p:nvSpPr>
+        <p:spPr>
+          <a:xfrm xmlns:a="http://schemas.openxmlformats.org/drawingml/2006/main">
+            <a:off x="8153400" y="4552950"/>
+            <a:ext cx="3476625" cy="1295400"/>
+          </a:xfrm>
+          <a:prstGeom xmlns:a="http://schemas.openxmlformats.org/drawingml/2006/main" prst="rect">
+            <a:avLst/>
+          </a:prstGeom>
+          <a:noFill xmlns:a="http://schemas.openxmlformats.org/drawingml/2006/main"/>
+          <a:ln xmlns:a="http://schemas.openxmlformats.org/drawingml/2006/main" w="9525">
+            <a:solidFill>
+              <a:srgbClr val="D6DCE1"/>
+            </a:solidFill>
+            <a:prstDash val="solid"/>
+          </a:ln>
+        </p:spPr>
+      </p:sp>
+      <p:sp>
+        <p:nvSpPr>
+          <p:cNvPr id="21" name="">
+            <a:extLst xmlns:a="http://schemas.openxmlformats.org/drawingml/2006/main">
+              <a:ext uri="{FF2B5EF4-FFF2-40B4-BE49-F238E27FC236}">
+                <a16:creationId xmlns:a16="http://schemas.microsoft.com/office/drawing/2014/main" id="{B85509BE-B834-486F-9D0D-208CCDAB7E4B}"/>
+              </a:ext>
+            </a:extLst>
+          </p:cNvPr>
+          <p:cNvSpPr>
+            <a:spLocks xmlns:a="http://schemas.openxmlformats.org/drawingml/2006/main" noGrp="1"/>
+          </p:cNvSpPr>
+          <p:nvPr/>
+        </p:nvSpPr>
+        <p:spPr>
+          <a:xfrm xmlns:a="http://schemas.openxmlformats.org/drawingml/2006/main">
+            <a:off x="8153400" y="4552950"/>
+            <a:ext cx="3476625" cy="285750"/>
+          </a:xfrm>
+          <a:prstGeom xmlns:a="http://schemas.openxmlformats.org/drawingml/2006/main" prst="rect">
+            <a:avLst/>
+          </a:prstGeom>
+          <a:solidFill xmlns:a="http://schemas.openxmlformats.org/drawingml/2006/main">
+            <a:srgbClr val="46B8DF"/>
+          </a:solidFill>
+          <a:ln xmlns:a="http://schemas.openxmlformats.org/drawingml/2006/main" w="0">
+            <a:solidFill>
+              <a:srgbClr val="46B8DF"/>
+            </a:solidFill>
+            <a:prstDash val="solid"/>
+          </a:ln>
+        </p:spPr>
+      </p:sp>
+      <p:sp>
+        <p:nvSpPr>
+          <p:cNvPr id="22" name="">
+            <a:extLst xmlns:a="http://schemas.openxmlformats.org/drawingml/2006/main">
+              <a:ext uri="{FF2B5EF4-FFF2-40B4-BE49-F238E27FC236}">
+                <a16:creationId xmlns:a16="http://schemas.microsoft.com/office/drawing/2014/main" id="{76C849E1-4FD0-4CB6-955A-4697BB2D7886}"/>
+              </a:ext>
+            </a:extLst>
+          </p:cNvPr>
+          <p:cNvSpPr>
+            <a:spLocks xmlns:a="http://schemas.openxmlformats.org/drawingml/2006/main" noGrp="1"/>
+          </p:cNvSpPr>
+          <p:nvPr/>
+        </p:nvSpPr>
+        <p:spPr>
+          <a:xfrm xmlns:a="http://schemas.openxmlformats.org/drawingml/2006/main">
+            <a:off x="8248650" y="4610100"/>
+            <a:ext cx="3286125" cy="171450"/>
+          </a:xfrm>
+          <a:prstGeom xmlns:a="http://schemas.openxmlformats.org/drawingml/2006/main" prst="rect">
+            <a:avLst/>
+          </a:prstGeom>
+          <a:noFill xmlns:a="http://schemas.openxmlformats.org/drawingml/2006/main"/>
+          <a:ln xmlns:a="http://schemas.openxmlformats.org/drawingml/2006/main" w="0">
+            <a:noFill/>
+            <a:prstDash val="solid"/>
+          </a:ln>
+        </p:spPr>
+        <p:txBody>
+          <a:bodyPr xmlns:a="http://schemas.openxmlformats.org/drawingml/2006/main" wrap="square" lIns="0" tIns="0" rIns="0" bIns="0" anchor="ctr">
+            <a:normAutofit fontScale="100000"/>
+          </a:bodyPr>
+          <a:lstStyle xmlns:a="http://schemas.openxmlformats.org/drawingml/2006/main"/>
+          <a:p xmlns:a="http://schemas.openxmlformats.org/drawingml/2006/main">
+            <a:pPr algn="l">
+              <a:buNone/>
+              <a:defRPr sz="975" b="1">
+                <a:solidFill>
+                  <a:srgbClr val="FFFFFF"/>
+                </a:solidFill>
+                <a:latin typeface="Noto Sans TC"/>
+                <a:ea typeface="Noto Sans TC"/>
+                <a:cs typeface="Noto Sans TC"/>
+              </a:defRPr>
+            </a:pPr>
+            <a:r>
+              <a:rPr sz="1100" b="1">
+                <a:solidFill>
+                  <a:srgbClr val="FFFFFF"/>
+                </a:solidFill>
+                <a:latin typeface="Noto Sans TC"/>
+                <a:ea typeface="Noto Sans TC"/>
+                <a:cs typeface="Noto Sans TC"/>
+              </a:rPr>
+              <a:t>PATCHES / REWORK</a:t>
+            </a:r>
+          </a:p>
+        </p:txBody>
+      </p:sp>
+      <p:sp>
+        <p:nvSpPr>
+          <p:cNvPr id="23" name="">
+            <a:extLst xmlns:a="http://schemas.openxmlformats.org/drawingml/2006/main">
+              <a:ext uri="{FF2B5EF4-FFF2-40B4-BE49-F238E27FC236}">
+                <a16:creationId xmlns:a16="http://schemas.microsoft.com/office/drawing/2014/main" id="{1EA2C016-5C5A-465D-ACE0-B92F537B4A73}"/>
+              </a:ext>
+            </a:extLst>
+          </p:cNvPr>
+          <p:cNvSpPr>
+            <a:spLocks xmlns:a="http://schemas.openxmlformats.org/drawingml/2006/main" noGrp="1"/>
+          </p:cNvSpPr>
+          <p:nvPr/>
+        </p:nvSpPr>
+        <p:spPr>
+          <a:xfrm xmlns:a="http://schemas.openxmlformats.org/drawingml/2006/main">
+            <a:off x="8382000" y="4962525"/>
+            <a:ext cx="3019425" cy="285750"/>
+          </a:xfrm>
+          <a:prstGeom xmlns:a="http://schemas.openxmlformats.org/drawingml/2006/main" prst="rect">
+            <a:avLst/>
+          </a:prstGeom>
+          <a:noFill xmlns:a="http://schemas.openxmlformats.org/drawingml/2006/main"/>
+          <a:ln xmlns:a="http://schemas.openxmlformats.org/drawingml/2006/main" w="0">
+            <a:noFill/>
+            <a:prstDash val="solid"/>
+          </a:ln>
+        </p:spPr>
+        <p:txBody>
+          <a:bodyPr xmlns:a="http://schemas.openxmlformats.org/drawingml/2006/main" wrap="square" lIns="0" tIns="0" rIns="0" bIns="0" anchor="t">
+            <a:normAutofit fontScale="89286"/>
+          </a:bodyPr>
+          <a:lstStyle xmlns:a="http://schemas.openxmlformats.org/drawingml/2006/main"/>
+          <a:p xmlns:a="http://schemas.openxmlformats.org/drawingml/2006/main">
+            <a:pPr algn="l">
+              <a:buNone/>
+              <a:defRPr sz="1725" b="1">
+                <a:solidFill>
+                  <a:srgbClr val="111111"/>
+                </a:solidFill>
+                <a:latin typeface="Noto Sans TC"/>
+                <a:ea typeface="Noto Sans TC"/>
+                <a:cs typeface="Noto Sans TC"/>
+              </a:defRPr>
+            </a:pPr>
+            <a:r>
+              <a:rPr sz="2100" b="1">
+                <a:solidFill>
+                  <a:srgbClr val="163A53"/>
+                </a:solidFill>
+                <a:latin typeface="Noto Sans TC"/>
+                <a:ea typeface="Noto Sans TC"/>
+                <a:cs typeface="Noto Sans TC"/>
+              </a:rPr>
+              <a:t>↓ 明顯下降</a:t>
+            </a:r>
+          </a:p>
+        </p:txBody>
+      </p:sp>
+      <p:sp>
+        <p:nvSpPr>
+          <p:cNvPr id="24" name="">
+            <a:extLst xmlns:a="http://schemas.openxmlformats.org/drawingml/2006/main">
+              <a:ext uri="{FF2B5EF4-FFF2-40B4-BE49-F238E27FC236}">
+                <a16:creationId xmlns:a16="http://schemas.microsoft.com/office/drawing/2014/main" id="{6E8B0C43-A552-45B0-BE18-D69845272384}"/>
+              </a:ext>
+            </a:extLst>
+          </p:cNvPr>
+          <p:cNvSpPr>
+            <a:spLocks xmlns:a="http://schemas.openxmlformats.org/drawingml/2006/main" noGrp="1"/>
+          </p:cNvSpPr>
+          <p:nvPr/>
+        </p:nvSpPr>
+        <p:spPr>
+          <a:xfrm xmlns:a="http://schemas.openxmlformats.org/drawingml/2006/main">
+            <a:off x="8382000" y="5295900"/>
+            <a:ext cx="3019425" cy="495300"/>
+          </a:xfrm>
+          <a:prstGeom xmlns:a="http://schemas.openxmlformats.org/drawingml/2006/main" prst="rect">
+            <a:avLst/>
+          </a:prstGeom>
+          <a:noFill xmlns:a="http://schemas.openxmlformats.org/drawingml/2006/main"/>
+          <a:ln xmlns:a="http://schemas.openxmlformats.org/drawingml/2006/main" w="0">
+            <a:noFill/>
+            <a:prstDash val="solid"/>
+          </a:ln>
+        </p:spPr>
+        <p:txBody>
+          <a:bodyPr xmlns:a="http://schemas.openxmlformats.org/drawingml/2006/main" wrap="square" lIns="0" tIns="0" rIns="0" bIns="0" anchor="t">
+            <a:normAutofit fontScale="100000"/>
+          </a:bodyPr>
+          <a:lstStyle xmlns:a="http://schemas.openxmlformats.org/drawingml/2006/main"/>
+          <a:p xmlns:a="http://schemas.openxmlformats.org/drawingml/2006/main">
+            <a:pPr algn="l">
+              <a:buNone/>
+              <a:defRPr sz="1275" b="0">
+                <a:solidFill>
+                  <a:srgbClr val="111111"/>
+                </a:solidFill>
+                <a:latin typeface="Noto Sans TC"/>
+                <a:ea typeface="Noto Sans TC"/>
+                <a:cs typeface="Noto Sans TC"/>
+              </a:defRPr>
+            </a:pPr>
+            <a:r>
+              <a:rPr sz="1600" b="0">
+                <a:solidFill>
+                  <a:srgbClr val="4F5B66"/>
+                </a:solidFill>
+                <a:latin typeface="Noto Sans TC"/>
+                <a:ea typeface="Noto Sans TC"/>
+                <a:cs typeface="Noto Sans TC"/>
+              </a:rPr>
+              <a:t>broader TDD coverage</a:t>
+            </a:r>
+          </a:p>
+          <a:p xmlns:a="http://schemas.openxmlformats.org/drawingml/2006/main">
+            <a:pPr algn="l">
+              <a:buNone/>
+              <a:defRPr sz="1275" b="0">
+                <a:solidFill>
+                  <a:srgbClr val="111111"/>
+                </a:solidFill>
+                <a:latin typeface="Noto Sans TC"/>
+                <a:ea typeface="Noto Sans TC"/>
+                <a:cs typeface="Noto Sans TC"/>
+              </a:defRPr>
+            </a:pPr>
+            <a:r>
+              <a:rPr sz="1600" b="0">
+                <a:solidFill>
+                  <a:srgbClr val="4F5B66"/>
+                </a:solidFill>
+                <a:latin typeface="Noto Sans TC"/>
+                <a:ea typeface="Noto Sans TC"/>
+                <a:cs typeface="Noto Sans TC"/>
+              </a:rPr>
+              <a:t>stronger fresh evidence</a:t>
+            </a:r>
+          </a:p>
+        </p:txBody>
+      </p:sp>
+      <p:sp>
+        <p:nvSpPr>
+          <p:cNvPr id="28" name="">
+            <a:extLst xmlns:a="http://schemas.openxmlformats.org/drawingml/2006/main">
+              <a:ext uri="{FF2B5EF4-FFF2-40B4-BE49-F238E27FC236}">
+                <a16:creationId xmlns:a16="http://schemas.microsoft.com/office/drawing/2014/main" id="{6563E22B-FC08-462D-B6F0-B9AA25B49D02}"/>
+              </a:ext>
+            </a:extLst>
+          </p:cNvPr>
+          <p:cNvSpPr>
+            <a:spLocks xmlns:a="http://schemas.openxmlformats.org/drawingml/2006/main" noGrp="1"/>
+          </p:cNvSpPr>
+          <p:nvPr/>
+        </p:nvSpPr>
+        <p:spPr>
+          <a:xfrm xmlns:a="http://schemas.openxmlformats.org/drawingml/2006/main">
+            <a:off x="400050" y="5953125"/>
+            <a:ext cx="10572750" cy="266700"/>
+          </a:xfrm>
+          <a:prstGeom xmlns:a="http://schemas.openxmlformats.org/drawingml/2006/main" prst="rect">
+            <a:avLst/>
+          </a:prstGeom>
+          <a:solidFill xmlns:a="http://schemas.openxmlformats.org/drawingml/2006/main">
+            <a:srgbClr val="FFF1CC"/>
+          </a:solidFill>
+          <a:ln xmlns:a="http://schemas.openxmlformats.org/drawingml/2006/main" w="0">
+            <a:noFill/>
+            <a:prstDash val="solid"/>
+          </a:ln>
+        </p:spPr>
+        <p:txBody>
+          <a:bodyPr xmlns:a="http://schemas.openxmlformats.org/drawingml/2006/main" wrap="square" lIns="0" tIns="0" rIns="0" bIns="0" anchor="t">
+            <a:normAutofit fontScale="100000"/>
+          </a:bodyPr>
+          <a:lstStyle xmlns:a="http://schemas.openxmlformats.org/drawingml/2006/main"/>
+          <a:p xmlns:a="http://schemas.openxmlformats.org/drawingml/2006/main">
+            <a:pPr algn="l">
+              <a:buNone/>
+              <a:defRPr sz="1425" b="1">
+                <a:solidFill>
+                  <a:srgbClr val="111111"/>
+                </a:solidFill>
+                <a:latin typeface="Noto Sans TC"/>
+                <a:ea typeface="Noto Sans TC"/>
+                <a:cs typeface="Noto Sans TC"/>
+              </a:defRPr>
+            </a:pPr>
+            <a:r>
+              <a:rPr sz="1100" b="1">
+                <a:solidFill>
+                  <a:srgbClr val="606B7A"/>
+                </a:solidFill>
+                <a:latin typeface="Noto Sans TC"/>
+                <a:ea typeface="Noto Sans TC"/>
+                <a:cs typeface="Noto Sans TC"/>
+              </a:rPr>
+              <a:t>Target illustration：兩條 bar 皆以相同 total effort = 100；pilot 後以實際 baseline 校準。</a:t>
+            </a:r>
+          </a:p>
+        </p:txBody>
+      </p:sp>
+      <p:graphicFrame>
+        <p:nvGraphicFramePr>
+          <p:cNvPr id="205" name="Chart"/>
+          <p:cNvGraphicFramePr/>
+          <p:nvPr/>
+        </p:nvGraphicFramePr>
+        <p:xfrm>
+          <a:off xmlns:a="http://schemas.openxmlformats.org/drawingml/2006/main" x="2609850" y="1476375"/>
+          <a:ext xmlns:a="http://schemas.openxmlformats.org/drawingml/2006/main" cx="8991600" cy="2809875"/>
+        </p:xfrm>
+        <a:graphic xmlns:a="http://schemas.openxmlformats.org/drawingml/2006/main">
+          <a:graphicData uri="http://schemas.openxmlformats.org/drawingml/2006/chart">
+            <c:chart xmlns:r="http://schemas.openxmlformats.org/officeDocument/2006/relationships" xmlns:c="http://schemas.openxmlformats.org/drawingml/2006/chart" r:id="R76d7aaea86d94263"/>
+          </a:graphicData>
+        </a:graphic>
+      </p:graphicFrame>
+    </p:spTree>
+    <p:extLst>
+      <p:ext uri="{BB962C8B-B14F-4D97-AF65-F5344CB8AC3E}">
+        <p14:creationId xmlns:p14="http://schemas.microsoft.com/office/powerpoint/2010/main" val="534048330"/>
+      </p:ext>
+    </p:extLst>
+  </p:cSld>
+</p:sld>
+</file>
+
+<file path=ppt/slides/slide11.xml><?xml version="1.0" encoding="utf-8"?>
+<p:sld xmlns:p="http://schemas.openxmlformats.org/presentationml/2006/main">
+  <p:cSld>
+    <p:bg>
+      <p:bgPr>
+        <a:solidFill xmlns:a="http://schemas.openxmlformats.org/drawingml/2006/main">
+          <a:srgbClr val="FFFFFF"/>
+        </a:solidFill>
+      </p:bgPr>
+    </p:bg>
+    <p:spTree>
+      <p:nvGrpSpPr>
+        <p:cNvPr id="1" name=""/>
+        <p:cNvGrpSpPr/>
+        <p:nvPr/>
+      </p:nvGrpSpPr>
+      <p:grpSpPr>
+        <a:xfrm xmlns:a="http://schemas.openxmlformats.org/drawingml/2006/main"/>
+      </p:grpSpPr>
+      <p:sp>
+        <p:nvSpPr>
+          <p:cNvPr id="1" name="">
+            <a:extLst xmlns:a="http://schemas.openxmlformats.org/drawingml/2006/main">
+              <a:ext uri="{FF2B5EF4-FFF2-40B4-BE49-F238E27FC236}">
+                <a16:creationId xmlns:a16="http://schemas.microsoft.com/office/drawing/2014/main" id="{B983216B-B198-4B14-A0A9-6CF04FB5A868}"/>
+              </a:ext>
+            </a:extLst>
+          </p:cNvPr>
+          <p:cNvSpPr>
+            <a:spLocks xmlns:a="http://schemas.openxmlformats.org/drawingml/2006/main" noGrp="1"/>
+          </p:cNvSpPr>
+          <p:nvPr/>
+        </p:nvSpPr>
+        <p:spPr>
+          <a:xfrm xmlns:a="http://schemas.openxmlformats.org/drawingml/2006/main">
+            <a:off x="400050" y="247650"/>
+            <a:ext cx="4953000" cy="228600"/>
+          </a:xfrm>
+          <a:prstGeom xmlns:a="http://schemas.openxmlformats.org/drawingml/2006/main" prst="rect">
+            <a:avLst/>
+          </a:prstGeom>
+          <a:noFill xmlns:a="http://schemas.openxmlformats.org/drawingml/2006/main"/>
+          <a:ln xmlns:a="http://schemas.openxmlformats.org/drawingml/2006/main" w="0">
+            <a:noFill/>
+            <a:prstDash val="solid"/>
+          </a:ln>
+        </p:spPr>
+        <p:txBody>
+          <a:bodyPr xmlns:a="http://schemas.openxmlformats.org/drawingml/2006/main" wrap="square" lIns="0" tIns="0" rIns="0" bIns="0" anchor="t">
+            <a:normAutofit fontScale="100000"/>
+          </a:bodyPr>
+          <a:lstStyle xmlns:a="http://schemas.openxmlformats.org/drawingml/2006/main"/>
+          <a:p xmlns:a="http://schemas.openxmlformats.org/drawingml/2006/main">
+            <a:pPr algn="l">
+              <a:buNone/>
+              <a:defRPr sz="900" b="1">
+                <a:solidFill>
+                  <a:srgbClr val="2478E5"/>
+                </a:solidFill>
+                <a:latin typeface="Nimbus Sans"/>
+                <a:ea typeface="Nimbus Sans"/>
+                <a:cs typeface="Nimbus Sans"/>
+              </a:defRPr>
+            </a:pPr>
+            <a:r>
+              <a:rPr sz="900" b="1">
+                <a:solidFill>
+                  <a:srgbClr val="2478E5"/>
+                </a:solidFill>
+                <a:latin typeface="Nimbus Sans"/>
+                <a:ea typeface="Nimbus Sans"/>
+                <a:cs typeface="Nimbus Sans"/>
+              </a:rPr>
+              <a:t>START USING IT</a:t>
+            </a:r>
+          </a:p>
+        </p:txBody>
+      </p:sp>
+      <p:sp>
+        <p:nvSpPr>
+          <p:cNvPr id="2" name="">
+            <a:extLst xmlns:a="http://schemas.openxmlformats.org/drawingml/2006/main">
+              <a:ext uri="{FF2B5EF4-FFF2-40B4-BE49-F238E27FC236}">
+                <a16:creationId xmlns:a16="http://schemas.microsoft.com/office/drawing/2014/main" id="{1D367F9D-C209-4CBC-B9DD-AB7A7D101EB1}"/>
+              </a:ext>
+            </a:extLst>
+          </p:cNvPr>
+          <p:cNvSpPr>
+            <a:spLocks xmlns:a="http://schemas.openxmlformats.org/drawingml/2006/main" noGrp="1"/>
+          </p:cNvSpPr>
+          <p:nvPr/>
+        </p:nvSpPr>
+        <p:spPr>
+          <a:xfrm xmlns:a="http://schemas.openxmlformats.org/drawingml/2006/main">
+            <a:off x="400050" y="552450"/>
+            <a:ext cx="11049000" cy="609600"/>
+          </a:xfrm>
+          <a:prstGeom xmlns:a="http://schemas.openxmlformats.org/drawingml/2006/main" prst="rect">
+            <a:avLst/>
+          </a:prstGeom>
+          <a:noFill xmlns:a="http://schemas.openxmlformats.org/drawingml/2006/main"/>
+          <a:ln xmlns:a="http://schemas.openxmlformats.org/drawingml/2006/main" w="0">
+            <a:noFill/>
+            <a:prstDash val="solid"/>
+          </a:ln>
+        </p:spPr>
+        <p:txBody>
+          <a:bodyPr xmlns:a="http://schemas.openxmlformats.org/drawingml/2006/main" wrap="square" lIns="0" tIns="0" rIns="0" bIns="0" anchor="t">
+            <a:noAutofit/>
+          </a:bodyPr>
+          <a:lstStyle xmlns:a="http://schemas.openxmlformats.org/drawingml/2006/main"/>
+          <a:p xmlns:a="http://schemas.openxmlformats.org/drawingml/2006/main">
+            <a:pPr algn="l">
+              <a:buNone/>
+              <a:defRPr sz="2850" b="1">
+                <a:solidFill>
+                  <a:srgbClr val="111111"/>
+                </a:solidFill>
+                <a:latin typeface="Noto Sans TC"/>
+                <a:ea typeface="Noto Sans TC"/>
+                <a:cs typeface="Noto Sans TC"/>
+              </a:defRPr>
+            </a:pPr>
+            <a:r>
+              <a:rPr sz="2850" b="1">
+                <a:solidFill>
+                  <a:srgbClr val="111111"/>
+                </a:solidFill>
+                <a:latin typeface="Noto Sans TC"/>
+                <a:ea typeface="Noto Sans TC"/>
+                <a:cs typeface="Noto Sans TC"/>
+              </a:rPr>
+              <a:t>從下一張真實 work item 開始，而不是先建立新 ceremony</a:t>
             </a:r>
           </a:p>
         </p:txBody>
       </p:sp>
       <p:cxnSp>
         <p:nvCxnSpPr>
-          <p:cNvPr id="142" name=""/>
+          <p:cNvPr id="177" name=""/>
           <p:cNvCxnSpPr/>
           <p:nvPr/>
         </p:nvCxnSpPr>
         <p:spPr>
           <a:xfrm xmlns:a="http://schemas.openxmlformats.org/drawingml/2006/main">
-            <a:off x="914400" y="2409825"/>
-            <a:ext cx="4476750" cy="0"/>
+            <a:off x="400050" y="1238250"/>
+            <a:ext cx="11391900" cy="0"/>
           </a:xfrm>
           <a:prstGeom xmlns:a="http://schemas.openxmlformats.org/drawingml/2006/main" prst="straightConnector1">
             <a:avLst/>
@@ -2529,22 +4016,22 @@
       </p:cxnSp>
       <p:sp>
         <p:nvSpPr>
-          <p:cNvPr id="9" name="">
-            <a:extLst xmlns:a="http://schemas.openxmlformats.org/drawingml/2006/main">
-              <a:ext uri="{FF2B5EF4-FFF2-40B4-BE49-F238E27FC236}">
-                <a16:creationId xmlns:a16="http://schemas.microsoft.com/office/drawing/2014/main" id="{4B5124EC-0E88-44EC-AC94-B26B74D9C738}"/>
-              </a:ext>
-            </a:extLst>
-          </p:cNvPr>
-          <p:cNvSpPr>
-            <a:spLocks xmlns:a="http://schemas.openxmlformats.org/drawingml/2006/main" noGrp="1"/>
-          </p:cNvSpPr>
-          <p:nvPr/>
-        </p:nvSpPr>
-        <p:spPr>
-          <a:xfrm xmlns:a="http://schemas.openxmlformats.org/drawingml/2006/main">
-            <a:off x="400050" y="2657475"/>
-            <a:ext cx="400050" cy="323850"/>
+          <p:cNvPr id="4" name="">
+            <a:extLst xmlns:a="http://schemas.openxmlformats.org/drawingml/2006/main">
+              <a:ext uri="{FF2B5EF4-FFF2-40B4-BE49-F238E27FC236}">
+                <a16:creationId xmlns:a16="http://schemas.microsoft.com/office/drawing/2014/main" id="{05575A72-5745-4C7E-B098-7D5AF62AE39C}"/>
+              </a:ext>
+            </a:extLst>
+          </p:cNvPr>
+          <p:cNvSpPr>
+            <a:spLocks xmlns:a="http://schemas.openxmlformats.org/drawingml/2006/main" noGrp="1"/>
+          </p:cNvSpPr>
+          <p:nvPr/>
+        </p:nvSpPr>
+        <p:spPr>
+          <a:xfrm xmlns:a="http://schemas.openxmlformats.org/drawingml/2006/main">
+            <a:off x="11287125" y="6419850"/>
+            <a:ext cx="495300" cy="190500"/>
           </a:xfrm>
           <a:prstGeom xmlns:a="http://schemas.openxmlformats.org/drawingml/2006/main" prst="rect">
             <a:avLst/>
@@ -2561,49 +4048,49 @@
           </a:bodyPr>
           <a:lstStyle xmlns:a="http://schemas.openxmlformats.org/drawingml/2006/main"/>
           <a:p xmlns:a="http://schemas.openxmlformats.org/drawingml/2006/main">
-            <a:pPr algn="l">
-              <a:buNone/>
-              <a:defRPr sz="1800" b="1">
-                <a:solidFill>
-                  <a:srgbClr val="2478E5"/>
-                </a:solidFill>
-                <a:latin typeface="Noto Sans TC"/>
-                <a:ea typeface="Noto Sans TC"/>
-                <a:cs typeface="Noto Sans TC"/>
-              </a:defRPr>
-            </a:pPr>
-            <a:r>
-              <a:rPr sz="1800" b="1">
-                <a:solidFill>
-                  <a:srgbClr val="2478E5"/>
-                </a:solidFill>
-                <a:latin typeface="Noto Sans TC"/>
-                <a:ea typeface="Noto Sans TC"/>
-                <a:cs typeface="Noto Sans TC"/>
-              </a:rPr>
-              <a:t>2</a:t>
-            </a:r>
-          </a:p>
-        </p:txBody>
-      </p:sp>
-      <p:sp>
-        <p:nvSpPr>
-          <p:cNvPr id="10" name="">
-            <a:extLst xmlns:a="http://schemas.openxmlformats.org/drawingml/2006/main">
-              <a:ext uri="{FF2B5EF4-FFF2-40B4-BE49-F238E27FC236}">
-                <a16:creationId xmlns:a16="http://schemas.microsoft.com/office/drawing/2014/main" id="{85FF5DA1-1519-47AD-90FB-8482D8AB2D7B}"/>
-              </a:ext>
-            </a:extLst>
-          </p:cNvPr>
-          <p:cNvSpPr>
-            <a:spLocks xmlns:a="http://schemas.openxmlformats.org/drawingml/2006/main" noGrp="1"/>
-          </p:cNvSpPr>
-          <p:nvPr/>
-        </p:nvSpPr>
-        <p:spPr>
-          <a:xfrm xmlns:a="http://schemas.openxmlformats.org/drawingml/2006/main">
-            <a:off x="914400" y="2676525"/>
-            <a:ext cx="4476750" cy="323850"/>
+            <a:pPr algn="r">
+              <a:buNone/>
+              <a:defRPr sz="900" b="0">
+                <a:solidFill>
+                  <a:srgbClr val="5C6570"/>
+                </a:solidFill>
+                <a:latin typeface="Noto Sans TC"/>
+                <a:ea typeface="Noto Sans TC"/>
+                <a:cs typeface="Noto Sans TC"/>
+              </a:defRPr>
+            </a:pPr>
+            <a:r>
+              <a:rPr sz="1200" b="0">
+                <a:solidFill>
+                  <a:srgbClr val="5C6570"/>
+                </a:solidFill>
+                <a:latin typeface="Noto Sans TC"/>
+                <a:ea typeface="Noto Sans TC"/>
+                <a:cs typeface="Noto Sans TC"/>
+              </a:rPr>
+              <a:t>11</a:t>
+            </a:r>
+          </a:p>
+        </p:txBody>
+      </p:sp>
+      <p:sp>
+        <p:nvSpPr>
+          <p:cNvPr id="5" name="">
+            <a:extLst xmlns:a="http://schemas.openxmlformats.org/drawingml/2006/main">
+              <a:ext uri="{FF2B5EF4-FFF2-40B4-BE49-F238E27FC236}">
+                <a16:creationId xmlns:a16="http://schemas.microsoft.com/office/drawing/2014/main" id="{013AD55B-C19C-4B6C-A349-C2B0CC0D8EDE}"/>
+              </a:ext>
+            </a:extLst>
+          </p:cNvPr>
+          <p:cNvSpPr>
+            <a:spLocks xmlns:a="http://schemas.openxmlformats.org/drawingml/2006/main" noGrp="1"/>
+          </p:cNvSpPr>
+          <p:nvPr/>
+        </p:nvSpPr>
+        <p:spPr>
+          <a:xfrm xmlns:a="http://schemas.openxmlformats.org/drawingml/2006/main">
+            <a:off x="400050" y="1504950"/>
+            <a:ext cx="4191000" cy="266700"/>
           </a:xfrm>
           <a:prstGeom xmlns:a="http://schemas.openxmlformats.org/drawingml/2006/main" prst="rect">
             <a:avLst/>
@@ -2622,6 +4109,124 @@
           <a:p xmlns:a="http://schemas.openxmlformats.org/drawingml/2006/main">
             <a:pPr algn="l">
               <a:buNone/>
+              <a:defRPr sz="1125" b="1">
+                <a:solidFill>
+                  <a:srgbClr val="2478E5"/>
+                </a:solidFill>
+                <a:latin typeface="Noto Sans TC"/>
+                <a:ea typeface="Noto Sans TC"/>
+                <a:cs typeface="Noto Sans TC"/>
+              </a:defRPr>
+            </a:pPr>
+            <a:r>
+              <a:rPr sz="1125" b="1">
+                <a:solidFill>
+                  <a:srgbClr val="2478E5"/>
+                </a:solidFill>
+                <a:latin typeface="Noto Sans TC"/>
+                <a:ea typeface="Noto Sans TC"/>
+                <a:cs typeface="Noto Sans TC"/>
+              </a:rPr>
+              <a:t>ENGINEER · 60-SECOND START</a:t>
+            </a:r>
+          </a:p>
+        </p:txBody>
+      </p:sp>
+      <p:sp>
+        <p:nvSpPr>
+          <p:cNvPr id="6" name="">
+            <a:extLst xmlns:a="http://schemas.openxmlformats.org/drawingml/2006/main">
+              <a:ext uri="{FF2B5EF4-FFF2-40B4-BE49-F238E27FC236}">
+                <a16:creationId xmlns:a16="http://schemas.microsoft.com/office/drawing/2014/main" id="{9630A5C1-B68D-47AD-9009-56B9A69D36BE}"/>
+              </a:ext>
+            </a:extLst>
+          </p:cNvPr>
+          <p:cNvSpPr>
+            <a:spLocks xmlns:a="http://schemas.openxmlformats.org/drawingml/2006/main" noGrp="1"/>
+          </p:cNvSpPr>
+          <p:nvPr/>
+        </p:nvSpPr>
+        <p:spPr>
+          <a:xfrm xmlns:a="http://schemas.openxmlformats.org/drawingml/2006/main">
+            <a:off x="400050" y="2019300"/>
+            <a:ext cx="400050" cy="323850"/>
+          </a:xfrm>
+          <a:prstGeom xmlns:a="http://schemas.openxmlformats.org/drawingml/2006/main" prst="rect">
+            <a:avLst/>
+          </a:prstGeom>
+          <a:noFill xmlns:a="http://schemas.openxmlformats.org/drawingml/2006/main"/>
+          <a:ln xmlns:a="http://schemas.openxmlformats.org/drawingml/2006/main" w="0">
+            <a:noFill/>
+            <a:prstDash val="solid"/>
+          </a:ln>
+        </p:spPr>
+        <p:txBody>
+          <a:bodyPr xmlns:a="http://schemas.openxmlformats.org/drawingml/2006/main" wrap="square" lIns="0" tIns="0" rIns="0" bIns="0" anchor="t">
+            <a:normAutofit fontScale="100000"/>
+          </a:bodyPr>
+          <a:lstStyle xmlns:a="http://schemas.openxmlformats.org/drawingml/2006/main"/>
+          <a:p xmlns:a="http://schemas.openxmlformats.org/drawingml/2006/main">
+            <a:pPr algn="l">
+              <a:buNone/>
+              <a:defRPr sz="1800" b="1">
+                <a:solidFill>
+                  <a:srgbClr val="2478E5"/>
+                </a:solidFill>
+                <a:latin typeface="Noto Sans TC"/>
+                <a:ea typeface="Noto Sans TC"/>
+                <a:cs typeface="Noto Sans TC"/>
+              </a:defRPr>
+            </a:pPr>
+            <a:r>
+              <a:rPr sz="1800" b="1">
+                <a:solidFill>
+                  <a:srgbClr val="2478E5"/>
+                </a:solidFill>
+                <a:latin typeface="Noto Sans TC"/>
+                <a:ea typeface="Noto Sans TC"/>
+                <a:cs typeface="Noto Sans TC"/>
+              </a:rPr>
+              <a:t>1</a:t>
+            </a:r>
+          </a:p>
+        </p:txBody>
+      </p:sp>
+      <p:sp>
+        <p:nvSpPr>
+          <p:cNvPr id="7" name="">
+            <a:extLst xmlns:a="http://schemas.openxmlformats.org/drawingml/2006/main">
+              <a:ext uri="{FF2B5EF4-FFF2-40B4-BE49-F238E27FC236}">
+                <a16:creationId xmlns:a16="http://schemas.microsoft.com/office/drawing/2014/main" id="{90AD2C76-2802-408E-A12C-7AF062965AB4}"/>
+              </a:ext>
+            </a:extLst>
+          </p:cNvPr>
+          <p:cNvSpPr>
+            <a:spLocks xmlns:a="http://schemas.openxmlformats.org/drawingml/2006/main" noGrp="1"/>
+          </p:cNvSpPr>
+          <p:nvPr/>
+        </p:nvSpPr>
+        <p:spPr>
+          <a:xfrm xmlns:a="http://schemas.openxmlformats.org/drawingml/2006/main">
+            <a:off x="914400" y="2038350"/>
+            <a:ext cx="4476750" cy="323850"/>
+          </a:xfrm>
+          <a:prstGeom xmlns:a="http://schemas.openxmlformats.org/drawingml/2006/main" prst="rect">
+            <a:avLst/>
+          </a:prstGeom>
+          <a:noFill xmlns:a="http://schemas.openxmlformats.org/drawingml/2006/main"/>
+          <a:ln xmlns:a="http://schemas.openxmlformats.org/drawingml/2006/main" w="0">
+            <a:noFill/>
+            <a:prstDash val="solid"/>
+          </a:ln>
+        </p:spPr>
+        <p:txBody>
+          <a:bodyPr xmlns:a="http://schemas.openxmlformats.org/drawingml/2006/main" wrap="square" lIns="0" tIns="0" rIns="0" bIns="0" anchor="t">
+            <a:normAutofit fontScale="100000"/>
+          </a:bodyPr>
+          <a:lstStyle xmlns:a="http://schemas.openxmlformats.org/drawingml/2006/main"/>
+          <a:p xmlns:a="http://schemas.openxmlformats.org/drawingml/2006/main">
+            <a:pPr algn="l">
+              <a:buNone/>
               <a:defRPr sz="1350" b="1">
                 <a:solidFill>
                   <a:srgbClr val="111111"/>
@@ -2640,20 +4245,20 @@
                 <a:ea typeface="Noto Sans TC"/>
                 <a:cs typeface="Noto Sans TC"/>
               </a:rPr>
-              <a:t>確認 Archetype 與 Control Profile</a:t>
+              <a:t>選 P3 / P2 / P1 / P0 與 P0 type</a:t>
             </a:r>
           </a:p>
         </p:txBody>
       </p:sp>
       <p:cxnSp>
         <p:nvCxnSpPr>
-          <p:cNvPr id="145" name=""/>
+          <p:cNvPr id="182" name=""/>
           <p:cNvCxnSpPr/>
           <p:nvPr/>
         </p:nvCxnSpPr>
         <p:spPr>
           <a:xfrm xmlns:a="http://schemas.openxmlformats.org/drawingml/2006/main">
-            <a:off x="914400" y="3048000"/>
+            <a:off x="914400" y="2409825"/>
             <a:ext cx="4476750" cy="0"/>
           </a:xfrm>
           <a:prstGeom xmlns:a="http://schemas.openxmlformats.org/drawingml/2006/main" prst="straightConnector1">
@@ -2669,21 +4274,21 @@
       </p:cxnSp>
       <p:sp>
         <p:nvSpPr>
-          <p:cNvPr id="12" name="">
-            <a:extLst xmlns:a="http://schemas.openxmlformats.org/drawingml/2006/main">
-              <a:ext uri="{FF2B5EF4-FFF2-40B4-BE49-F238E27FC236}">
-                <a16:creationId xmlns:a16="http://schemas.microsoft.com/office/drawing/2014/main" id="{732BB758-A06A-43D7-9FEF-1CB8A55FDDCE}"/>
-              </a:ext>
-            </a:extLst>
-          </p:cNvPr>
-          <p:cNvSpPr>
-            <a:spLocks xmlns:a="http://schemas.openxmlformats.org/drawingml/2006/main" noGrp="1"/>
-          </p:cNvSpPr>
-          <p:nvPr/>
-        </p:nvSpPr>
-        <p:spPr>
-          <a:xfrm xmlns:a="http://schemas.openxmlformats.org/drawingml/2006/main">
-            <a:off x="400050" y="3295650"/>
+          <p:cNvPr id="9" name="">
+            <a:extLst xmlns:a="http://schemas.openxmlformats.org/drawingml/2006/main">
+              <a:ext uri="{FF2B5EF4-FFF2-40B4-BE49-F238E27FC236}">
+                <a16:creationId xmlns:a16="http://schemas.microsoft.com/office/drawing/2014/main" id="{4B5124EC-0E88-44EC-AC94-B26B74D9C738}"/>
+              </a:ext>
+            </a:extLst>
+          </p:cNvPr>
+          <p:cNvSpPr>
+            <a:spLocks xmlns:a="http://schemas.openxmlformats.org/drawingml/2006/main" noGrp="1"/>
+          </p:cNvSpPr>
+          <p:nvPr/>
+        </p:nvSpPr>
+        <p:spPr>
+          <a:xfrm xmlns:a="http://schemas.openxmlformats.org/drawingml/2006/main">
+            <a:off x="400050" y="2657475"/>
             <a:ext cx="400050" cy="323850"/>
           </a:xfrm>
           <a:prstGeom xmlns:a="http://schemas.openxmlformats.org/drawingml/2006/main" prst="rect">
@@ -2721,28 +4326,28 @@
                 <a:ea typeface="Noto Sans TC"/>
                 <a:cs typeface="Noto Sans TC"/>
               </a:rPr>
-              <a:t>3</a:t>
-            </a:r>
-          </a:p>
-        </p:txBody>
-      </p:sp>
-      <p:sp>
-        <p:nvSpPr>
-          <p:cNvPr id="13" name="">
-            <a:extLst xmlns:a="http://schemas.openxmlformats.org/drawingml/2006/main">
-              <a:ext uri="{FF2B5EF4-FFF2-40B4-BE49-F238E27FC236}">
-                <a16:creationId xmlns:a16="http://schemas.microsoft.com/office/drawing/2014/main" id="{BAF8F88E-9677-4CEA-A527-08C99AFBDB07}"/>
-              </a:ext>
-            </a:extLst>
-          </p:cNvPr>
-          <p:cNvSpPr>
-            <a:spLocks xmlns:a="http://schemas.openxmlformats.org/drawingml/2006/main" noGrp="1"/>
-          </p:cNvSpPr>
-          <p:nvPr/>
-        </p:nvSpPr>
-        <p:spPr>
-          <a:xfrm xmlns:a="http://schemas.openxmlformats.org/drawingml/2006/main">
-            <a:off x="914400" y="3314700"/>
+              <a:t>2</a:t>
+            </a:r>
+          </a:p>
+        </p:txBody>
+      </p:sp>
+      <p:sp>
+        <p:nvSpPr>
+          <p:cNvPr id="10" name="">
+            <a:extLst xmlns:a="http://schemas.openxmlformats.org/drawingml/2006/main">
+              <a:ext uri="{FF2B5EF4-FFF2-40B4-BE49-F238E27FC236}">
+                <a16:creationId xmlns:a16="http://schemas.microsoft.com/office/drawing/2014/main" id="{85FF5DA1-1519-47AD-90FB-8482D8AB2D7B}"/>
+              </a:ext>
+            </a:extLst>
+          </p:cNvPr>
+          <p:cNvSpPr>
+            <a:spLocks xmlns:a="http://schemas.openxmlformats.org/drawingml/2006/main" noGrp="1"/>
+          </p:cNvSpPr>
+          <p:nvPr/>
+        </p:nvSpPr>
+        <p:spPr>
+          <a:xfrm xmlns:a="http://schemas.openxmlformats.org/drawingml/2006/main">
+            <a:off x="914400" y="2676525"/>
             <a:ext cx="4476750" cy="323850"/>
           </a:xfrm>
           <a:prstGeom xmlns:a="http://schemas.openxmlformats.org/drawingml/2006/main" prst="rect">
@@ -2780,20 +4385,20 @@
                 <a:ea typeface="Noto Sans TC"/>
                 <a:cs typeface="Noto Sans TC"/>
               </a:rPr>
-              <a:t>找第一個還不能回答的 Golden Stage</a:t>
+              <a:t>確認 Archetype 與 Control Profile</a:t>
             </a:r>
           </a:p>
         </p:txBody>
       </p:sp>
       <p:cxnSp>
         <p:nvCxnSpPr>
-          <p:cNvPr id="148" name=""/>
+          <p:cNvPr id="185" name=""/>
           <p:cNvCxnSpPr/>
           <p:nvPr/>
         </p:nvCxnSpPr>
         <p:spPr>
           <a:xfrm xmlns:a="http://schemas.openxmlformats.org/drawingml/2006/main">
-            <a:off x="914400" y="3686175"/>
+            <a:off x="914400" y="3048000"/>
             <a:ext cx="4476750" cy="0"/>
           </a:xfrm>
           <a:prstGeom xmlns:a="http://schemas.openxmlformats.org/drawingml/2006/main" prst="straightConnector1">
@@ -2809,21 +4414,21 @@
       </p:cxnSp>
       <p:sp>
         <p:nvSpPr>
-          <p:cNvPr id="15" name="">
-            <a:extLst xmlns:a="http://schemas.openxmlformats.org/drawingml/2006/main">
-              <a:ext uri="{FF2B5EF4-FFF2-40B4-BE49-F238E27FC236}">
-                <a16:creationId xmlns:a16="http://schemas.microsoft.com/office/drawing/2014/main" id="{2E5046E0-440B-4A81-BCA5-60A57B44642E}"/>
-              </a:ext>
-            </a:extLst>
-          </p:cNvPr>
-          <p:cNvSpPr>
-            <a:spLocks xmlns:a="http://schemas.openxmlformats.org/drawingml/2006/main" noGrp="1"/>
-          </p:cNvSpPr>
-          <p:nvPr/>
-        </p:nvSpPr>
-        <p:spPr>
-          <a:xfrm xmlns:a="http://schemas.openxmlformats.org/drawingml/2006/main">
-            <a:off x="400050" y="3933825"/>
+          <p:cNvPr id="12" name="">
+            <a:extLst xmlns:a="http://schemas.openxmlformats.org/drawingml/2006/main">
+              <a:ext uri="{FF2B5EF4-FFF2-40B4-BE49-F238E27FC236}">
+                <a16:creationId xmlns:a16="http://schemas.microsoft.com/office/drawing/2014/main" id="{732BB758-A06A-43D7-9FEF-1CB8A55FDDCE}"/>
+              </a:ext>
+            </a:extLst>
+          </p:cNvPr>
+          <p:cNvSpPr>
+            <a:spLocks xmlns:a="http://schemas.openxmlformats.org/drawingml/2006/main" noGrp="1"/>
+          </p:cNvSpPr>
+          <p:nvPr/>
+        </p:nvSpPr>
+        <p:spPr>
+          <a:xfrm xmlns:a="http://schemas.openxmlformats.org/drawingml/2006/main">
+            <a:off x="400050" y="3295650"/>
             <a:ext cx="400050" cy="323850"/>
           </a:xfrm>
           <a:prstGeom xmlns:a="http://schemas.openxmlformats.org/drawingml/2006/main" prst="rect">
@@ -2861,28 +4466,28 @@
                 <a:ea typeface="Noto Sans TC"/>
                 <a:cs typeface="Noto Sans TC"/>
               </a:rPr>
-              <a:t>4</a:t>
-            </a:r>
-          </a:p>
-        </p:txBody>
-      </p:sp>
-      <p:sp>
-        <p:nvSpPr>
-          <p:cNvPr id="16" name="">
-            <a:extLst xmlns:a="http://schemas.openxmlformats.org/drawingml/2006/main">
-              <a:ext uri="{FF2B5EF4-FFF2-40B4-BE49-F238E27FC236}">
-                <a16:creationId xmlns:a16="http://schemas.microsoft.com/office/drawing/2014/main" id="{3E215CA2-2FA4-404B-BA2C-02ADAD9BDD7A}"/>
-              </a:ext>
-            </a:extLst>
-          </p:cNvPr>
-          <p:cNvSpPr>
-            <a:spLocks xmlns:a="http://schemas.openxmlformats.org/drawingml/2006/main" noGrp="1"/>
-          </p:cNvSpPr>
-          <p:nvPr/>
-        </p:nvSpPr>
-        <p:spPr>
-          <a:xfrm xmlns:a="http://schemas.openxmlformats.org/drawingml/2006/main">
-            <a:off x="914400" y="3952875"/>
+              <a:t>3</a:t>
+            </a:r>
+          </a:p>
+        </p:txBody>
+      </p:sp>
+      <p:sp>
+        <p:nvSpPr>
+          <p:cNvPr id="13" name="">
+            <a:extLst xmlns:a="http://schemas.openxmlformats.org/drawingml/2006/main">
+              <a:ext uri="{FF2B5EF4-FFF2-40B4-BE49-F238E27FC236}">
+                <a16:creationId xmlns:a16="http://schemas.microsoft.com/office/drawing/2014/main" id="{BAF8F88E-9677-4CEA-A527-08C99AFBDB07}"/>
+              </a:ext>
+            </a:extLst>
+          </p:cNvPr>
+          <p:cNvSpPr>
+            <a:spLocks xmlns:a="http://schemas.openxmlformats.org/drawingml/2006/main" noGrp="1"/>
+          </p:cNvSpPr>
+          <p:nvPr/>
+        </p:nvSpPr>
+        <p:spPr>
+          <a:xfrm xmlns:a="http://schemas.openxmlformats.org/drawingml/2006/main">
+            <a:off x="914400" y="3314700"/>
             <a:ext cx="4476750" cy="323850"/>
           </a:xfrm>
           <a:prstGeom xmlns:a="http://schemas.openxmlformats.org/drawingml/2006/main" prst="rect">
@@ -2920,20 +4525,20 @@
                 <a:ea typeface="Noto Sans TC"/>
                 <a:cs typeface="Noto Sans TC"/>
               </a:rPr>
-              <a:t>執行一個 lead skill，留下 minimum artifact</a:t>
+              <a:t>找第一個還不能回答的 Golden Stage</a:t>
             </a:r>
           </a:p>
         </p:txBody>
       </p:sp>
       <p:cxnSp>
         <p:nvCxnSpPr>
-          <p:cNvPr id="151" name=""/>
+          <p:cNvPr id="188" name=""/>
           <p:cNvCxnSpPr/>
           <p:nvPr/>
         </p:nvCxnSpPr>
         <p:spPr>
           <a:xfrm xmlns:a="http://schemas.openxmlformats.org/drawingml/2006/main">
-            <a:off x="914400" y="4324350"/>
+            <a:off x="914400" y="3686175"/>
             <a:ext cx="4476750" cy="0"/>
           </a:xfrm>
           <a:prstGeom xmlns:a="http://schemas.openxmlformats.org/drawingml/2006/main" prst="straightConnector1">
@@ -2949,6 +4554,146 @@
       </p:cxnSp>
       <p:sp>
         <p:nvSpPr>
+          <p:cNvPr id="15" name="">
+            <a:extLst xmlns:a="http://schemas.openxmlformats.org/drawingml/2006/main">
+              <a:ext uri="{FF2B5EF4-FFF2-40B4-BE49-F238E27FC236}">
+                <a16:creationId xmlns:a16="http://schemas.microsoft.com/office/drawing/2014/main" id="{2E5046E0-440B-4A81-BCA5-60A57B44642E}"/>
+              </a:ext>
+            </a:extLst>
+          </p:cNvPr>
+          <p:cNvSpPr>
+            <a:spLocks xmlns:a="http://schemas.openxmlformats.org/drawingml/2006/main" noGrp="1"/>
+          </p:cNvSpPr>
+          <p:nvPr/>
+        </p:nvSpPr>
+        <p:spPr>
+          <a:xfrm xmlns:a="http://schemas.openxmlformats.org/drawingml/2006/main">
+            <a:off x="400050" y="3933825"/>
+            <a:ext cx="400050" cy="323850"/>
+          </a:xfrm>
+          <a:prstGeom xmlns:a="http://schemas.openxmlformats.org/drawingml/2006/main" prst="rect">
+            <a:avLst/>
+          </a:prstGeom>
+          <a:noFill xmlns:a="http://schemas.openxmlformats.org/drawingml/2006/main"/>
+          <a:ln xmlns:a="http://schemas.openxmlformats.org/drawingml/2006/main" w="0">
+            <a:noFill/>
+            <a:prstDash val="solid"/>
+          </a:ln>
+        </p:spPr>
+        <p:txBody>
+          <a:bodyPr xmlns:a="http://schemas.openxmlformats.org/drawingml/2006/main" wrap="square" lIns="0" tIns="0" rIns="0" bIns="0" anchor="t">
+            <a:normAutofit fontScale="100000"/>
+          </a:bodyPr>
+          <a:lstStyle xmlns:a="http://schemas.openxmlformats.org/drawingml/2006/main"/>
+          <a:p xmlns:a="http://schemas.openxmlformats.org/drawingml/2006/main">
+            <a:pPr algn="l">
+              <a:buNone/>
+              <a:defRPr sz="1800" b="1">
+                <a:solidFill>
+                  <a:srgbClr val="2478E5"/>
+                </a:solidFill>
+                <a:latin typeface="Noto Sans TC"/>
+                <a:ea typeface="Noto Sans TC"/>
+                <a:cs typeface="Noto Sans TC"/>
+              </a:defRPr>
+            </a:pPr>
+            <a:r>
+              <a:rPr sz="1800" b="1">
+                <a:solidFill>
+                  <a:srgbClr val="2478E5"/>
+                </a:solidFill>
+                <a:latin typeface="Noto Sans TC"/>
+                <a:ea typeface="Noto Sans TC"/>
+                <a:cs typeface="Noto Sans TC"/>
+              </a:rPr>
+              <a:t>4</a:t>
+            </a:r>
+          </a:p>
+        </p:txBody>
+      </p:sp>
+      <p:sp>
+        <p:nvSpPr>
+          <p:cNvPr id="16" name="">
+            <a:extLst xmlns:a="http://schemas.openxmlformats.org/drawingml/2006/main">
+              <a:ext uri="{FF2B5EF4-FFF2-40B4-BE49-F238E27FC236}">
+                <a16:creationId xmlns:a16="http://schemas.microsoft.com/office/drawing/2014/main" id="{3E215CA2-2FA4-404B-BA2C-02ADAD9BDD7A}"/>
+              </a:ext>
+            </a:extLst>
+          </p:cNvPr>
+          <p:cNvSpPr>
+            <a:spLocks xmlns:a="http://schemas.openxmlformats.org/drawingml/2006/main" noGrp="1"/>
+          </p:cNvSpPr>
+          <p:nvPr/>
+        </p:nvSpPr>
+        <p:spPr>
+          <a:xfrm xmlns:a="http://schemas.openxmlformats.org/drawingml/2006/main">
+            <a:off x="914400" y="3952875"/>
+            <a:ext cx="4476750" cy="323850"/>
+          </a:xfrm>
+          <a:prstGeom xmlns:a="http://schemas.openxmlformats.org/drawingml/2006/main" prst="rect">
+            <a:avLst/>
+          </a:prstGeom>
+          <a:noFill xmlns:a="http://schemas.openxmlformats.org/drawingml/2006/main"/>
+          <a:ln xmlns:a="http://schemas.openxmlformats.org/drawingml/2006/main" w="0">
+            <a:noFill/>
+            <a:prstDash val="solid"/>
+          </a:ln>
+        </p:spPr>
+        <p:txBody>
+          <a:bodyPr xmlns:a="http://schemas.openxmlformats.org/drawingml/2006/main" wrap="square" lIns="0" tIns="0" rIns="0" bIns="0" anchor="t">
+            <a:normAutofit fontScale="100000"/>
+          </a:bodyPr>
+          <a:lstStyle xmlns:a="http://schemas.openxmlformats.org/drawingml/2006/main"/>
+          <a:p xmlns:a="http://schemas.openxmlformats.org/drawingml/2006/main">
+            <a:pPr algn="l">
+              <a:buNone/>
+              <a:defRPr sz="1350" b="1">
+                <a:solidFill>
+                  <a:srgbClr val="111111"/>
+                </a:solidFill>
+                <a:latin typeface="Noto Sans TC"/>
+                <a:ea typeface="Noto Sans TC"/>
+                <a:cs typeface="Noto Sans TC"/>
+              </a:defRPr>
+            </a:pPr>
+            <a:r>
+              <a:rPr sz="1350" b="1">
+                <a:solidFill>
+                  <a:srgbClr val="111111"/>
+                </a:solidFill>
+                <a:latin typeface="Noto Sans TC"/>
+                <a:ea typeface="Noto Sans TC"/>
+                <a:cs typeface="Noto Sans TC"/>
+              </a:rPr>
+              <a:t>執行一個 lead skill，留下 minimum artifact</a:t>
+            </a:r>
+          </a:p>
+        </p:txBody>
+      </p:sp>
+      <p:cxnSp>
+        <p:nvCxnSpPr>
+          <p:cNvPr id="191" name=""/>
+          <p:cNvCxnSpPr/>
+          <p:nvPr/>
+        </p:nvCxnSpPr>
+        <p:spPr>
+          <a:xfrm xmlns:a="http://schemas.openxmlformats.org/drawingml/2006/main">
+            <a:off x="914400" y="4324350"/>
+            <a:ext cx="4476750" cy="0"/>
+          </a:xfrm>
+          <a:prstGeom xmlns:a="http://schemas.openxmlformats.org/drawingml/2006/main" prst="straightConnector1">
+            <a:avLst/>
+          </a:prstGeom>
+          <a:ln xmlns:a="http://schemas.openxmlformats.org/drawingml/2006/main" w="9525">
+            <a:solidFill>
+              <a:srgbClr val="B8BCC4"/>
+            </a:solidFill>
+            <a:prstDash val="solid"/>
+          </a:ln>
+        </p:spPr>
+      </p:cxnSp>
+      <p:sp>
+        <p:nvSpPr>
           <p:cNvPr id="18" name="">
             <a:extLst xmlns:a="http://schemas.openxmlformats.org/drawingml/2006/main">
               <a:ext uri="{FF2B5EF4-FFF2-40B4-BE49-F238E27FC236}">
@@ -3067,7 +4812,7 @@
       </p:sp>
       <p:cxnSp>
         <p:nvCxnSpPr>
-          <p:cNvPr id="154" name=""/>
+          <p:cNvPr id="194" name=""/>
           <p:cNvCxnSpPr/>
           <p:nvPr/>
         </p:nvCxnSpPr>
@@ -3915,7 +5660,7 @@
       </p:sp>
       <p:cxnSp>
         <p:nvCxnSpPr>
-          <p:cNvPr id="29" name=""/>
+          <p:cNvPr id="33" name=""/>
           <p:cNvCxnSpPr/>
           <p:nvPr/>
         </p:nvCxnSpPr>
@@ -4826,7 +6571,7 @@
       </p:sp>
       <p:cxnSp>
         <p:nvCxnSpPr>
-          <p:cNvPr id="192" name=""/>
+          <p:cNvPr id="254" name=""/>
           <p:cNvCxnSpPr/>
           <p:nvPr/>
         </p:nvCxnSpPr>
@@ -5056,7 +6801,7 @@
       </p:sp>
       <p:cxnSp>
         <p:nvCxnSpPr>
-          <p:cNvPr id="197" name=""/>
+          <p:cNvPr id="259" name=""/>
           <p:cNvCxnSpPr/>
           <p:nvPr/>
         </p:nvCxnSpPr>
@@ -5078,7 +6823,7 @@
       </p:cxnSp>
       <p:cxnSp>
         <p:nvCxnSpPr>
-          <p:cNvPr id="198" name=""/>
+          <p:cNvPr id="260" name=""/>
           <p:cNvCxnSpPr/>
           <p:nvPr/>
         </p:nvCxnSpPr>
@@ -5100,7 +6845,7 @@
       </p:cxnSp>
       <p:cxnSp>
         <p:nvCxnSpPr>
-          <p:cNvPr id="199" name=""/>
+          <p:cNvPr id="261" name=""/>
           <p:cNvCxnSpPr/>
           <p:nvPr/>
         </p:nvCxnSpPr>
@@ -5122,7 +6867,7 @@
       </p:cxnSp>
       <p:cxnSp>
         <p:nvCxnSpPr>
-          <p:cNvPr id="200" name=""/>
+          <p:cNvPr id="262" name=""/>
           <p:cNvCxnSpPr/>
           <p:nvPr/>
         </p:nvCxnSpPr>
@@ -6184,7 +7929,7 @@
       </p:sp>
       <p:cxnSp>
         <p:nvCxnSpPr>
-          <p:cNvPr id="221" name=""/>
+          <p:cNvPr id="283" name=""/>
           <p:cNvCxnSpPr/>
           <p:nvPr/>
         </p:nvCxnSpPr>
@@ -6502,7 +8247,7 @@
       </p:sp>
       <p:cxnSp>
         <p:nvCxnSpPr>
-          <p:cNvPr id="70" name=""/>
+          <p:cNvPr id="82" name=""/>
           <p:cNvCxnSpPr/>
           <p:nvPr/>
         </p:nvCxnSpPr>
@@ -6583,7 +8328,7 @@
       </p:sp>
       <p:cxnSp>
         <p:nvCxnSpPr>
-          <p:cNvPr id="72" name=""/>
+          <p:cNvPr id="84" name=""/>
           <p:cNvCxnSpPr/>
           <p:nvPr/>
         </p:nvCxnSpPr>
@@ -6605,7 +8350,7 @@
       </p:cxnSp>
       <p:cxnSp>
         <p:nvCxnSpPr>
-          <p:cNvPr id="73" name=""/>
+          <p:cNvPr id="85" name=""/>
           <p:cNvCxnSpPr/>
           <p:nvPr/>
         </p:nvCxnSpPr>
@@ -6627,7 +8372,7 @@
       </p:cxnSp>
       <p:cxnSp>
         <p:nvCxnSpPr>
-          <p:cNvPr id="74" name=""/>
+          <p:cNvPr id="86" name=""/>
           <p:cNvCxnSpPr/>
           <p:nvPr/>
         </p:nvCxnSpPr>
@@ -8373,7 +10118,7 @@
       </p:sp>
       <p:cxnSp>
         <p:nvCxnSpPr>
-          <p:cNvPr id="77" name=""/>
+          <p:cNvPr id="81" name=""/>
           <p:cNvCxnSpPr/>
           <p:nvPr/>
         </p:nvCxnSpPr>
@@ -11914,7 +13659,7 @@
       </p:sp>
       <p:cxnSp>
         <p:nvCxnSpPr>
-          <p:cNvPr id="63" name=""/>
+          <p:cNvPr id="77" name=""/>
           <p:cNvCxnSpPr/>
           <p:nvPr/>
         </p:nvCxnSpPr>
@@ -11995,7 +13740,7 @@
       </p:sp>
       <p:cxnSp>
         <p:nvCxnSpPr>
-          <p:cNvPr id="65" name=""/>
+          <p:cNvPr id="79" name=""/>
           <p:cNvCxnSpPr/>
           <p:nvPr/>
         </p:nvCxnSpPr>
@@ -12017,7 +13762,7 @@
       </p:cxnSp>
       <p:cxnSp>
         <p:nvCxnSpPr>
-          <p:cNvPr id="66" name=""/>
+          <p:cNvPr id="80" name=""/>
           <p:cNvCxnSpPr/>
           <p:nvPr/>
         </p:nvCxnSpPr>
@@ -12039,7 +13784,7 @@
       </p:cxnSp>
       <p:cxnSp>
         <p:nvCxnSpPr>
-          <p:cNvPr id="67" name=""/>
+          <p:cNvPr id="81" name=""/>
           <p:cNvCxnSpPr/>
           <p:nvPr/>
         </p:nvCxnSpPr>
@@ -12061,7 +13806,7 @@
       </p:cxnSp>
       <p:cxnSp>
         <p:nvCxnSpPr>
-          <p:cNvPr id="68" name=""/>
+          <p:cNvPr id="82" name=""/>
           <p:cNvCxnSpPr/>
           <p:nvPr/>
         </p:nvCxnSpPr>
@@ -13140,7 +14885,7 @@
       </p:sp>
       <p:cxnSp>
         <p:nvCxnSpPr>
-          <p:cNvPr id="37" name=""/>
+          <p:cNvPr id="41" name=""/>
           <p:cNvCxnSpPr/>
           <p:nvPr/>
         </p:nvCxnSpPr>
@@ -14595,7 +16340,7 @@
       </p:sp>
       <p:cxnSp>
         <p:nvCxnSpPr>
-          <p:cNvPr id="42" name=""/>
+          <p:cNvPr id="46" name=""/>
           <p:cNvCxnSpPr/>
           <p:nvPr/>
         </p:nvCxnSpPr>
@@ -16161,7 +17906,7 @@
       </p:sp>
       <p:cxnSp>
         <p:nvCxnSpPr>
-          <p:cNvPr id="155" name=""/>
+          <p:cNvPr id="205" name=""/>
           <p:cNvCxnSpPr/>
           <p:nvPr/>
         </p:nvCxnSpPr>
@@ -16577,7 +18322,7 @@
       </p:sp>
       <p:cxnSp>
         <p:nvCxnSpPr>
-          <p:cNvPr id="162" name=""/>
+          <p:cNvPr id="212" name=""/>
           <p:cNvCxnSpPr/>
           <p:nvPr/>
         </p:nvCxnSpPr>
@@ -17052,7 +18797,7 @@
       </p:sp>
       <p:cxnSp>
         <p:nvCxnSpPr>
-          <p:cNvPr id="170" name=""/>
+          <p:cNvPr id="220" name=""/>
           <p:cNvCxnSpPr/>
           <p:nvPr/>
         </p:nvCxnSpPr>
@@ -17527,7 +19272,7 @@
       </p:sp>
       <p:cxnSp>
         <p:nvCxnSpPr>
-          <p:cNvPr id="178" name=""/>
+          <p:cNvPr id="228" name=""/>
           <p:cNvCxnSpPr/>
           <p:nvPr/>
         </p:nvCxnSpPr>

</xml_diff>

<commit_message>
Refine AI Engineering cycle-time target
</commit_message>
<xml_diff>
--- a/presentation/06_Training_Presentation.pptx
+++ b/presentation/06_Training_Presentation.pptx
@@ -2,23 +2,23 @@
 <file path=ppt/presentation.xml><?xml version="1.0" encoding="utf-8"?>
 <p:presentation xmlns:p="http://schemas.openxmlformats.org/presentationml/2006/main">
   <p:sldMasterIdLst>
-    <p:sldMasterId xmlns:r="http://schemas.openxmlformats.org/officeDocument/2006/relationships" id="2147483648" r:id="R6902ea8fb1424bcc"/>
+    <p:sldMasterId xmlns:r="http://schemas.openxmlformats.org/officeDocument/2006/relationships" id="2147483648" r:id="R71212c5e2b164067"/>
   </p:sldMasterIdLst>
   <p:notesMasterIdLst>
-    <p:notesMasterId xmlns:r="http://schemas.openxmlformats.org/officeDocument/2006/relationships" r:id="R5192e9d091c140a4"/>
+    <p:notesMasterId xmlns:r="http://schemas.openxmlformats.org/officeDocument/2006/relationships" r:id="R68e9a088c4564894"/>
   </p:notesMasterIdLst>
   <p:sldIdLst>
-    <p:sldId xmlns:r="http://schemas.openxmlformats.org/officeDocument/2006/relationships" id="256" r:id="R50a988b24d04466e"/>
-    <p:sldId xmlns:r="http://schemas.openxmlformats.org/officeDocument/2006/relationships" id="257" r:id="R9ba16b42ebf34437"/>
-    <p:sldId xmlns:r="http://schemas.openxmlformats.org/officeDocument/2006/relationships" id="258" r:id="R8639e1e630bc4f03"/>
-    <p:sldId xmlns:r="http://schemas.openxmlformats.org/officeDocument/2006/relationships" id="259" r:id="R311c6c901d38475a"/>
-    <p:sldId xmlns:r="http://schemas.openxmlformats.org/officeDocument/2006/relationships" id="260" r:id="R9f486f1a06104806"/>
-    <p:sldId xmlns:r="http://schemas.openxmlformats.org/officeDocument/2006/relationships" id="261" r:id="R09c52771eb894b36"/>
-    <p:sldId xmlns:r="http://schemas.openxmlformats.org/officeDocument/2006/relationships" id="262" r:id="Ra9c8c97b737940d7"/>
-    <p:sldId xmlns:r="http://schemas.openxmlformats.org/officeDocument/2006/relationships" id="263" r:id="Rf4510ca3911f4122"/>
-    <p:sldId xmlns:r="http://schemas.openxmlformats.org/officeDocument/2006/relationships" id="264" r:id="R60893d42da734280"/>
-    <p:sldId xmlns:r="http://schemas.openxmlformats.org/officeDocument/2006/relationships" id="265" r:id="Rb5e6e338a256444a"/>
-    <p:sldId xmlns:r="http://schemas.openxmlformats.org/officeDocument/2006/relationships" id="266" r:id="R2c39608964f04472"/>
+    <p:sldId xmlns:r="http://schemas.openxmlformats.org/officeDocument/2006/relationships" id="256" r:id="Rde74da350c4f475b"/>
+    <p:sldId xmlns:r="http://schemas.openxmlformats.org/officeDocument/2006/relationships" id="257" r:id="R65e5b84d592e42bc"/>
+    <p:sldId xmlns:r="http://schemas.openxmlformats.org/officeDocument/2006/relationships" id="258" r:id="Ra85624c4c65140af"/>
+    <p:sldId xmlns:r="http://schemas.openxmlformats.org/officeDocument/2006/relationships" id="259" r:id="R6a7ceeb54dbd46af"/>
+    <p:sldId xmlns:r="http://schemas.openxmlformats.org/officeDocument/2006/relationships" id="260" r:id="Rf46be67db53f41de"/>
+    <p:sldId xmlns:r="http://schemas.openxmlformats.org/officeDocument/2006/relationships" id="261" r:id="R87325f1b92224ce1"/>
+    <p:sldId xmlns:r="http://schemas.openxmlformats.org/officeDocument/2006/relationships" id="262" r:id="R2f9f72e9556f4363"/>
+    <p:sldId xmlns:r="http://schemas.openxmlformats.org/officeDocument/2006/relationships" id="263" r:id="Rb283f68e8cf5468b"/>
+    <p:sldId xmlns:r="http://schemas.openxmlformats.org/officeDocument/2006/relationships" id="264" r:id="Ra97536e19a7a4035"/>
+    <p:sldId xmlns:r="http://schemas.openxmlformats.org/officeDocument/2006/relationships" id="265" r:id="R99aeb4958a5f41ef"/>
+    <p:sldId xmlns:r="http://schemas.openxmlformats.org/officeDocument/2006/relationships" id="266" r:id="R82756a4a2569455a"/>
   </p:sldIdLst>
   <p:sldSz cx="12192000" cy="6858000"/>
   <p:notesSz cx="6858000" cy="9144000"/>
@@ -1271,7 +1271,7 @@
   </p:cSld>
   <p:clrMap bg1="lt1" tx1="dk1" bg2="lt2" tx2="dk2" accent1="accent1" accent2="accent2" accent3="accent3" accent4="accent4" accent5="accent5" accent6="accent6" hlink="hlink" folHlink="folHlink"/>
   <p:sldLayoutIdLst>
-    <p:sldLayoutId xmlns:r="http://schemas.openxmlformats.org/officeDocument/2006/relationships" id="2147483649" r:id="R05725fae5108411f"/>
+    <p:sldLayoutId xmlns:r="http://schemas.openxmlformats.org/officeDocument/2006/relationships" id="2147483649" r:id="Rc9333caf25bc4210"/>
   </p:sldLayoutIdLst>
   <p:txStyles>
     <p:titleStyle>
@@ -1798,311 +1798,6 @@
 </a:theme>
 </file>
 
-<file path=ppt/slides/charts/chart1.xml><?xml version="1.0" encoding="utf-8"?>
-<c:chartSpace xmlns:c="http://schemas.openxmlformats.org/drawingml/2006/chart">
-  <c:lang val="en-US"/>
-  <c:chart>
-    <c:plotArea>
-      <c:barChart>
-        <c:barDir val="bar"/>
-        <c:grouping val="stacked"/>
-        <c:varyColors val="0"/>
-        <c:ser>
-          <c:idx val="0"/>
-          <c:order val="0"/>
-          <c:tx>
-            <c:v>Research</c:v>
-          </c:tx>
-          <c:spPr>
-            <a:solidFill xmlns:a="http://schemas.openxmlformats.org/drawingml/2006/main">
-              <a:srgbClr val="163A53"/>
-            </a:solidFill>
-          </c:spPr>
-          <c:cat>
-            <c:strLit>
-              <c:ptCount val="2"/>
-              <c:pt idx="0">
-                <c:v> </c:v>
-              </c:pt>
-              <c:pt idx="1">
-                <c:v>  </c:v>
-              </c:pt>
-            </c:strLit>
-          </c:cat>
-          <c:val>
-            <c:numLit>
-              <c:formatCode>General</c:formatCode>
-              <c:ptCount val="2"/>
-              <c:pt idx="0">
-                <c:v>22</c:v>
-              </c:pt>
-              <c:pt idx="1">
-                <c:v>12</c:v>
-              </c:pt>
-            </c:numLit>
-          </c:val>
-        </c:ser>
-        <c:ser>
-          <c:idx val="1"/>
-          <c:order val="1"/>
-          <c:tx>
-            <c:v>Design</c:v>
-          </c:tx>
-          <c:spPr>
-            <a:solidFill xmlns:a="http://schemas.openxmlformats.org/drawingml/2006/main">
-              <a:srgbClr val="4D80B8"/>
-            </a:solidFill>
-          </c:spPr>
-          <c:cat>
-            <c:strLit>
-              <c:ptCount val="2"/>
-              <c:pt idx="0">
-                <c:v> </c:v>
-              </c:pt>
-              <c:pt idx="1">
-                <c:v>  </c:v>
-              </c:pt>
-            </c:strLit>
-          </c:cat>
-          <c:val>
-            <c:numLit>
-              <c:formatCode>General</c:formatCode>
-              <c:ptCount val="2"/>
-              <c:pt idx="0">
-                <c:v>24</c:v>
-              </c:pt>
-              <c:pt idx="1">
-                <c:v>10</c:v>
-              </c:pt>
-            </c:numLit>
-          </c:val>
-        </c:ser>
-        <c:ser>
-          <c:idx val="2"/>
-          <c:order val="2"/>
-          <c:tx>
-            <c:v>Plan</c:v>
-          </c:tx>
-          <c:spPr>
-            <a:solidFill xmlns:a="http://schemas.openxmlformats.org/drawingml/2006/main">
-              <a:srgbClr val="A7B4BE"/>
-            </a:solidFill>
-          </c:spPr>
-          <c:cat>
-            <c:strLit>
-              <c:ptCount val="2"/>
-              <c:pt idx="0">
-                <c:v> </c:v>
-              </c:pt>
-              <c:pt idx="1">
-                <c:v>  </c:v>
-              </c:pt>
-            </c:strLit>
-          </c:cat>
-          <c:val>
-            <c:numLit>
-              <c:formatCode>General</c:formatCode>
-              <c:ptCount val="2"/>
-              <c:pt idx="0">
-                <c:v>10</c:v>
-              </c:pt>
-              <c:pt idx="1">
-                <c:v>5</c:v>
-              </c:pt>
-            </c:numLit>
-          </c:val>
-        </c:ser>
-        <c:ser>
-          <c:idx val="3"/>
-          <c:order val="3"/>
-          <c:tx>
-            <c:v>Implement</c:v>
-          </c:tx>
-          <c:spPr>
-            <a:solidFill xmlns:a="http://schemas.openxmlformats.org/drawingml/2006/main">
-              <a:srgbClr val="5C6570"/>
-            </a:solidFill>
-          </c:spPr>
-          <c:cat>
-            <c:strLit>
-              <c:ptCount val="2"/>
-              <c:pt idx="0">
-                <c:v> </c:v>
-              </c:pt>
-              <c:pt idx="1">
-                <c:v>  </c:v>
-              </c:pt>
-            </c:strLit>
-          </c:cat>
-          <c:val>
-            <c:numLit>
-              <c:formatCode>General</c:formatCode>
-              <c:ptCount val="2"/>
-              <c:pt idx="0">
-                <c:v>8</c:v>
-              </c:pt>
-              <c:pt idx="1">
-                <c:v>55</c:v>
-              </c:pt>
-            </c:numLit>
-          </c:val>
-        </c:ser>
-        <c:ser>
-          <c:idx val="4"/>
-          <c:order val="4"/>
-          <c:tx>
-            <c:v>Validate</c:v>
-          </c:tx>
-          <c:spPr>
-            <a:solidFill xmlns:a="http://schemas.openxmlformats.org/drawingml/2006/main">
-              <a:srgbClr val="46B8DF"/>
-            </a:solidFill>
-          </c:spPr>
-          <c:cat>
-            <c:strLit>
-              <c:ptCount val="2"/>
-              <c:pt idx="0">
-                <c:v> </c:v>
-              </c:pt>
-              <c:pt idx="1">
-                <c:v>  </c:v>
-              </c:pt>
-            </c:strLit>
-          </c:cat>
-          <c:val>
-            <c:numLit>
-              <c:formatCode>General</c:formatCode>
-              <c:ptCount val="2"/>
-              <c:pt idx="0">
-                <c:v>36</c:v>
-              </c:pt>
-              <c:pt idx="1">
-                <c:v>18</c:v>
-              </c:pt>
-            </c:numLit>
-          </c:val>
-        </c:ser>
-        <c:gapWidth val="48"/>
-        <c:overlap val="100"/>
-        <c:axId val="48650112"/>
-        <c:axId val="48672768"/>
-      </c:barChart>
-      <c:catAx>
-        <c:axId val="48650112"/>
-        <c:scaling>
-          <c:orientation val="minMax"/>
-        </c:scaling>
-        <c:delete val="0"/>
-        <c:axPos val="l"/>
-        <c:numFmt formatCode="General"/>
-        <c:majorTickMark val="none"/>
-        <c:minorTickMark val="none"/>
-        <c:spPr>
-          <a:ln xmlns:a="http://schemas.openxmlformats.org/drawingml/2006/main" w="9525">
-            <a:solidFill>
-              <a:srgbClr val="D4D4D4"/>
-            </a:solidFill>
-            <a:prstDash val="solid"/>
-          </a:ln>
-        </c:spPr>
-        <c:txPr>
-          <a:bodyPr xmlns:a="http://schemas.openxmlformats.org/drawingml/2006/main" anchorCtr="1"/>
-          <a:lstStyle xmlns:a="http://schemas.openxmlformats.org/drawingml/2006/main"/>
-          <a:p xmlns:a="http://schemas.openxmlformats.org/drawingml/2006/main">
-            <a:pPr>
-              <a:defRPr>
-                <a:solidFill>
-                  <a:srgbClr val="666666"/>
-                </a:solidFill>
-              </a:defRPr>
-            </a:pPr>
-          </a:p>
-        </c:txPr>
-        <c:crossAx val="48672768"/>
-        <c:lblAlgn val="ctr"/>
-        <c:lblOffset val="100"/>
-        <c:noMultiLvlLbl val="0"/>
-      </c:catAx>
-      <c:valAx>
-        <c:axId val="48672768"/>
-        <c:scaling>
-          <c:orientation val="minMax"/>
-        </c:scaling>
-        <c:delete val="0"/>
-        <c:axPos val="b"/>
-        <c:numFmt formatCode="General"/>
-        <c:majorTickMark val="none"/>
-        <c:minorTickMark val="none"/>
-        <c:tickLblPos val="none"/>
-        <c:spPr>
-          <a:ln xmlns:a="http://schemas.openxmlformats.org/drawingml/2006/main" w="0">
-            <a:solidFill>
-              <a:srgbClr val="FFFFFF"/>
-            </a:solidFill>
-            <a:prstDash val="solid"/>
-          </a:ln>
-        </c:spPr>
-        <c:txPr>
-          <a:bodyPr xmlns:a="http://schemas.openxmlformats.org/drawingml/2006/main" anchorCtr="1"/>
-          <a:lstStyle xmlns:a="http://schemas.openxmlformats.org/drawingml/2006/main"/>
-          <a:p xmlns:a="http://schemas.openxmlformats.org/drawingml/2006/main">
-            <a:pPr>
-              <a:defRPr sz="100">
-                <a:solidFill>
-                  <a:srgbClr val="FFFFFF"/>
-                </a:solidFill>
-              </a:defRPr>
-            </a:pPr>
-          </a:p>
-        </c:txPr>
-        <c:crossAx val="48650112"/>
-        <c:crossBetween val="between"/>
-      </c:valAx>
-      <c:spPr>
-        <a:solidFill xmlns:a="http://schemas.openxmlformats.org/drawingml/2006/main">
-          <a:srgbClr val="FFFFFF"/>
-        </a:solidFill>
-        <a:ln xmlns:a="http://schemas.openxmlformats.org/drawingml/2006/main" w="0">
-          <a:solidFill>
-            <a:srgbClr val="FFFFFF"/>
-          </a:solidFill>
-          <a:prstDash val="solid"/>
-        </a:ln>
-      </c:spPr>
-    </c:plotArea>
-    <c:legend>
-      <c:legendPos val="t"/>
-      <c:overlay val="0"/>
-      <c:txPr>
-        <a:bodyPr xmlns:a="http://schemas.openxmlformats.org/drawingml/2006/main" anchorCtr="1"/>
-        <a:lstStyle xmlns:a="http://schemas.openxmlformats.org/drawingml/2006/main"/>
-        <a:p xmlns:a="http://schemas.openxmlformats.org/drawingml/2006/main">
-          <a:pPr>
-            <a:defRPr sz="1125">
-              <a:solidFill>
-                <a:srgbClr val="4F5B66"/>
-              </a:solidFill>
-            </a:defRPr>
-          </a:pPr>
-        </a:p>
-      </c:txPr>
-    </c:legend>
-    <c:plotVisOnly val="1"/>
-  </c:chart>
-  <c:spPr>
-    <a:solidFill xmlns:a="http://schemas.openxmlformats.org/drawingml/2006/main">
-      <a:srgbClr val="FFFFFF"/>
-    </a:solidFill>
-    <a:ln xmlns:a="http://schemas.openxmlformats.org/drawingml/2006/main" w="0">
-      <a:solidFill>
-        <a:srgbClr val="FFFFFF"/>
-      </a:solidFill>
-      <a:prstDash val="solid"/>
-    </a:ln>
-  </c:spPr>
-</c:chartSpace>
-</file>
-
 <file path=ppt/slides/slide1.xml><?xml version="1.0" encoding="utf-8"?>
 <p:sld xmlns:p="http://schemas.openxmlformats.org/presentationml/2006/main">
   <p:cSld>
@@ -2467,7 +2162,7 @@
                 <a:ea typeface="Noto Sans TC"/>
                 <a:cs typeface="Noto Sans TC"/>
               </a:rPr>
-              <a:t>v1.3 Baseline Candidate</a:t>
+              <a:t>v1.4 Baseline Candidate</a:t>
             </a:r>
           </a:p>
         </p:txBody>
@@ -2555,7 +2250,7 @@
                 <a:ea typeface="Noto Sans TC"/>
                 <a:cs typeface="Noto Sans TC"/>
               </a:rPr>
-              <a:t>把時間從 coding 移向 research、design 與 evidence</a:t>
+              <a:t>8 週 → 5–6 週：把時間從 coding 移向 design 與 evidence</a:t>
             </a:r>
           </a:p>
         </p:txBody>
@@ -2818,7 +2513,7 @@
                 <a:ea typeface="Noto Sans TC"/>
                 <a:cs typeface="Noto Sans TC"/>
               </a:rPr>
-              <a:t>↑ System-wide</a:t>
+              <a:t>0.5 → 1.0 wk</a:t>
             </a:r>
           </a:p>
         </p:txBody>
@@ -2877,7 +2572,7 @@
                 <a:ea typeface="Noto Sans TC"/>
                 <a:cs typeface="Noto Sans TC"/>
               </a:rPr>
-              <a:t>FR / NFR / trade-off</a:t>
+              <a:t>design time ×2</a:t>
             </a:r>
           </a:p>
           <a:p xmlns:a="http://schemas.openxmlformats.org/drawingml/2006/main">
@@ -2901,7 +2596,7 @@
                 <a:ea typeface="Noto Sans TC"/>
                 <a:cs typeface="Noto Sans TC"/>
               </a:rPr>
-              <a:t>failure modes made explicit</a:t>
+              <a:t>FR / NFR / failure modes</a:t>
             </a:r>
           </a:p>
         </p:txBody>
@@ -2922,8 +2617,8 @@
         </p:nvSpPr>
         <p:spPr>
           <a:xfrm xmlns:a="http://schemas.openxmlformats.org/drawingml/2006/main">
-            <a:off x="400050" y="1847850"/>
-            <a:ext cx="1952625" cy="209550"/>
+            <a:off x="400050" y="1809750"/>
+            <a:ext cx="2238375" cy="209550"/>
           </a:xfrm>
           <a:prstGeom xmlns:a="http://schemas.openxmlformats.org/drawingml/2006/main" prst="rect">
             <a:avLst/>
@@ -2952,7 +2647,7 @@
               </a:defRPr>
             </a:pPr>
             <a:r>
-              <a:rPr sz="1200" b="1">
+              <a:rPr sz="1150" b="1">
                 <a:solidFill>
                   <a:srgbClr val="163A53"/>
                 </a:solidFill>
@@ -2960,7 +2655,7 @@
                 <a:ea typeface="Noto Sans TC"/>
                 <a:cs typeface="Noto Sans TC"/>
               </a:rPr>
-              <a:t>AS-IS</a:t>
+              <a:t>AS-IS · 8 WEEKS</a:t>
             </a:r>
           </a:p>
         </p:txBody>
@@ -2981,8 +2676,8 @@
         </p:nvSpPr>
         <p:spPr>
           <a:xfrm xmlns:a="http://schemas.openxmlformats.org/drawingml/2006/main">
-            <a:off x="400050" y="2095500"/>
-            <a:ext cx="2095500" cy="685800"/>
+            <a:off x="400050" y="2057400"/>
+            <a:ext cx="2333625" cy="685800"/>
           </a:xfrm>
           <a:prstGeom xmlns:a="http://schemas.openxmlformats.org/drawingml/2006/main" prst="rect">
             <a:avLst/>
@@ -2995,7 +2690,7 @@
         </p:spPr>
         <p:txBody>
           <a:bodyPr xmlns:a="http://schemas.openxmlformats.org/drawingml/2006/main" wrap="square" lIns="0" tIns="0" rIns="0" bIns="0" anchor="t">
-            <a:normAutofit fontScale="93750"/>
+            <a:normAutofit fontScale="95937"/>
           </a:bodyPr>
           <a:lstStyle xmlns:a="http://schemas.openxmlformats.org/drawingml/2006/main"/>
           <a:p xmlns:a="http://schemas.openxmlformats.org/drawingml/2006/main">
@@ -3011,7 +2706,7 @@
               </a:defRPr>
             </a:pPr>
             <a:r>
-              <a:rPr sz="1600" b="1">
+              <a:rPr sz="1500" b="1">
                 <a:solidFill>
                   <a:srgbClr val="4F5B66"/>
                 </a:solidFill>
@@ -3019,6 +2714,30 @@
                 <a:ea typeface="Noto Sans TC"/>
                 <a:cs typeface="Noto Sans TC"/>
               </a:rPr>
+              <a:t>4 × 2-week sprints</a:t>
+            </a:r>
+          </a:p>
+          <a:p xmlns:a="http://schemas.openxmlformats.org/drawingml/2006/main">
+            <a:pPr algn="l">
+              <a:buNone/>
+              <a:defRPr sz="1125" b="1">
+                <a:solidFill>
+                  <a:srgbClr val="173B57"/>
+                </a:solidFill>
+                <a:latin typeface="Noto Sans TC"/>
+                <a:ea typeface="Noto Sans TC"/>
+                <a:cs typeface="Noto Sans TC"/>
+              </a:defRPr>
+            </a:pPr>
+            <a:r>
+              <a:rPr sz="1500" b="1">
+                <a:solidFill>
+                  <a:srgbClr val="4F5B66"/>
+                </a:solidFill>
+                <a:latin typeface="Noto Sans TC"/>
+                <a:ea typeface="Noto Sans TC"/>
+                <a:cs typeface="Noto Sans TC"/>
+              </a:rPr>
               <a:t>single-repo research</a:t>
             </a:r>
           </a:p>
@@ -3035,7 +2754,7 @@
               </a:defRPr>
             </a:pPr>
             <a:r>
-              <a:rPr sz="1600" b="1">
+              <a:rPr sz="1500" b="1">
                 <a:solidFill>
                   <a:srgbClr val="4F5B66"/>
                 </a:solidFill>
@@ -3043,31 +2762,7 @@
                 <a:ea typeface="Noto Sans TC"/>
                 <a:cs typeface="Noto Sans TC"/>
               </a:rPr>
-              <a:t>FR / NFR 不明確</a:t>
-            </a:r>
-          </a:p>
-          <a:p xmlns:a="http://schemas.openxmlformats.org/drawingml/2006/main">
-            <a:pPr algn="l">
-              <a:buNone/>
-              <a:defRPr sz="1125" b="1">
-                <a:solidFill>
-                  <a:srgbClr val="173B57"/>
-                </a:solidFill>
-                <a:latin typeface="Noto Sans TC"/>
-                <a:ea typeface="Noto Sans TC"/>
-                <a:cs typeface="Noto Sans TC"/>
-              </a:defRPr>
-            </a:pPr>
-            <a:r>
-              <a:rPr sz="1600" b="1">
-                <a:solidFill>
-                  <a:srgbClr val="4F5B66"/>
-                </a:solidFill>
-                <a:latin typeface="Noto Sans TC"/>
-                <a:ea typeface="Noto Sans TC"/>
-                <a:cs typeface="Noto Sans TC"/>
-              </a:rPr>
-              <a:t>thin tests</a:t>
+              <a:t>unclear FR/NFR · thin tests</a:t>
             </a:r>
           </a:p>
         </p:txBody>
@@ -3190,7 +2885,7 @@
                 <a:ea typeface="Noto Sans TC"/>
                 <a:cs typeface="Noto Sans TC"/>
               </a:rPr>
-              <a:t>IMPLEMENTATION EFFORT</a:t>
+              <a:t>IMPLEMENTATION TIME</a:t>
             </a:r>
           </a:p>
         </p:txBody>
@@ -3249,7 +2944,7 @@
                 <a:ea typeface="Noto Sans TC"/>
                 <a:cs typeface="Noto Sans TC"/>
               </a:rPr>
-              <a:t>↓ 80–90%</a:t>
+              <a:t>5.5 → 2.25 wk</a:t>
             </a:r>
           </a:p>
         </p:txBody>
@@ -3284,7 +2979,7 @@
         </p:spPr>
         <p:txBody>
           <a:bodyPr xmlns:a="http://schemas.openxmlformats.org/drawingml/2006/main" wrap="square" lIns="0" tIns="0" rIns="0" bIns="0" anchor="t">
-            <a:normAutofit fontScale="93457"/>
+            <a:normAutofit fontScale="100000"/>
           </a:bodyPr>
           <a:lstStyle xmlns:a="http://schemas.openxmlformats.org/drawingml/2006/main"/>
           <a:p xmlns:a="http://schemas.openxmlformats.org/drawingml/2006/main">
@@ -3308,7 +3003,7 @@
                 <a:ea typeface="Noto Sans TC"/>
                 <a:cs typeface="Noto Sans TC"/>
               </a:rPr>
-              <a:t>code time target：降至約 1/5–1/10</a:t>
+              <a:t>implementation time ↓59%</a:t>
             </a:r>
           </a:p>
           <a:p xmlns:a="http://schemas.openxmlformats.org/drawingml/2006/main">
@@ -3332,7 +3027,7 @@
                 <a:ea typeface="Noto Sans TC"/>
                 <a:cs typeface="Noto Sans TC"/>
               </a:rPr>
-              <a:t>of current implementation effort</a:t>
+              <a:t>less patch-driven delivery</a:t>
             </a:r>
           </a:p>
         </p:txBody>
@@ -3353,8 +3048,8 @@
         </p:nvSpPr>
         <p:spPr>
           <a:xfrm xmlns:a="http://schemas.openxmlformats.org/drawingml/2006/main">
-            <a:off x="400050" y="3076575"/>
-            <a:ext cx="2095500" cy="209550"/>
+            <a:off x="400050" y="3038475"/>
+            <a:ext cx="2333625" cy="209550"/>
           </a:xfrm>
           <a:prstGeom xmlns:a="http://schemas.openxmlformats.org/drawingml/2006/main" prst="rect">
             <a:avLst/>
@@ -3383,7 +3078,7 @@
               </a:defRPr>
             </a:pPr>
             <a:r>
-              <a:rPr sz="1200" b="1">
+              <a:rPr sz="1150" b="1">
                 <a:solidFill>
                   <a:srgbClr val="1D78C8"/>
                 </a:solidFill>
@@ -3391,7 +3086,7 @@
                 <a:ea typeface="Noto Sans TC"/>
                 <a:cs typeface="Noto Sans TC"/>
               </a:rPr>
-              <a:t>AI ENGINEERING</a:t>
+              <a:t>AI ENGINEERING · 5.5 WEEKS</a:t>
             </a:r>
           </a:p>
         </p:txBody>
@@ -3412,8 +3107,8 @@
         </p:nvSpPr>
         <p:spPr>
           <a:xfrm xmlns:a="http://schemas.openxmlformats.org/drawingml/2006/main">
-            <a:off x="400050" y="3324225"/>
-            <a:ext cx="2095500" cy="685800"/>
+            <a:off x="400050" y="3286125"/>
+            <a:ext cx="2333625" cy="685800"/>
           </a:xfrm>
           <a:prstGeom xmlns:a="http://schemas.openxmlformats.org/drawingml/2006/main" prst="rect">
             <a:avLst/>
@@ -3426,7 +3121,7 @@
         </p:spPr>
         <p:txBody>
           <a:bodyPr xmlns:a="http://schemas.openxmlformats.org/drawingml/2006/main" wrap="square" lIns="0" tIns="0" rIns="0" bIns="0" anchor="t">
-            <a:normAutofit fontScale="88619"/>
+            <a:normAutofit fontScale="85152"/>
           </a:bodyPr>
           <a:lstStyle xmlns:a="http://schemas.openxmlformats.org/drawingml/2006/main"/>
           <a:p xmlns:a="http://schemas.openxmlformats.org/drawingml/2006/main">
@@ -3442,7 +3137,7 @@
               </a:defRPr>
             </a:pPr>
             <a:r>
-              <a:rPr sz="1600" b="1">
+              <a:rPr sz="1500" b="1">
                 <a:solidFill>
                   <a:srgbClr val="4F5B66"/>
                 </a:solidFill>
@@ -3450,6 +3145,30 @@
                 <a:ea typeface="Noto Sans TC"/>
                 <a:cs typeface="Noto Sans TC"/>
               </a:rPr>
+              <a:t>≈ 3 × 2-week sprints</a:t>
+            </a:r>
+          </a:p>
+          <a:p xmlns:a="http://schemas.openxmlformats.org/drawingml/2006/main">
+            <a:pPr algn="l">
+              <a:buNone/>
+              <a:defRPr sz="1125" b="1">
+                <a:solidFill>
+                  <a:srgbClr val="173B57"/>
+                </a:solidFill>
+                <a:latin typeface="Noto Sans TC"/>
+                <a:ea typeface="Noto Sans TC"/>
+                <a:cs typeface="Noto Sans TC"/>
+              </a:defRPr>
+            </a:pPr>
+            <a:r>
+              <a:rPr sz="1500" b="1">
+                <a:solidFill>
+                  <a:srgbClr val="4F5B66"/>
+                </a:solidFill>
+                <a:latin typeface="Noto Sans TC"/>
+                <a:ea typeface="Noto Sans TC"/>
+                <a:cs typeface="Noto Sans TC"/>
+              </a:rPr>
               <a:t>system-wide research</a:t>
             </a:r>
           </a:p>
@@ -3466,7 +3185,7 @@
               </a:defRPr>
             </a:pPr>
             <a:r>
-              <a:rPr sz="1600" b="1">
+              <a:rPr sz="1500" b="1">
                 <a:solidFill>
                   <a:srgbClr val="4F5B66"/>
                 </a:solidFill>
@@ -3474,31 +3193,7 @@
                 <a:ea typeface="Noto Sans TC"/>
                 <a:cs typeface="Noto Sans TC"/>
               </a:rPr>
-              <a:t>explicit FR / NFR</a:t>
-            </a:r>
-          </a:p>
-          <a:p xmlns:a="http://schemas.openxmlformats.org/drawingml/2006/main">
-            <a:pPr algn="l">
-              <a:buNone/>
-              <a:defRPr sz="1125" b="1">
-                <a:solidFill>
-                  <a:srgbClr val="173B57"/>
-                </a:solidFill>
-                <a:latin typeface="Noto Sans TC"/>
-                <a:ea typeface="Noto Sans TC"/>
-                <a:cs typeface="Noto Sans TC"/>
-              </a:defRPr>
-            </a:pPr>
-            <a:r>
-              <a:rPr sz="1600" b="1">
-                <a:solidFill>
-                  <a:srgbClr val="4F5B66"/>
-                </a:solidFill>
-                <a:latin typeface="Noto Sans TC"/>
-                <a:ea typeface="Noto Sans TC"/>
-                <a:cs typeface="Noto Sans TC"/>
-              </a:rPr>
-              <a:t>TDD + broader evidence</a:t>
+              <a:t>explicit design · TDD evidence</a:t>
             </a:r>
           </a:p>
         </p:txBody>
@@ -3680,7 +3375,7 @@
                 <a:ea typeface="Noto Sans TC"/>
                 <a:cs typeface="Noto Sans TC"/>
               </a:rPr>
-              <a:t>↓ 明顯下降</a:t>
+              <a:t>↓ Fewer loops</a:t>
             </a:r>
           </a:p>
         </p:txBody>
@@ -3739,31 +3434,31 @@
                 <a:ea typeface="Noto Sans TC"/>
                 <a:cs typeface="Noto Sans TC"/>
               </a:rPr>
+              <a:t>validation 1.0 → 1.25 wk</a:t>
+            </a:r>
+          </a:p>
+          <a:p xmlns:a="http://schemas.openxmlformats.org/drawingml/2006/main">
+            <a:pPr algn="l">
+              <a:buNone/>
+              <a:defRPr sz="1275" b="0">
+                <a:solidFill>
+                  <a:srgbClr val="111111"/>
+                </a:solidFill>
+                <a:latin typeface="Noto Sans TC"/>
+                <a:ea typeface="Noto Sans TC"/>
+                <a:cs typeface="Noto Sans TC"/>
+              </a:defRPr>
+            </a:pPr>
+            <a:r>
+              <a:rPr sz="1600" b="0">
+                <a:solidFill>
+                  <a:srgbClr val="4F5B66"/>
+                </a:solidFill>
+                <a:latin typeface="Noto Sans TC"/>
+                <a:ea typeface="Noto Sans TC"/>
+                <a:cs typeface="Noto Sans TC"/>
+              </a:rPr>
               <a:t>broader TDD coverage</a:t>
-            </a:r>
-          </a:p>
-          <a:p xmlns:a="http://schemas.openxmlformats.org/drawingml/2006/main">
-            <a:pPr algn="l">
-              <a:buNone/>
-              <a:defRPr sz="1275" b="0">
-                <a:solidFill>
-                  <a:srgbClr val="111111"/>
-                </a:solidFill>
-                <a:latin typeface="Noto Sans TC"/>
-                <a:ea typeface="Noto Sans TC"/>
-                <a:cs typeface="Noto Sans TC"/>
-              </a:defRPr>
-            </a:pPr>
-            <a:r>
-              <a:rPr sz="1600" b="0">
-                <a:solidFill>
-                  <a:srgbClr val="4F5B66"/>
-                </a:solidFill>
-                <a:latin typeface="Noto Sans TC"/>
-                <a:ea typeface="Noto Sans TC"/>
-                <a:cs typeface="Noto Sans TC"/>
-              </a:rPr>
-              <a:t>stronger fresh evidence</a:t>
             </a:r>
           </a:p>
         </p:txBody>
@@ -3824,27 +3519,33 @@
                 <a:ea typeface="Noto Sans TC"/>
                 <a:cs typeface="Noto Sans TC"/>
               </a:rPr>
-              <a:t>Target illustration：兩條 bar 皆以相同 total effort = 100；pilot 後以實際 baseline 校準。</a:t>
-            </a:r>
-          </a:p>
-        </p:txBody>
-      </p:sp>
-      <p:graphicFrame>
-        <p:nvGraphicFramePr>
-          <p:cNvPr id="205" name="Chart"/>
-          <p:cNvGraphicFramePr/>
-          <p:nvPr/>
-        </p:nvGraphicFramePr>
-        <p:xfrm>
-          <a:off xmlns:a="http://schemas.openxmlformats.org/drawingml/2006/main" x="2609850" y="1476375"/>
-          <a:ext xmlns:a="http://schemas.openxmlformats.org/drawingml/2006/main" cx="8991600" cy="2809875"/>
-        </p:xfrm>
-        <a:graphic xmlns:a="http://schemas.openxmlformats.org/drawingml/2006/main">
-          <a:graphicData uri="http://schemas.openxmlformats.org/drawingml/2006/chart">
-            <c:chart xmlns:r="http://schemas.openxmlformats.org/officeDocument/2006/relationships" xmlns:c="http://schemas.openxmlformats.org/drawingml/2006/chart" r:id="R76d7aaea86d94263"/>
-          </a:graphicData>
-        </a:graphic>
-      </p:graphicFrame>
+              <a:t>Illustrative calendar allocation：2-week sprint；stages may overlap；pilot 後以 actual baseline 校準。</a:t>
+            </a:r>
+          </a:p>
+        </p:txBody>
+      </p:sp>
+      <p:pic>
+        <p:nvPicPr>
+          <p:cNvPr id="205" name=""/>
+          <p:cNvPicPr>
+            <a:picLocks xmlns:a="http://schemas.openxmlformats.org/drawingml/2006/main" noChangeAspect="1"/>
+          </p:cNvPicPr>
+          <p:nvPr/>
+        </p:nvPicPr>
+        <p:blipFill>
+          <a:blip xmlns:r="http://schemas.openxmlformats.org/officeDocument/2006/relationships" xmlns:a="http://schemas.openxmlformats.org/drawingml/2006/main" r:embed="Reaf4ab1e15944885"/>
+          <a:stretch xmlns:a="http://schemas.openxmlformats.org/drawingml/2006/main"/>
+        </p:blipFill>
+        <p:spPr>
+          <a:xfrm xmlns:a="http://schemas.openxmlformats.org/drawingml/2006/main">
+            <a:off x="2858558" y="1476375"/>
+            <a:ext cx="8741833" cy="2809875"/>
+          </a:xfrm>
+          <a:prstGeom xmlns:a="http://schemas.openxmlformats.org/drawingml/2006/main" prst="rect">
+            <a:avLst/>
+          </a:prstGeom>
+        </p:spPr>
+      </p:pic>
     </p:spTree>
     <p:extLst>
       <p:ext uri="{BB962C8B-B14F-4D97-AF65-F5344CB8AC3E}">

</xml_diff>

<commit_message>
Finalize six-week delivery target
</commit_message>
<xml_diff>
--- a/presentation/06_Training_Presentation.pptx
+++ b/presentation/06_Training_Presentation.pptx
@@ -2,23 +2,23 @@
 <file path=ppt/presentation.xml><?xml version="1.0" encoding="utf-8"?>
 <p:presentation xmlns:p="http://schemas.openxmlformats.org/presentationml/2006/main">
   <p:sldMasterIdLst>
-    <p:sldMasterId xmlns:r="http://schemas.openxmlformats.org/officeDocument/2006/relationships" id="2147483648" r:id="R71212c5e2b164067"/>
+    <p:sldMasterId xmlns:r="http://schemas.openxmlformats.org/officeDocument/2006/relationships" id="2147483648" r:id="Rbf9234ed5ed94db1"/>
   </p:sldMasterIdLst>
   <p:notesMasterIdLst>
-    <p:notesMasterId xmlns:r="http://schemas.openxmlformats.org/officeDocument/2006/relationships" r:id="R68e9a088c4564894"/>
+    <p:notesMasterId xmlns:r="http://schemas.openxmlformats.org/officeDocument/2006/relationships" r:id="Re8a5a80685d14294"/>
   </p:notesMasterIdLst>
   <p:sldIdLst>
-    <p:sldId xmlns:r="http://schemas.openxmlformats.org/officeDocument/2006/relationships" id="256" r:id="Rde74da350c4f475b"/>
-    <p:sldId xmlns:r="http://schemas.openxmlformats.org/officeDocument/2006/relationships" id="257" r:id="R65e5b84d592e42bc"/>
-    <p:sldId xmlns:r="http://schemas.openxmlformats.org/officeDocument/2006/relationships" id="258" r:id="Ra85624c4c65140af"/>
-    <p:sldId xmlns:r="http://schemas.openxmlformats.org/officeDocument/2006/relationships" id="259" r:id="R6a7ceeb54dbd46af"/>
-    <p:sldId xmlns:r="http://schemas.openxmlformats.org/officeDocument/2006/relationships" id="260" r:id="Rf46be67db53f41de"/>
-    <p:sldId xmlns:r="http://schemas.openxmlformats.org/officeDocument/2006/relationships" id="261" r:id="R87325f1b92224ce1"/>
-    <p:sldId xmlns:r="http://schemas.openxmlformats.org/officeDocument/2006/relationships" id="262" r:id="R2f9f72e9556f4363"/>
-    <p:sldId xmlns:r="http://schemas.openxmlformats.org/officeDocument/2006/relationships" id="263" r:id="Rb283f68e8cf5468b"/>
-    <p:sldId xmlns:r="http://schemas.openxmlformats.org/officeDocument/2006/relationships" id="264" r:id="Ra97536e19a7a4035"/>
-    <p:sldId xmlns:r="http://schemas.openxmlformats.org/officeDocument/2006/relationships" id="265" r:id="R99aeb4958a5f41ef"/>
-    <p:sldId xmlns:r="http://schemas.openxmlformats.org/officeDocument/2006/relationships" id="266" r:id="R82756a4a2569455a"/>
+    <p:sldId xmlns:r="http://schemas.openxmlformats.org/officeDocument/2006/relationships" id="256" r:id="Ree7f76fc217d4a72"/>
+    <p:sldId xmlns:r="http://schemas.openxmlformats.org/officeDocument/2006/relationships" id="257" r:id="R525e63bd12134ba8"/>
+    <p:sldId xmlns:r="http://schemas.openxmlformats.org/officeDocument/2006/relationships" id="258" r:id="R091a35d5fce64b28"/>
+    <p:sldId xmlns:r="http://schemas.openxmlformats.org/officeDocument/2006/relationships" id="259" r:id="R27317aca0b1e496c"/>
+    <p:sldId xmlns:r="http://schemas.openxmlformats.org/officeDocument/2006/relationships" id="260" r:id="Reeab47bbe17d4191"/>
+    <p:sldId xmlns:r="http://schemas.openxmlformats.org/officeDocument/2006/relationships" id="261" r:id="Re44a9a05fe2b4c86"/>
+    <p:sldId xmlns:r="http://schemas.openxmlformats.org/officeDocument/2006/relationships" id="262" r:id="R8b133f397185420a"/>
+    <p:sldId xmlns:r="http://schemas.openxmlformats.org/officeDocument/2006/relationships" id="263" r:id="R2908358a5c5c4171"/>
+    <p:sldId xmlns:r="http://schemas.openxmlformats.org/officeDocument/2006/relationships" id="264" r:id="R13bb4ac9bbd84611"/>
+    <p:sldId xmlns:r="http://schemas.openxmlformats.org/officeDocument/2006/relationships" id="265" r:id="R669390c6d47a4c98"/>
+    <p:sldId xmlns:r="http://schemas.openxmlformats.org/officeDocument/2006/relationships" id="266" r:id="R4c0246dab10f40a3"/>
   </p:sldIdLst>
   <p:sldSz cx="12192000" cy="6858000"/>
   <p:notesSz cx="6858000" cy="9144000"/>
@@ -1271,7 +1271,7 @@
   </p:cSld>
   <p:clrMap bg1="lt1" tx1="dk1" bg2="lt2" tx2="dk2" accent1="accent1" accent2="accent2" accent3="accent3" accent4="accent4" accent5="accent5" accent6="accent6" hlink="hlink" folHlink="folHlink"/>
   <p:sldLayoutIdLst>
-    <p:sldLayoutId xmlns:r="http://schemas.openxmlformats.org/officeDocument/2006/relationships" id="2147483649" r:id="Rc9333caf25bc4210"/>
+    <p:sldLayoutId xmlns:r="http://schemas.openxmlformats.org/officeDocument/2006/relationships" id="2147483649" r:id="R0ae94ad148404318"/>
   </p:sldLayoutIdLst>
   <p:txStyles>
     <p:titleStyle>
@@ -2162,7 +2162,7 @@
                 <a:ea typeface="Noto Sans TC"/>
                 <a:cs typeface="Noto Sans TC"/>
               </a:rPr>
-              <a:t>v1.4 Baseline Candidate</a:t>
+              <a:t>v1.5 Baseline Candidate</a:t>
             </a:r>
           </a:p>
         </p:txBody>
@@ -2250,7 +2250,7 @@
                 <a:ea typeface="Noto Sans TC"/>
                 <a:cs typeface="Noto Sans TC"/>
               </a:rPr>
-              <a:t>8 週 → 5–6 週：把時間從 coding 移向 design 與 evidence</a:t>
+              <a:t>8 週 → 6 週：把時間從 coding 移向 design 與 evidence</a:t>
             </a:r>
           </a:p>
         </p:txBody>
@@ -2944,7 +2944,7 @@
                 <a:ea typeface="Noto Sans TC"/>
                 <a:cs typeface="Noto Sans TC"/>
               </a:rPr>
-              <a:t>5.5 → 2.25 wk</a:t>
+              <a:t>5.5 → 2.0 wk</a:t>
             </a:r>
           </a:p>
         </p:txBody>
@@ -3003,7 +3003,7 @@
                 <a:ea typeface="Noto Sans TC"/>
                 <a:cs typeface="Noto Sans TC"/>
               </a:rPr>
-              <a:t>implementation time ↓59%</a:t>
+              <a:t>implementation time ↓64%</a:t>
             </a:r>
           </a:p>
           <a:p xmlns:a="http://schemas.openxmlformats.org/drawingml/2006/main">
@@ -3086,7 +3086,7 @@
                 <a:ea typeface="Noto Sans TC"/>
                 <a:cs typeface="Noto Sans TC"/>
               </a:rPr>
-              <a:t>AI ENGINEERING · 5.5 WEEKS</a:t>
+              <a:t>AI ENGINEERING · 6 WEEKS</a:t>
             </a:r>
           </a:p>
         </p:txBody>
@@ -3434,7 +3434,7 @@
                 <a:ea typeface="Noto Sans TC"/>
                 <a:cs typeface="Noto Sans TC"/>
               </a:rPr>
-              <a:t>validation 1.0 → 1.25 wk</a:t>
+              <a:t>validation 1.0 → 2.0 wk</a:t>
             </a:r>
           </a:p>
           <a:p xmlns:a="http://schemas.openxmlformats.org/drawingml/2006/main">
@@ -3458,7 +3458,7 @@
                 <a:ea typeface="Noto Sans TC"/>
                 <a:cs typeface="Noto Sans TC"/>
               </a:rPr>
-              <a:t>broader TDD coverage</a:t>
+              <a:t>TDD · staging · readiness</a:t>
             </a:r>
           </a:p>
         </p:txBody>
@@ -3533,7 +3533,7 @@
           <p:nvPr/>
         </p:nvPicPr>
         <p:blipFill>
-          <a:blip xmlns:r="http://schemas.openxmlformats.org/officeDocument/2006/relationships" xmlns:a="http://schemas.openxmlformats.org/drawingml/2006/main" r:embed="Reaf4ab1e15944885"/>
+          <a:blip xmlns:r="http://schemas.openxmlformats.org/officeDocument/2006/relationships" xmlns:a="http://schemas.openxmlformats.org/drawingml/2006/main" r:embed="R41d313c73c7f4310"/>
           <a:stretch xmlns:a="http://schemas.openxmlformats.org/drawingml/2006/main"/>
         </p:blipFill>
         <p:spPr>

</xml_diff>